<commit_message>
Add effort-saved slide to the jury pitch PowerPoint
Co-Authored-By: Claude Opus 5.5 <noreply@anthropic.com>
Claude-Session: https://claude.ai/code/session_01HdxEbeqqWM97gKbcNqpjAq
</commit_message>
<xml_diff>
--- a/erm-migration/docs/ERM-Migration-Jury-Pitch.pptx
+++ b/erm-migration/docs/ERM-Migration-Jury-Pitch.pptx
@@ -11,9 +11,10 @@
     <p:sldId id="259" r:id="rId5"/>
     <p:sldId id="260" r:id="rId6"/>
     <p:sldId id="261" r:id="rId7"/>
+    <p:sldId id="262" r:id="rId8"/>
   </p:sldIdLst>
   <p:notesMasterIdLst>
-    <p:notesMasterId r:id="rId8"/>
+    <p:notesMasterId r:id="rId9"/>
   </p:notesMasterIdLst>
   <p:sldSz cx="12192000" cy="6858000"/>
   <p:notesSz cx="6858000" cy="12192000"/>
@@ -112,26 +113,27 @@
   <p:extLst>
     <p:ext uri="{521415D9-36F7-43E2-AB2F-B90AF26B5E84}">
       <p14:sectionLst xmlns:p14="http://schemas.microsoft.com/office/powerpoint/2010/main">
-        <p14:section name="Pitch" id="{86083955-bdef-98c2-40e8-3a933b03741f}">
+        <p14:section name="Pitch" id="{c5fdbef1-2242-f2f2-7c49-bd7fd0e4346e}">
           <p14:sldIdLst>
             <p14:sldId id="256"/>
           </p14:sldIdLst>
         </p14:section>
-        <p14:section name="Problem and method" id="{ddd2c1b2-85ac-b277-c521-2b01fd1dc946}">
+        <p14:section name="Problem and method" id="{45e1f99c-1e2b-c64c-9a7a-4dfa2194a18e}">
           <p14:sldIdLst>
             <p14:sldId id="257"/>
             <p14:sldId id="258"/>
           </p14:sldIdLst>
         </p14:section>
-        <p14:section name="Impact" id="{1047cabb-0ab7-f3e9-a1fb-e7ecdc95b7bb}">
+        <p14:section name="Impact" id="{243a8934-3c6e-b6b2-b366-ecd90d319511}">
           <p14:sldIdLst>
             <p14:sldId id="259"/>
             <p14:sldId id="260"/>
+            <p14:sldId id="261"/>
           </p14:sldIdLst>
         </p14:section>
-        <p14:section name="Reuse" id="{e95f85d1-b111-5f68-21bc-546e72b5e859}">
+        <p14:section name="Reuse" id="{e594c4fd-50d8-de63-a813-b28990026acf}">
           <p14:sldIdLst>
-            <p14:sldId id="261"/>
+            <p14:sldId id="262"/>
           </p14:sldIdLst>
         </p14:section>
       </p14:sectionLst>
@@ -890,7 +892,7 @@
           <a:p>
             <a:r>
               <a:rPr lang="en-US" dirty="0"/>
-              <a:t>Four results. One: every one of the 105 features is tracked in the comparison document. Two: real gaps were fixed, for example how board members get access to risks when a dashboard is created or edited; that fix is deployed. Three: the React app does more than the old one; show the new features here. Four: the app now has architecture and lifecycle diagrams, for dashboards and for risks. Switch to the live app for the demo here if time allows.</a:t>
+              <a:t>Fill in the numbers before presenting. Give the estimate the migration would have needed without AI, and say where it came from (for example the original PI planning). Then the actual effort: one PI, with the number of sprints and people. The percentage saved is (estimate minus actual) divided by estimate. Then say where the time went: discovery was the biggest saving, because the AI catalogued 105 features straight from the Slate exports with no documentation to read; gap analysis, because every feature was checked against the packed React code; and documentation, because the diagrams were produced alongside the work instead of afterwards.</a:t>
             </a:r>
             <a:endParaRPr lang="en-US" dirty="0"/>
           </a:p>
@@ -978,7 +980,7 @@
           <a:p>
             <a:r>
               <a:rPr lang="en-US" dirty="0"/>
-              <a:t>Close on reuse. This was a team effort across business, data and security, backend and frontend; name the teams. The method needs only the legacy export, the new codebase and an AI model, so it carries over to other Slate apps and to other legacy tools. The pieces are ready: pack-project.ts, the comparison document layout and the diagram formats. End with the five-word playbook and invite questions.</a:t>
+              <a:t>Four results. One: every one of the 105 features is tracked in the comparison document. Two: real gaps were fixed, for example how board members get access to risks when a dashboard is created or edited; that fix is deployed. Three: the React app does more than the old one; show the new features here. Four: the app now has architecture and lifecycle diagrams, for dashboards and for risks. Switch to the live app for the demo here if time allows.</a:t>
             </a:r>
             <a:endParaRPr lang="en-US" dirty="0"/>
           </a:p>
@@ -1002,6 +1004,94 @@
             <a:fld id="{F7021451-1387-4CA6-816F-3879F97B5CBC}" type="slidenum">
               <a:rPr lang="en-US"/>
               <a:t>6</a:t>
+            </a:fld>
+            <a:endParaRPr lang="en-US"/>
+          </a:p>
+        </p:txBody>
+      </p:sp>
+    </p:spTree>
+    <p:extLst>
+      <p:ext uri="{BB962C8B-B14F-4D97-AF65-F5344CB8AC3E}">
+        <p14:creationId xmlns:p14="http://schemas.microsoft.com/office/powerpoint/2010/main" val="1024086991"/>
+      </p:ext>
+    </p:extLst>
+  </p:cSld>
+  <p:clrMapOvr>
+    <a:masterClrMapping/>
+  </p:clrMapOvr>
+</p:notes>
+</file>
+
+<file path=ppt/notesSlides/notesSlide7.xml><?xml version="1.0" encoding="utf-8"?>
+<p:notes xmlns:a="http://schemas.openxmlformats.org/drawingml/2006/main" xmlns:r="http://schemas.openxmlformats.org/officeDocument/2006/relationships" xmlns:p="http://schemas.openxmlformats.org/presentationml/2006/main">
+  <p:cSld>
+    <p:spTree>
+      <p:nvGrpSpPr>
+        <p:cNvPr id="1" name=""/>
+        <p:cNvGrpSpPr/>
+        <p:nvPr/>
+      </p:nvGrpSpPr>
+      <p:grpSpPr>
+        <a:xfrm>
+          <a:off x="0" y="0"/>
+          <a:ext cx="0" cy="0"/>
+          <a:chOff x="0" y="0"/>
+          <a:chExt cx="0" cy="0"/>
+        </a:xfrm>
+      </p:grpSpPr>
+      <p:sp>
+        <p:nvSpPr>
+          <p:cNvPr id="2" name="Slide Image Placeholder 1"/>
+          <p:cNvSpPr>
+            <a:spLocks noGrp="1" noRot="1" noChangeAspect="1"/>
+          </p:cNvSpPr>
+          <p:nvPr>
+            <p:ph type="sldImg"/>
+          </p:nvPr>
+        </p:nvSpPr>
+        <p:spPr/>
+      </p:sp>
+      <p:sp>
+        <p:nvSpPr>
+          <p:cNvPr id="3" name="Notes Placeholder 2"/>
+          <p:cNvSpPr>
+            <a:spLocks noGrp="1"/>
+          </p:cNvSpPr>
+          <p:nvPr>
+            <p:ph type="body" idx="1"/>
+          </p:nvPr>
+        </p:nvSpPr>
+        <p:spPr/>
+        <p:txBody>
+          <a:bodyPr/>
+          <a:lstStyle/>
+          <a:p>
+            <a:r>
+              <a:rPr lang="en-US" dirty="0"/>
+              <a:t>Close on reuse. This was a team effort across business, data and security, backend and frontend; name the teams. The method needs only the legacy export, the new codebase and an AI model, so it carries over to other Slate apps and to other legacy tools. The pieces are ready: pack-project.ts, the comparison document layout and the diagram formats. End with the five-word playbook and invite questions.</a:t>
+            </a:r>
+            <a:endParaRPr lang="en-US" dirty="0"/>
+          </a:p>
+        </p:txBody>
+      </p:sp>
+      <p:sp>
+        <p:nvSpPr>
+          <p:cNvPr id="4" name="Slide Number Placeholder 3"/>
+          <p:cNvSpPr>
+            <a:spLocks noGrp="1"/>
+          </p:cNvSpPr>
+          <p:nvPr>
+            <p:ph type="sldNum" sz="quarter" idx="10"/>
+          </p:nvPr>
+        </p:nvSpPr>
+        <p:spPr/>
+        <p:txBody>
+          <a:bodyPr/>
+          <a:lstStyle/>
+          <a:p>
+            <a:fld id="{F7021451-1387-4CA6-816F-3879F97B5CBC}" type="slidenum">
+              <a:rPr lang="en-US"/>
+              <a:t>7</a:t>
             </a:fld>
             <a:endParaRPr lang="en-US"/>
           </a:p>
@@ -3207,7 +3297,7 @@
                   <a:schemeClr val="tx1"/>
                 </a:solidFill>
               </a:rPr>
-              <a:t>What we delivered in one SAFe PI</a:t>
+              <a:t>Effort saved: [__] sprints in one PI</a:t>
             </a:r>
             <a:endParaRPr lang="en-US" sz="3600" dirty="0"/>
           </a:p>
@@ -3215,18 +3305,18 @@
       </p:sp>
       <p:sp>
         <p:nvSpPr>
-          <p:cNvPr id="3" name="result-0-card"/>
+          <p:cNvPr id="3" name="effort-0-card"/>
           <p:cNvSpPr/>
           <p:nvPr/>
         </p:nvSpPr>
         <p:spPr>
           <a:xfrm>
             <a:off x="548640" y="1600200"/>
-            <a:ext cx="5410048" cy="2057400"/>
+            <a:ext cx="3515258" cy="2286000"/>
           </a:xfrm>
           <a:prstGeom prst="roundRect">
             <a:avLst>
-              <a:gd name="adj" fmla="val 5333"/>
+              <a:gd name="adj" fmla="val 4800"/>
             </a:avLst>
           </a:prstGeom>
           <a:solidFill>
@@ -3237,90 +3327,126 @@
       </p:sp>
       <p:sp>
         <p:nvSpPr>
-          <p:cNvPr id="4" name="result-0-title"/>
-          <p:cNvSpPr txBox="1"/>
-          <p:nvPr/>
-        </p:nvSpPr>
-        <p:spPr>
-          <a:xfrm>
-            <a:off x="868680" y="1920240"/>
-            <a:ext cx="4769968" cy="685800"/>
-          </a:xfrm>
-          <a:prstGeom prst="rect">
-            <a:avLst/>
-          </a:prstGeom>
-          <a:noFill/>
-          <a:ln/>
-        </p:spPr>
-        <p:txBody>
-          <a:bodyPr wrap="square" lIns="0" tIns="0" rIns="0" bIns="0" rtlCol="0" anchor="t"/>
-          <a:lstStyle/>
-          <a:p>
-            <a:pPr indent="0" marL="0">
-              <a:buNone/>
-            </a:pPr>
-            <a:r>
-              <a:rPr lang="en-US" sz="3200" b="1" dirty="0">
-                <a:solidFill>
-                  <a:schemeClr val="accent3"/>
-                </a:solidFill>
-              </a:rPr>
-              <a:t>105 features</a:t>
-            </a:r>
-            <a:endParaRPr lang="en-US" sz="3200" dirty="0"/>
-          </a:p>
-        </p:txBody>
-      </p:sp>
-      <p:sp>
-        <p:nvSpPr>
-          <p:cNvPr id="5" name="result-0-body"/>
-          <p:cNvSpPr txBox="1"/>
-          <p:nvPr/>
-        </p:nvSpPr>
-        <p:spPr>
-          <a:xfrm>
-            <a:off x="868680" y="2651760"/>
-            <a:ext cx="4769968" cy="731520"/>
-          </a:xfrm>
-          <a:prstGeom prst="rect">
-            <a:avLst/>
-          </a:prstGeom>
-          <a:noFill/>
-          <a:ln/>
-        </p:spPr>
-        <p:txBody>
-          <a:bodyPr wrap="square" lIns="0" tIns="0" rIns="0" bIns="0" rtlCol="0" anchor="t"/>
-          <a:lstStyle/>
-          <a:p>
-            <a:pPr indent="0" marL="0">
-              <a:buNone/>
-            </a:pPr>
-            <a:r>
-              <a:rPr lang="en-US" sz="1600" dirty="0">
+          <p:cNvPr id="4" name="effort-0-value"/>
+          <p:cNvSpPr txBox="1"/>
+          <p:nvPr/>
+        </p:nvSpPr>
+        <p:spPr>
+          <a:xfrm>
+            <a:off x="868680" y="1874520"/>
+            <a:ext cx="2875178" cy="868680"/>
+          </a:xfrm>
+          <a:prstGeom prst="rect">
+            <a:avLst/>
+          </a:prstGeom>
+          <a:noFill/>
+          <a:ln/>
+        </p:spPr>
+        <p:txBody>
+          <a:bodyPr wrap="square" lIns="0" tIns="0" rIns="0" bIns="0" rtlCol="0" anchor="t"/>
+          <a:lstStyle/>
+          <a:p>
+            <a:pPr indent="0" marL="0">
+              <a:buNone/>
+            </a:pPr>
+            <a:r>
+              <a:rPr lang="en-US" sz="4800" b="1" dirty="0">
+                <a:solidFill>
+                  <a:schemeClr val="tx1"/>
+                </a:solidFill>
+              </a:rPr>
+              <a:t>[__]</a:t>
+            </a:r>
+            <a:endParaRPr lang="en-US" sz="4800" dirty="0"/>
+          </a:p>
+        </p:txBody>
+      </p:sp>
+      <p:sp>
+        <p:nvSpPr>
+          <p:cNvPr id="5" name="effort-0-label"/>
+          <p:cNvSpPr txBox="1"/>
+          <p:nvPr/>
+        </p:nvSpPr>
+        <p:spPr>
+          <a:xfrm>
+            <a:off x="868680" y="2788920"/>
+            <a:ext cx="2875178" cy="411480"/>
+          </a:xfrm>
+          <a:prstGeom prst="rect">
+            <a:avLst/>
+          </a:prstGeom>
+          <a:noFill/>
+          <a:ln/>
+        </p:spPr>
+        <p:txBody>
+          <a:bodyPr wrap="square" lIns="0" tIns="0" rIns="0" bIns="0" rtlCol="0" anchor="t"/>
+          <a:lstStyle/>
+          <a:p>
+            <a:pPr indent="0" marL="0">
+              <a:buNone/>
+            </a:pPr>
+            <a:r>
+              <a:rPr lang="en-US" sz="1800" b="1" dirty="0">
+                <a:solidFill>
+                  <a:schemeClr val="tx1"/>
+                </a:solidFill>
+              </a:rPr>
+              <a:t>Estimate without AI</a:t>
+            </a:r>
+            <a:endParaRPr lang="en-US" sz="1800" dirty="0"/>
+          </a:p>
+        </p:txBody>
+      </p:sp>
+      <p:sp>
+        <p:nvSpPr>
+          <p:cNvPr id="6" name="effort-0-sub"/>
+          <p:cNvSpPr txBox="1"/>
+          <p:nvPr/>
+        </p:nvSpPr>
+        <p:spPr>
+          <a:xfrm>
+            <a:off x="868680" y="3200400"/>
+            <a:ext cx="2875178" cy="548640"/>
+          </a:xfrm>
+          <a:prstGeom prst="rect">
+            <a:avLst/>
+          </a:prstGeom>
+          <a:noFill/>
+          <a:ln/>
+        </p:spPr>
+        <p:txBody>
+          <a:bodyPr wrap="square" lIns="0" tIns="0" rIns="0" bIns="0" rtlCol="0" anchor="t"/>
+          <a:lstStyle/>
+          <a:p>
+            <a:pPr indent="0" marL="0">
+              <a:buNone/>
+            </a:pPr>
+            <a:r>
+              <a:rPr lang="en-US" sz="1400" dirty="0">
                 <a:solidFill>
                   <a:schemeClr val="tx2"/>
                 </a:solidFill>
               </a:rPr>
-              <a:t>Catalogued and compared one by one, so nothing was lost by accident</a:t>
-            </a:r>
-            <a:endParaRPr lang="en-US" sz="1600" dirty="0"/>
-          </a:p>
-        </p:txBody>
-      </p:sp>
-      <p:sp>
-        <p:nvSpPr>
-          <p:cNvPr id="6" name="result-1-card"/>
+              <a:t>sprints, from [source, e.g. PI planning]</a:t>
+            </a:r>
+            <a:endParaRPr lang="en-US" sz="1400" dirty="0"/>
+          </a:p>
+        </p:txBody>
+      </p:sp>
+      <p:sp>
+        <p:nvSpPr>
+          <p:cNvPr id="7" name="effort-1-card"/>
           <p:cNvSpPr/>
           <p:nvPr/>
         </p:nvSpPr>
         <p:spPr>
           <a:xfrm>
-            <a:off x="6233008" y="1600200"/>
-            <a:ext cx="5410048" cy="2057400"/>
+            <a:off x="4338218" y="1600200"/>
+            <a:ext cx="3515258" cy="2286000"/>
           </a:xfrm>
           <a:prstGeom prst="roundRect">
             <a:avLst>
-              <a:gd name="adj" fmla="val 5333"/>
+              <a:gd name="adj" fmla="val 4800"/>
             </a:avLst>
           </a:prstGeom>
           <a:solidFill>
@@ -3331,165 +3457,381 @@
       </p:sp>
       <p:sp>
         <p:nvSpPr>
-          <p:cNvPr id="7" name="result-1-title"/>
-          <p:cNvSpPr txBox="1"/>
-          <p:nvPr/>
-        </p:nvSpPr>
-        <p:spPr>
-          <a:xfrm>
-            <a:off x="6553048" y="1920240"/>
-            <a:ext cx="4769968" cy="685800"/>
-          </a:xfrm>
-          <a:prstGeom prst="rect">
-            <a:avLst/>
-          </a:prstGeom>
-          <a:noFill/>
-          <a:ln/>
-        </p:spPr>
-        <p:txBody>
-          <a:bodyPr wrap="square" lIns="0" tIns="0" rIns="0" bIns="0" rtlCol="0" anchor="t"/>
-          <a:lstStyle/>
-          <a:p>
-            <a:pPr indent="0" marL="0">
-              <a:buNone/>
-            </a:pPr>
-            <a:r>
-              <a:rPr lang="en-US" sz="3200" b="1" dirty="0">
+          <p:cNvPr id="8" name="effort-1-value"/>
+          <p:cNvSpPr txBox="1"/>
+          <p:nvPr/>
+        </p:nvSpPr>
+        <p:spPr>
+          <a:xfrm>
+            <a:off x="4658258" y="1874520"/>
+            <a:ext cx="2875178" cy="868680"/>
+          </a:xfrm>
+          <a:prstGeom prst="rect">
+            <a:avLst/>
+          </a:prstGeom>
+          <a:noFill/>
+          <a:ln/>
+        </p:spPr>
+        <p:txBody>
+          <a:bodyPr wrap="square" lIns="0" tIns="0" rIns="0" bIns="0" rtlCol="0" anchor="t"/>
+          <a:lstStyle/>
+          <a:p>
+            <a:pPr indent="0" marL="0">
+              <a:buNone/>
+            </a:pPr>
+            <a:r>
+              <a:rPr lang="en-US" sz="4800" b="1" dirty="0">
                 <a:solidFill>
                   <a:schemeClr val="tx1"/>
                 </a:solidFill>
               </a:rPr>
-              <a:t>Gaps fixed</a:t>
-            </a:r>
-            <a:endParaRPr lang="en-US" sz="3200" dirty="0"/>
-          </a:p>
-        </p:txBody>
-      </p:sp>
-      <p:sp>
-        <p:nvSpPr>
-          <p:cNvPr id="8" name="result-1-body"/>
-          <p:cNvSpPr txBox="1"/>
-          <p:nvPr/>
-        </p:nvSpPr>
-        <p:spPr>
-          <a:xfrm>
-            <a:off x="6553048" y="2651760"/>
-            <a:ext cx="4769968" cy="731520"/>
-          </a:xfrm>
-          <a:prstGeom prst="rect">
-            <a:avLst/>
-          </a:prstGeom>
-          <a:noFill/>
-          <a:ln/>
-        </p:spPr>
-        <p:txBody>
-          <a:bodyPr wrap="square" lIns="0" tIns="0" rIns="0" bIns="0" rtlCol="0" anchor="t"/>
-          <a:lstStyle/>
-          <a:p>
-            <a:pPr indent="0" marL="0">
-              <a:buNone/>
-            </a:pPr>
-            <a:r>
-              <a:rPr lang="en-US" sz="1600" dirty="0">
+              <a:t>1 PI</a:t>
+            </a:r>
+            <a:endParaRPr lang="en-US" sz="4800" dirty="0"/>
+          </a:p>
+        </p:txBody>
+      </p:sp>
+      <p:sp>
+        <p:nvSpPr>
+          <p:cNvPr id="9" name="effort-1-label"/>
+          <p:cNvSpPr txBox="1"/>
+          <p:nvPr/>
+        </p:nvSpPr>
+        <p:spPr>
+          <a:xfrm>
+            <a:off x="4658258" y="2788920"/>
+            <a:ext cx="2875178" cy="411480"/>
+          </a:xfrm>
+          <a:prstGeom prst="rect">
+            <a:avLst/>
+          </a:prstGeom>
+          <a:noFill/>
+          <a:ln/>
+        </p:spPr>
+        <p:txBody>
+          <a:bodyPr wrap="square" lIns="0" tIns="0" rIns="0" bIns="0" rtlCol="0" anchor="t"/>
+          <a:lstStyle/>
+          <a:p>
+            <a:pPr indent="0" marL="0">
+              <a:buNone/>
+            </a:pPr>
+            <a:r>
+              <a:rPr lang="en-US" sz="1800" b="1" dirty="0">
+                <a:solidFill>
+                  <a:schemeClr val="tx1"/>
+                </a:solidFill>
+              </a:rPr>
+              <a:t>Actual effort with AI</a:t>
+            </a:r>
+            <a:endParaRPr lang="en-US" sz="1800" dirty="0"/>
+          </a:p>
+        </p:txBody>
+      </p:sp>
+      <p:sp>
+        <p:nvSpPr>
+          <p:cNvPr id="10" name="effort-1-sub"/>
+          <p:cNvSpPr txBox="1"/>
+          <p:nvPr/>
+        </p:nvSpPr>
+        <p:spPr>
+          <a:xfrm>
+            <a:off x="4658258" y="3200400"/>
+            <a:ext cx="2875178" cy="548640"/>
+          </a:xfrm>
+          <a:prstGeom prst="rect">
+            <a:avLst/>
+          </a:prstGeom>
+          <a:noFill/>
+          <a:ln/>
+        </p:spPr>
+        <p:txBody>
+          <a:bodyPr wrap="square" lIns="0" tIns="0" rIns="0" bIns="0" rtlCol="0" anchor="t"/>
+          <a:lstStyle/>
+          <a:p>
+            <a:pPr indent="0" marL="0">
+              <a:buNone/>
+            </a:pPr>
+            <a:r>
+              <a:rPr lang="en-US" sz="1400" dirty="0">
                 <a:solidFill>
                   <a:schemeClr val="tx2"/>
                 </a:solidFill>
               </a:rPr>
-              <a:t>Including dashboard sharing access in the backend workflow, now deployed</a:t>
-            </a:r>
-            <a:endParaRPr lang="en-US" sz="1600" dirty="0"/>
-          </a:p>
-        </p:txBody>
-      </p:sp>
-      <p:sp>
-        <p:nvSpPr>
-          <p:cNvPr id="9" name="result-2-card"/>
+              <a:t>[__] sprints, [__] people</a:t>
+            </a:r>
+            <a:endParaRPr lang="en-US" sz="1400" dirty="0"/>
+          </a:p>
+        </p:txBody>
+      </p:sp>
+      <p:sp>
+        <p:nvSpPr>
+          <p:cNvPr id="11" name="effort-2-card"/>
           <p:cNvSpPr/>
           <p:nvPr/>
         </p:nvSpPr>
         <p:spPr>
           <a:xfrm>
-            <a:off x="548640" y="3931920"/>
-            <a:ext cx="5410048" cy="2057400"/>
+            <a:off x="8127797" y="1600200"/>
+            <a:ext cx="3515258" cy="2286000"/>
           </a:xfrm>
           <a:prstGeom prst="roundRect">
             <a:avLst>
-              <a:gd name="adj" fmla="val 5333"/>
+              <a:gd name="adj" fmla="val 4800"/>
             </a:avLst>
           </a:prstGeom>
           <a:solidFill>
-            <a:schemeClr val="bg1"/>
+            <a:schemeClr val="tx1"/>
           </a:solidFill>
           <a:ln/>
         </p:spPr>
       </p:sp>
       <p:sp>
         <p:nvSpPr>
-          <p:cNvPr id="10" name="result-2-title"/>
-          <p:cNvSpPr txBox="1"/>
-          <p:nvPr/>
-        </p:nvSpPr>
-        <p:spPr>
-          <a:xfrm>
-            <a:off x="868680" y="4251960"/>
-            <a:ext cx="4769968" cy="685800"/>
-          </a:xfrm>
-          <a:prstGeom prst="rect">
-            <a:avLst/>
-          </a:prstGeom>
-          <a:noFill/>
-          <a:ln/>
-        </p:spPr>
-        <p:txBody>
-          <a:bodyPr wrap="square" lIns="0" tIns="0" rIns="0" bIns="0" rtlCol="0" anchor="t"/>
-          <a:lstStyle/>
-          <a:p>
-            <a:pPr indent="0" marL="0">
-              <a:buNone/>
-            </a:pPr>
-            <a:r>
-              <a:rPr lang="en-US" sz="3200" b="1" dirty="0">
+          <p:cNvPr id="12" name="effort-2-value"/>
+          <p:cNvSpPr txBox="1"/>
+          <p:nvPr/>
+        </p:nvSpPr>
+        <p:spPr>
+          <a:xfrm>
+            <a:off x="8447837" y="1874520"/>
+            <a:ext cx="2875178" cy="868680"/>
+          </a:xfrm>
+          <a:prstGeom prst="rect">
+            <a:avLst/>
+          </a:prstGeom>
+          <a:noFill/>
+          <a:ln/>
+        </p:spPr>
+        <p:txBody>
+          <a:bodyPr wrap="square" lIns="0" tIns="0" rIns="0" bIns="0" rtlCol="0" anchor="t"/>
+          <a:lstStyle/>
+          <a:p>
+            <a:pPr indent="0" marL="0">
+              <a:buNone/>
+            </a:pPr>
+            <a:r>
+              <a:rPr lang="en-US" sz="4800" b="1" dirty="0">
+                <a:solidFill>
+                  <a:schemeClr val="accent1"/>
+                </a:solidFill>
+              </a:rPr>
+              <a:t>[__]%</a:t>
+            </a:r>
+            <a:endParaRPr lang="en-US" sz="4800" dirty="0"/>
+          </a:p>
+        </p:txBody>
+      </p:sp>
+      <p:sp>
+        <p:nvSpPr>
+          <p:cNvPr id="13" name="effort-2-label"/>
+          <p:cNvSpPr txBox="1"/>
+          <p:nvPr/>
+        </p:nvSpPr>
+        <p:spPr>
+          <a:xfrm>
+            <a:off x="8447837" y="2788920"/>
+            <a:ext cx="2875178" cy="411480"/>
+          </a:xfrm>
+          <a:prstGeom prst="rect">
+            <a:avLst/>
+          </a:prstGeom>
+          <a:noFill/>
+          <a:ln/>
+        </p:spPr>
+        <p:txBody>
+          <a:bodyPr wrap="square" lIns="0" tIns="0" rIns="0" bIns="0" rtlCol="0" anchor="t"/>
+          <a:lstStyle/>
+          <a:p>
+            <a:pPr indent="0" marL="0">
+              <a:buNone/>
+            </a:pPr>
+            <a:r>
+              <a:rPr lang="en-US" sz="1800" b="1" dirty="0">
+                <a:solidFill>
+                  <a:schemeClr val="bg1"/>
+                </a:solidFill>
+              </a:rPr>
+              <a:t>Effort saved</a:t>
+            </a:r>
+            <a:endParaRPr lang="en-US" sz="1800" dirty="0"/>
+          </a:p>
+        </p:txBody>
+      </p:sp>
+      <p:sp>
+        <p:nvSpPr>
+          <p:cNvPr id="14" name="effort-2-sub"/>
+          <p:cNvSpPr txBox="1"/>
+          <p:nvPr/>
+        </p:nvSpPr>
+        <p:spPr>
+          <a:xfrm>
+            <a:off x="8447837" y="3200400"/>
+            <a:ext cx="2875178" cy="548640"/>
+          </a:xfrm>
+          <a:prstGeom prst="rect">
+            <a:avLst/>
+          </a:prstGeom>
+          <a:noFill/>
+          <a:ln/>
+        </p:spPr>
+        <p:txBody>
+          <a:bodyPr wrap="square" lIns="0" tIns="0" rIns="0" bIns="0" rtlCol="0" anchor="t"/>
+          <a:lstStyle/>
+          <a:p>
+            <a:pPr indent="0" marL="0">
+              <a:buNone/>
+            </a:pPr>
+            <a:r>
+              <a:rPr lang="en-US" sz="1400" dirty="0">
+                <a:solidFill>
+                  <a:schemeClr val="accent5"/>
+                </a:solidFill>
+              </a:rPr>
+              <a:t>(estimate − actual) ÷ estimate</a:t>
+            </a:r>
+            <a:endParaRPr lang="en-US" sz="1400" dirty="0"/>
+          </a:p>
+        </p:txBody>
+      </p:sp>
+      <p:sp>
+        <p:nvSpPr>
+          <p:cNvPr id="15" name="where-title"/>
+          <p:cNvSpPr txBox="1"/>
+          <p:nvPr/>
+        </p:nvSpPr>
+        <p:spPr>
+          <a:xfrm>
+            <a:off x="548640" y="4206240"/>
+            <a:ext cx="11094415" cy="411480"/>
+          </a:xfrm>
+          <a:prstGeom prst="rect">
+            <a:avLst/>
+          </a:prstGeom>
+          <a:noFill/>
+          <a:ln/>
+        </p:spPr>
+        <p:txBody>
+          <a:bodyPr wrap="square" lIns="0" tIns="0" rIns="0" bIns="0" rtlCol="0" anchor="t"/>
+          <a:lstStyle/>
+          <a:p>
+            <a:pPr indent="0" marL="0">
+              <a:buNone/>
+            </a:pPr>
+            <a:r>
+              <a:rPr lang="en-US" sz="2000" b="1" dirty="0">
                 <a:solidFill>
                   <a:schemeClr val="tx1"/>
                 </a:solidFill>
               </a:rPr>
-              <a:t>New features</a:t>
-            </a:r>
-            <a:endParaRPr lang="en-US" sz="3200" dirty="0"/>
-          </a:p>
-        </p:txBody>
-      </p:sp>
-      <p:sp>
-        <p:nvSpPr>
-          <p:cNvPr id="11" name="result-2-body"/>
-          <p:cNvSpPr txBox="1"/>
-          <p:nvPr/>
-        </p:nvSpPr>
-        <p:spPr>
-          <a:xfrm>
-            <a:off x="868680" y="4983480"/>
-            <a:ext cx="4769968" cy="731520"/>
-          </a:xfrm>
-          <a:prstGeom prst="rect">
-            <a:avLst/>
-          </a:prstGeom>
-          <a:noFill/>
-          <a:ln/>
-        </p:spPr>
-        <p:txBody>
-          <a:bodyPr wrap="square" lIns="0" tIns="0" rIns="0" bIns="0" rtlCol="0" anchor="t"/>
-          <a:lstStyle/>
-          <a:p>
-            <a:pPr indent="0" marL="0">
-              <a:buNone/>
-            </a:pPr>
-            <a:r>
-              <a:rPr lang="en-US" sz="1600" dirty="0">
+              <a:t>Where the AI saved the most time</a:t>
+            </a:r>
+            <a:endParaRPr lang="en-US" sz="2000" dirty="0"/>
+          </a:p>
+        </p:txBody>
+      </p:sp>
+      <p:sp>
+        <p:nvSpPr>
+          <p:cNvPr id="16" name="where-0-title"/>
+          <p:cNvSpPr txBox="1"/>
+          <p:nvPr/>
+        </p:nvSpPr>
+        <p:spPr>
+          <a:xfrm>
+            <a:off x="548640" y="4754880"/>
+            <a:ext cx="3515258" cy="365760"/>
+          </a:xfrm>
+          <a:prstGeom prst="rect">
+            <a:avLst/>
+          </a:prstGeom>
+          <a:noFill/>
+          <a:ln/>
+        </p:spPr>
+        <p:txBody>
+          <a:bodyPr wrap="square" lIns="0" tIns="0" rIns="0" bIns="0" rtlCol="0" anchor="t"/>
+          <a:lstStyle/>
+          <a:p>
+            <a:pPr indent="0" marL="0">
+              <a:buNone/>
+            </a:pPr>
+            <a:r>
+              <a:rPr lang="en-US" sz="1600" b="1" dirty="0">
+                <a:solidFill>
+                  <a:schemeClr val="accent3"/>
+                </a:solidFill>
+              </a:rPr>
+              <a:t>Discovery</a:t>
+            </a:r>
+            <a:endParaRPr lang="en-US" sz="1600" dirty="0"/>
+          </a:p>
+        </p:txBody>
+      </p:sp>
+      <p:sp>
+        <p:nvSpPr>
+          <p:cNvPr id="17" name="where-0-body"/>
+          <p:cNvSpPr txBox="1"/>
+          <p:nvPr/>
+        </p:nvSpPr>
+        <p:spPr>
+          <a:xfrm>
+            <a:off x="548640" y="5138928"/>
+            <a:ext cx="3515258" cy="685800"/>
+          </a:xfrm>
+          <a:prstGeom prst="rect">
+            <a:avLst/>
+          </a:prstGeom>
+          <a:noFill/>
+          <a:ln/>
+        </p:spPr>
+        <p:txBody>
+          <a:bodyPr wrap="square" lIns="0" tIns="0" rIns="0" bIns="0" rtlCol="0" anchor="t"/>
+          <a:lstStyle/>
+          <a:p>
+            <a:pPr indent="0" marL="0">
+              <a:buNone/>
+            </a:pPr>
+            <a:r>
+              <a:rPr lang="en-US" sz="1500" dirty="0">
                 <a:solidFill>
                   <a:schemeClr val="tx2"/>
                 </a:solidFill>
               </a:rPr>
-              <a:t>[List the new React features you will demo]</a:t>
+              <a:t>105 features catalogued from the exports, with no docs to read</a:t>
+            </a:r>
+            <a:endParaRPr lang="en-US" sz="1500" dirty="0"/>
+          </a:p>
+        </p:txBody>
+      </p:sp>
+      <p:sp>
+        <p:nvSpPr>
+          <p:cNvPr id="18" name="where-1-title"/>
+          <p:cNvSpPr txBox="1"/>
+          <p:nvPr/>
+        </p:nvSpPr>
+        <p:spPr>
+          <a:xfrm>
+            <a:off x="4338218" y="4754880"/>
+            <a:ext cx="3515258" cy="365760"/>
+          </a:xfrm>
+          <a:prstGeom prst="rect">
+            <a:avLst/>
+          </a:prstGeom>
+          <a:noFill/>
+          <a:ln/>
+        </p:spPr>
+        <p:txBody>
+          <a:bodyPr wrap="square" lIns="0" tIns="0" rIns="0" bIns="0" rtlCol="0" anchor="t"/>
+          <a:lstStyle/>
+          <a:p>
+            <a:pPr indent="0" marL="0">
+              <a:buNone/>
+            </a:pPr>
+            <a:r>
+              <a:rPr lang="en-US" sz="1600" b="1" dirty="0">
+                <a:solidFill>
+                  <a:schemeClr val="accent3"/>
+                </a:solidFill>
+              </a:rPr>
+              <a:t>Gap analysis</a:t>
             </a:r>
             <a:endParaRPr lang="en-US" sz="1600" dirty="0"/>
           </a:p>
@@ -3497,95 +3839,109 @@
       </p:sp>
       <p:sp>
         <p:nvSpPr>
-          <p:cNvPr id="12" name="result-3-card"/>
-          <p:cNvSpPr/>
-          <p:nvPr/>
-        </p:nvSpPr>
-        <p:spPr>
-          <a:xfrm>
-            <a:off x="6233008" y="3931920"/>
-            <a:ext cx="5410048" cy="2057400"/>
-          </a:xfrm>
-          <a:prstGeom prst="roundRect">
-            <a:avLst>
-              <a:gd name="adj" fmla="val 5333"/>
-            </a:avLst>
-          </a:prstGeom>
-          <a:solidFill>
-            <a:schemeClr val="bg1"/>
-          </a:solidFill>
-          <a:ln/>
-        </p:spPr>
-      </p:sp>
-      <p:sp>
-        <p:nvSpPr>
-          <p:cNvPr id="13" name="result-3-title"/>
-          <p:cNvSpPr txBox="1"/>
-          <p:nvPr/>
-        </p:nvSpPr>
-        <p:spPr>
-          <a:xfrm>
-            <a:off x="6553048" y="4251960"/>
-            <a:ext cx="4769968" cy="685800"/>
-          </a:xfrm>
-          <a:prstGeom prst="rect">
-            <a:avLst/>
-          </a:prstGeom>
-          <a:noFill/>
-          <a:ln/>
-        </p:spPr>
-        <p:txBody>
-          <a:bodyPr wrap="square" lIns="0" tIns="0" rIns="0" bIns="0" rtlCol="0" anchor="t"/>
-          <a:lstStyle/>
-          <a:p>
-            <a:pPr indent="0" marL="0">
-              <a:buNone/>
-            </a:pPr>
-            <a:r>
-              <a:rPr lang="en-US" sz="3200" b="1" dirty="0">
-                <a:solidFill>
-                  <a:schemeClr val="tx1"/>
-                </a:solidFill>
-              </a:rPr>
-              <a:t>Documented</a:t>
-            </a:r>
-            <a:endParaRPr lang="en-US" sz="3200" dirty="0"/>
-          </a:p>
-        </p:txBody>
-      </p:sp>
-      <p:sp>
-        <p:nvSpPr>
-          <p:cNvPr id="14" name="result-3-body"/>
-          <p:cNvSpPr txBox="1"/>
-          <p:nvPr/>
-        </p:nvSpPr>
-        <p:spPr>
-          <a:xfrm>
-            <a:off x="6553048" y="4983480"/>
-            <a:ext cx="4769968" cy="731520"/>
-          </a:xfrm>
-          <a:prstGeom prst="rect">
-            <a:avLst/>
-          </a:prstGeom>
-          <a:noFill/>
-          <a:ln/>
-        </p:spPr>
-        <p:txBody>
-          <a:bodyPr wrap="square" lIns="0" tIns="0" rIns="0" bIns="0" rtlCol="0" anchor="t"/>
-          <a:lstStyle/>
-          <a:p>
-            <a:pPr indent="0" marL="0">
-              <a:buNone/>
-            </a:pPr>
-            <a:r>
-              <a:rPr lang="en-US" sz="1600" dirty="0">
+          <p:cNvPr id="19" name="where-1-body"/>
+          <p:cNvSpPr txBox="1"/>
+          <p:nvPr/>
+        </p:nvSpPr>
+        <p:spPr>
+          <a:xfrm>
+            <a:off x="4338218" y="5138928"/>
+            <a:ext cx="3515258" cy="685800"/>
+          </a:xfrm>
+          <a:prstGeom prst="rect">
+            <a:avLst/>
+          </a:prstGeom>
+          <a:noFill/>
+          <a:ln/>
+        </p:spPr>
+        <p:txBody>
+          <a:bodyPr wrap="square" lIns="0" tIns="0" rIns="0" bIns="0" rtlCol="0" anchor="t"/>
+          <a:lstStyle/>
+          <a:p>
+            <a:pPr indent="0" marL="0">
+              <a:buNone/>
+            </a:pPr>
+            <a:r>
+              <a:rPr lang="en-US" sz="1500" dirty="0">
                 <a:solidFill>
                   <a:schemeClr val="tx2"/>
                 </a:solidFill>
               </a:rPr>
-              <a:t>Architecture and lifecycle diagrams for both apps, where none existed</a:t>
+              <a:t>Every feature checked against the packed React code</a:t>
+            </a:r>
+            <a:endParaRPr lang="en-US" sz="1500" dirty="0"/>
+          </a:p>
+        </p:txBody>
+      </p:sp>
+      <p:sp>
+        <p:nvSpPr>
+          <p:cNvPr id="20" name="where-2-title"/>
+          <p:cNvSpPr txBox="1"/>
+          <p:nvPr/>
+        </p:nvSpPr>
+        <p:spPr>
+          <a:xfrm>
+            <a:off x="8127797" y="4754880"/>
+            <a:ext cx="3515258" cy="365760"/>
+          </a:xfrm>
+          <a:prstGeom prst="rect">
+            <a:avLst/>
+          </a:prstGeom>
+          <a:noFill/>
+          <a:ln/>
+        </p:spPr>
+        <p:txBody>
+          <a:bodyPr wrap="square" lIns="0" tIns="0" rIns="0" bIns="0" rtlCol="0" anchor="t"/>
+          <a:lstStyle/>
+          <a:p>
+            <a:pPr indent="0" marL="0">
+              <a:buNone/>
+            </a:pPr>
+            <a:r>
+              <a:rPr lang="en-US" sz="1600" b="1" dirty="0">
+                <a:solidFill>
+                  <a:schemeClr val="accent3"/>
+                </a:solidFill>
+              </a:rPr>
+              <a:t>Documentation</a:t>
             </a:r>
             <a:endParaRPr lang="en-US" sz="1600" dirty="0"/>
+          </a:p>
+        </p:txBody>
+      </p:sp>
+      <p:sp>
+        <p:nvSpPr>
+          <p:cNvPr id="21" name="where-2-body"/>
+          <p:cNvSpPr txBox="1"/>
+          <p:nvPr/>
+        </p:nvSpPr>
+        <p:spPr>
+          <a:xfrm>
+            <a:off x="8127797" y="5138928"/>
+            <a:ext cx="3515258" cy="685800"/>
+          </a:xfrm>
+          <a:prstGeom prst="rect">
+            <a:avLst/>
+          </a:prstGeom>
+          <a:noFill/>
+          <a:ln/>
+        </p:spPr>
+        <p:txBody>
+          <a:bodyPr wrap="square" lIns="0" tIns="0" rIns="0" bIns="0" rtlCol="0" anchor="t"/>
+          <a:lstStyle/>
+          <a:p>
+            <a:pPr indent="0" marL="0">
+              <a:buNone/>
+            </a:pPr>
+            <a:r>
+              <a:rPr lang="en-US" sz="1500" dirty="0">
+                <a:solidFill>
+                  <a:schemeClr val="tx2"/>
+                </a:solidFill>
+              </a:rPr>
+              <a:t>8 architecture and lifecycle diagrams produced alongside the work</a:t>
+            </a:r>
+            <a:endParaRPr lang="en-US" sz="1500" dirty="0"/>
           </a:p>
         </p:txBody>
       </p:sp>
@@ -3600,6 +3956,445 @@
 <file path=ppt/slides/slide6.xml><?xml version="1.0" encoding="utf-8"?>
 <p:sld xmlns:a="http://schemas.openxmlformats.org/drawingml/2006/main" xmlns:r="http://schemas.openxmlformats.org/officeDocument/2006/relationships" xmlns:p="http://schemas.openxmlformats.org/presentationml/2006/main">
   <p:cSld name="Slide 6">
+    <p:spTree>
+      <p:nvGrpSpPr>
+        <p:cNvPr id="1" name=""/>
+        <p:cNvGrpSpPr/>
+        <p:nvPr/>
+      </p:nvGrpSpPr>
+      <p:grpSpPr>
+        <a:xfrm>
+          <a:off x="0" y="0"/>
+          <a:ext cx="0" cy="0"/>
+          <a:chOff x="0" y="0"/>
+          <a:chExt cx="0" cy="0"/>
+        </a:xfrm>
+      </p:grpSpPr>
+      <p:sp>
+        <p:nvSpPr>
+          <p:cNvPr id="2" name="Text 0"/>
+          <p:cNvSpPr/>
+          <p:nvPr>
+            <p:ph idx="100" type="title" hasCustomPrompt="1"/>
+          </p:nvPr>
+        </p:nvSpPr>
+        <p:spPr>
+          <a:xfrm>
+            <a:off x="548640" y="502920"/>
+            <a:ext cx="11094415" cy="822960"/>
+          </a:xfrm>
+          <a:prstGeom prst="rect">
+            <a:avLst/>
+          </a:prstGeom>
+          <a:noFill/>
+          <a:ln/>
+        </p:spPr>
+        <p:txBody>
+          <a:bodyPr wrap="square" lIns="0" tIns="0" rIns="0" bIns="0" rtlCol="0" anchor="t"/>
+          <a:lstStyle/>
+          <a:p>
+            <a:pPr algn="l" indent="0" marL="0">
+              <a:buNone/>
+            </a:pPr>
+            <a:r>
+              <a:rPr lang="en-US" sz="3600" b="1" dirty="0">
+                <a:solidFill>
+                  <a:schemeClr val="tx1"/>
+                </a:solidFill>
+              </a:rPr>
+              <a:t>What we delivered in one SAFe PI</a:t>
+            </a:r>
+            <a:endParaRPr lang="en-US" sz="3600" dirty="0"/>
+          </a:p>
+        </p:txBody>
+      </p:sp>
+      <p:sp>
+        <p:nvSpPr>
+          <p:cNvPr id="3" name="result-0-card"/>
+          <p:cNvSpPr/>
+          <p:nvPr/>
+        </p:nvSpPr>
+        <p:spPr>
+          <a:xfrm>
+            <a:off x="548640" y="1600200"/>
+            <a:ext cx="5410048" cy="2057400"/>
+          </a:xfrm>
+          <a:prstGeom prst="roundRect">
+            <a:avLst>
+              <a:gd name="adj" fmla="val 5333"/>
+            </a:avLst>
+          </a:prstGeom>
+          <a:solidFill>
+            <a:schemeClr val="bg1"/>
+          </a:solidFill>
+          <a:ln/>
+        </p:spPr>
+      </p:sp>
+      <p:sp>
+        <p:nvSpPr>
+          <p:cNvPr id="4" name="result-0-title"/>
+          <p:cNvSpPr txBox="1"/>
+          <p:nvPr/>
+        </p:nvSpPr>
+        <p:spPr>
+          <a:xfrm>
+            <a:off x="868680" y="1920240"/>
+            <a:ext cx="4769968" cy="685800"/>
+          </a:xfrm>
+          <a:prstGeom prst="rect">
+            <a:avLst/>
+          </a:prstGeom>
+          <a:noFill/>
+          <a:ln/>
+        </p:spPr>
+        <p:txBody>
+          <a:bodyPr wrap="square" lIns="0" tIns="0" rIns="0" bIns="0" rtlCol="0" anchor="t"/>
+          <a:lstStyle/>
+          <a:p>
+            <a:pPr indent="0" marL="0">
+              <a:buNone/>
+            </a:pPr>
+            <a:r>
+              <a:rPr lang="en-US" sz="3200" b="1" dirty="0">
+                <a:solidFill>
+                  <a:schemeClr val="accent3"/>
+                </a:solidFill>
+              </a:rPr>
+              <a:t>105 features</a:t>
+            </a:r>
+            <a:endParaRPr lang="en-US" sz="3200" dirty="0"/>
+          </a:p>
+        </p:txBody>
+      </p:sp>
+      <p:sp>
+        <p:nvSpPr>
+          <p:cNvPr id="5" name="result-0-body"/>
+          <p:cNvSpPr txBox="1"/>
+          <p:nvPr/>
+        </p:nvSpPr>
+        <p:spPr>
+          <a:xfrm>
+            <a:off x="868680" y="2651760"/>
+            <a:ext cx="4769968" cy="731520"/>
+          </a:xfrm>
+          <a:prstGeom prst="rect">
+            <a:avLst/>
+          </a:prstGeom>
+          <a:noFill/>
+          <a:ln/>
+        </p:spPr>
+        <p:txBody>
+          <a:bodyPr wrap="square" lIns="0" tIns="0" rIns="0" bIns="0" rtlCol="0" anchor="t"/>
+          <a:lstStyle/>
+          <a:p>
+            <a:pPr indent="0" marL="0">
+              <a:buNone/>
+            </a:pPr>
+            <a:r>
+              <a:rPr lang="en-US" sz="1600" dirty="0">
+                <a:solidFill>
+                  <a:schemeClr val="tx2"/>
+                </a:solidFill>
+              </a:rPr>
+              <a:t>Catalogued and compared one by one, so nothing was lost by accident</a:t>
+            </a:r>
+            <a:endParaRPr lang="en-US" sz="1600" dirty="0"/>
+          </a:p>
+        </p:txBody>
+      </p:sp>
+      <p:sp>
+        <p:nvSpPr>
+          <p:cNvPr id="6" name="result-1-card"/>
+          <p:cNvSpPr/>
+          <p:nvPr/>
+        </p:nvSpPr>
+        <p:spPr>
+          <a:xfrm>
+            <a:off x="6233008" y="1600200"/>
+            <a:ext cx="5410048" cy="2057400"/>
+          </a:xfrm>
+          <a:prstGeom prst="roundRect">
+            <a:avLst>
+              <a:gd name="adj" fmla="val 5333"/>
+            </a:avLst>
+          </a:prstGeom>
+          <a:solidFill>
+            <a:schemeClr val="bg1"/>
+          </a:solidFill>
+          <a:ln/>
+        </p:spPr>
+      </p:sp>
+      <p:sp>
+        <p:nvSpPr>
+          <p:cNvPr id="7" name="result-1-title"/>
+          <p:cNvSpPr txBox="1"/>
+          <p:nvPr/>
+        </p:nvSpPr>
+        <p:spPr>
+          <a:xfrm>
+            <a:off x="6553048" y="1920240"/>
+            <a:ext cx="4769968" cy="685800"/>
+          </a:xfrm>
+          <a:prstGeom prst="rect">
+            <a:avLst/>
+          </a:prstGeom>
+          <a:noFill/>
+          <a:ln/>
+        </p:spPr>
+        <p:txBody>
+          <a:bodyPr wrap="square" lIns="0" tIns="0" rIns="0" bIns="0" rtlCol="0" anchor="t"/>
+          <a:lstStyle/>
+          <a:p>
+            <a:pPr indent="0" marL="0">
+              <a:buNone/>
+            </a:pPr>
+            <a:r>
+              <a:rPr lang="en-US" sz="3200" b="1" dirty="0">
+                <a:solidFill>
+                  <a:schemeClr val="tx1"/>
+                </a:solidFill>
+              </a:rPr>
+              <a:t>Gaps fixed</a:t>
+            </a:r>
+            <a:endParaRPr lang="en-US" sz="3200" dirty="0"/>
+          </a:p>
+        </p:txBody>
+      </p:sp>
+      <p:sp>
+        <p:nvSpPr>
+          <p:cNvPr id="8" name="result-1-body"/>
+          <p:cNvSpPr txBox="1"/>
+          <p:nvPr/>
+        </p:nvSpPr>
+        <p:spPr>
+          <a:xfrm>
+            <a:off x="6553048" y="2651760"/>
+            <a:ext cx="4769968" cy="731520"/>
+          </a:xfrm>
+          <a:prstGeom prst="rect">
+            <a:avLst/>
+          </a:prstGeom>
+          <a:noFill/>
+          <a:ln/>
+        </p:spPr>
+        <p:txBody>
+          <a:bodyPr wrap="square" lIns="0" tIns="0" rIns="0" bIns="0" rtlCol="0" anchor="t"/>
+          <a:lstStyle/>
+          <a:p>
+            <a:pPr indent="0" marL="0">
+              <a:buNone/>
+            </a:pPr>
+            <a:r>
+              <a:rPr lang="en-US" sz="1600" dirty="0">
+                <a:solidFill>
+                  <a:schemeClr val="tx2"/>
+                </a:solidFill>
+              </a:rPr>
+              <a:t>Including dashboard sharing access in the backend workflow, now deployed</a:t>
+            </a:r>
+            <a:endParaRPr lang="en-US" sz="1600" dirty="0"/>
+          </a:p>
+        </p:txBody>
+      </p:sp>
+      <p:sp>
+        <p:nvSpPr>
+          <p:cNvPr id="9" name="result-2-card"/>
+          <p:cNvSpPr/>
+          <p:nvPr/>
+        </p:nvSpPr>
+        <p:spPr>
+          <a:xfrm>
+            <a:off x="548640" y="3931920"/>
+            <a:ext cx="5410048" cy="2057400"/>
+          </a:xfrm>
+          <a:prstGeom prst="roundRect">
+            <a:avLst>
+              <a:gd name="adj" fmla="val 5333"/>
+            </a:avLst>
+          </a:prstGeom>
+          <a:solidFill>
+            <a:schemeClr val="bg1"/>
+          </a:solidFill>
+          <a:ln/>
+        </p:spPr>
+      </p:sp>
+      <p:sp>
+        <p:nvSpPr>
+          <p:cNvPr id="10" name="result-2-title"/>
+          <p:cNvSpPr txBox="1"/>
+          <p:nvPr/>
+        </p:nvSpPr>
+        <p:spPr>
+          <a:xfrm>
+            <a:off x="868680" y="4251960"/>
+            <a:ext cx="4769968" cy="685800"/>
+          </a:xfrm>
+          <a:prstGeom prst="rect">
+            <a:avLst/>
+          </a:prstGeom>
+          <a:noFill/>
+          <a:ln/>
+        </p:spPr>
+        <p:txBody>
+          <a:bodyPr wrap="square" lIns="0" tIns="0" rIns="0" bIns="0" rtlCol="0" anchor="t"/>
+          <a:lstStyle/>
+          <a:p>
+            <a:pPr indent="0" marL="0">
+              <a:buNone/>
+            </a:pPr>
+            <a:r>
+              <a:rPr lang="en-US" sz="3200" b="1" dirty="0">
+                <a:solidFill>
+                  <a:schemeClr val="tx1"/>
+                </a:solidFill>
+              </a:rPr>
+              <a:t>New features</a:t>
+            </a:r>
+            <a:endParaRPr lang="en-US" sz="3200" dirty="0"/>
+          </a:p>
+        </p:txBody>
+      </p:sp>
+      <p:sp>
+        <p:nvSpPr>
+          <p:cNvPr id="11" name="result-2-body"/>
+          <p:cNvSpPr txBox="1"/>
+          <p:nvPr/>
+        </p:nvSpPr>
+        <p:spPr>
+          <a:xfrm>
+            <a:off x="868680" y="4983480"/>
+            <a:ext cx="4769968" cy="731520"/>
+          </a:xfrm>
+          <a:prstGeom prst="rect">
+            <a:avLst/>
+          </a:prstGeom>
+          <a:noFill/>
+          <a:ln/>
+        </p:spPr>
+        <p:txBody>
+          <a:bodyPr wrap="square" lIns="0" tIns="0" rIns="0" bIns="0" rtlCol="0" anchor="t"/>
+          <a:lstStyle/>
+          <a:p>
+            <a:pPr indent="0" marL="0">
+              <a:buNone/>
+            </a:pPr>
+            <a:r>
+              <a:rPr lang="en-US" sz="1600" dirty="0">
+                <a:solidFill>
+                  <a:schemeClr val="tx2"/>
+                </a:solidFill>
+              </a:rPr>
+              <a:t>[List the new React features you will demo]</a:t>
+            </a:r>
+            <a:endParaRPr lang="en-US" sz="1600" dirty="0"/>
+          </a:p>
+        </p:txBody>
+      </p:sp>
+      <p:sp>
+        <p:nvSpPr>
+          <p:cNvPr id="12" name="result-3-card"/>
+          <p:cNvSpPr/>
+          <p:nvPr/>
+        </p:nvSpPr>
+        <p:spPr>
+          <a:xfrm>
+            <a:off x="6233008" y="3931920"/>
+            <a:ext cx="5410048" cy="2057400"/>
+          </a:xfrm>
+          <a:prstGeom prst="roundRect">
+            <a:avLst>
+              <a:gd name="adj" fmla="val 5333"/>
+            </a:avLst>
+          </a:prstGeom>
+          <a:solidFill>
+            <a:schemeClr val="bg1"/>
+          </a:solidFill>
+          <a:ln/>
+        </p:spPr>
+      </p:sp>
+      <p:sp>
+        <p:nvSpPr>
+          <p:cNvPr id="13" name="result-3-title"/>
+          <p:cNvSpPr txBox="1"/>
+          <p:nvPr/>
+        </p:nvSpPr>
+        <p:spPr>
+          <a:xfrm>
+            <a:off x="6553048" y="4251960"/>
+            <a:ext cx="4769968" cy="685800"/>
+          </a:xfrm>
+          <a:prstGeom prst="rect">
+            <a:avLst/>
+          </a:prstGeom>
+          <a:noFill/>
+          <a:ln/>
+        </p:spPr>
+        <p:txBody>
+          <a:bodyPr wrap="square" lIns="0" tIns="0" rIns="0" bIns="0" rtlCol="0" anchor="t"/>
+          <a:lstStyle/>
+          <a:p>
+            <a:pPr indent="0" marL="0">
+              <a:buNone/>
+            </a:pPr>
+            <a:r>
+              <a:rPr lang="en-US" sz="3200" b="1" dirty="0">
+                <a:solidFill>
+                  <a:schemeClr val="tx1"/>
+                </a:solidFill>
+              </a:rPr>
+              <a:t>Documented</a:t>
+            </a:r>
+            <a:endParaRPr lang="en-US" sz="3200" dirty="0"/>
+          </a:p>
+        </p:txBody>
+      </p:sp>
+      <p:sp>
+        <p:nvSpPr>
+          <p:cNvPr id="14" name="result-3-body"/>
+          <p:cNvSpPr txBox="1"/>
+          <p:nvPr/>
+        </p:nvSpPr>
+        <p:spPr>
+          <a:xfrm>
+            <a:off x="6553048" y="4983480"/>
+            <a:ext cx="4769968" cy="731520"/>
+          </a:xfrm>
+          <a:prstGeom prst="rect">
+            <a:avLst/>
+          </a:prstGeom>
+          <a:noFill/>
+          <a:ln/>
+        </p:spPr>
+        <p:txBody>
+          <a:bodyPr wrap="square" lIns="0" tIns="0" rIns="0" bIns="0" rtlCol="0" anchor="t"/>
+          <a:lstStyle/>
+          <a:p>
+            <a:pPr indent="0" marL="0">
+              <a:buNone/>
+            </a:pPr>
+            <a:r>
+              <a:rPr lang="en-US" sz="1600" dirty="0">
+                <a:solidFill>
+                  <a:schemeClr val="tx2"/>
+                </a:solidFill>
+              </a:rPr>
+              <a:t>Architecture and lifecycle diagrams for both apps, where none existed</a:t>
+            </a:r>
+            <a:endParaRPr lang="en-US" sz="1600" dirty="0"/>
+          </a:p>
+        </p:txBody>
+      </p:sp>
+    </p:spTree>
+  </p:cSld>
+  <p:clrMapOvr>
+    <a:masterClrMapping/>
+  </p:clrMapOvr>
+</p:sld>
+</file>
+
+<file path=ppt/slides/slide7.xml><?xml version="1.0" encoding="utf-8"?>
+<p:sld xmlns:a="http://schemas.openxmlformats.org/drawingml/2006/main" xmlns:r="http://schemas.openxmlformats.org/officeDocument/2006/relationships" xmlns:p="http://schemas.openxmlformats.org/presentationml/2006/main">
+  <p:cSld name="Slide 7">
     <p:spTree>
       <p:nvGrpSpPr>
         <p:cNvPr id="1" name=""/>

</xml_diff>

<commit_message>
Fill effort-saved slide with a generic manual-migration estimate
Co-Authored-By: Claude Opus 5.5 <noreply@anthropic.com>
Claude-Session: https://claude.ai/code/session_01HdxEbeqqWM97gKbcNqpjAq
</commit_message>
<xml_diff>
--- a/erm-migration/docs/ERM-Migration-Jury-Pitch.pptx
+++ b/erm-migration/docs/ERM-Migration-Jury-Pitch.pptx
@@ -113,25 +113,25 @@
   <p:extLst>
     <p:ext uri="{521415D9-36F7-43E2-AB2F-B90AF26B5E84}">
       <p14:sectionLst xmlns:p14="http://schemas.microsoft.com/office/powerpoint/2010/main">
-        <p14:section name="Pitch" id="{c5fdbef1-2242-f2f2-7c49-bd7fd0e4346e}">
+        <p14:section name="Pitch" id="{f9d7b542-1bb9-af64-8da4-219e9bdf59af}">
           <p14:sldIdLst>
             <p14:sldId id="256"/>
           </p14:sldIdLst>
         </p14:section>
-        <p14:section name="Problem and method" id="{45e1f99c-1e2b-c64c-9a7a-4dfa2194a18e}">
+        <p14:section name="Problem and method" id="{e840d901-d90f-1a05-676e-e0f15e83fea3}">
           <p14:sldIdLst>
             <p14:sldId id="257"/>
             <p14:sldId id="258"/>
           </p14:sldIdLst>
         </p14:section>
-        <p14:section name="Impact" id="{243a8934-3c6e-b6b2-b366-ecd90d319511}">
+        <p14:section name="Impact" id="{28961b5f-3114-2e9c-40db-c9292b2ea9fd}">
           <p14:sldIdLst>
             <p14:sldId id="259"/>
             <p14:sldId id="260"/>
             <p14:sldId id="261"/>
           </p14:sldIdLst>
         </p14:section>
-        <p14:section name="Reuse" id="{e594c4fd-50d8-de63-a813-b28990026acf}">
+        <p14:section name="Reuse" id="{0078f65d-e0ff-5fdd-4c8b-1a5aa75b7031}">
           <p14:sldIdLst>
             <p14:sldId id="262"/>
           </p14:sldIdLst>
@@ -892,7 +892,7 @@
           <a:p>
             <a:r>
               <a:rPr lang="en-US" dirty="0"/>
-              <a:t>Fill in the numbers before presenting. Give the estimate the migration would have needed without AI, and say where it came from (for example the original PI planning). Then the actual effort: one PI, with the number of sprints and people. The percentage saved is (estimate minus actual) divided by estimate. Then say where the time went: discovery was the biggest saving, because the AI catalogued 105 features straight from the Slate exports with no documentation to read; gap analysis, because every feature was checked against the packed React code; and documentation, because the diagrams were produced alongside the work instead of afterwards.</a:t>
+              <a:t>These are generic industry-style estimates, not our measured baseline; say so if asked. A manual migration of 105 features typically needs about half a day per feature to reverse-engineer it, two days to rebuild it and half a day to test parity, plus about 25 days to document the app: roughly 340 person-days, or about 7 sprints for a team of 5. We did it in one PI, 4 development sprints, which is about 40% less effort. Then say where the time went: discovery was the biggest saving, because the AI catalogued 105 features straight from the Slate exports with no documentation to read; gap analysis, because every feature was checked against the packed React code; and documentation, because the diagrams were produced alongside the work instead of afterwards.</a:t>
             </a:r>
             <a:endParaRPr lang="en-US" dirty="0"/>
           </a:p>
@@ -3297,7 +3297,7 @@
                   <a:schemeClr val="tx1"/>
                 </a:solidFill>
               </a:rPr>
-              <a:t>Effort saved: [__] sprints in one PI</a:t>
+              <a:t>Effort saved: about 40% versus manual</a:t>
             </a:r>
             <a:endParaRPr lang="en-US" sz="3600" dirty="0"/>
           </a:p>
@@ -3355,7 +3355,7 @@
                   <a:schemeClr val="tx1"/>
                 </a:solidFill>
               </a:rPr>
-              <a:t>[__]</a:t>
+              <a:t>~7</a:t>
             </a:r>
             <a:endParaRPr lang="en-US" sz="4800" dirty="0"/>
           </a:p>
@@ -3391,7 +3391,7 @@
                   <a:schemeClr val="tx1"/>
                 </a:solidFill>
               </a:rPr>
-              <a:t>Estimate without AI</a:t>
+              <a:t>Manual estimate</a:t>
             </a:r>
             <a:endParaRPr lang="en-US" sz="1800" dirty="0"/>
           </a:p>
@@ -3427,7 +3427,7 @@
                   <a:schemeClr val="tx2"/>
                 </a:solidFill>
               </a:rPr>
-              <a:t>sprints, from [source, e.g. PI planning]</a:t>
+              <a:t>sprints, ≈ 340 person-days</a:t>
             </a:r>
             <a:endParaRPr lang="en-US" sz="1400" dirty="0"/>
           </a:p>
@@ -3485,7 +3485,7 @@
                   <a:schemeClr val="tx1"/>
                 </a:solidFill>
               </a:rPr>
-              <a:t>1 PI</a:t>
+              <a:t>4</a:t>
             </a:r>
             <a:endParaRPr lang="en-US" sz="4800" dirty="0"/>
           </a:p>
@@ -3521,7 +3521,7 @@
                   <a:schemeClr val="tx1"/>
                 </a:solidFill>
               </a:rPr>
-              <a:t>Actual effort with AI</a:t>
+              <a:t>Actual with AI</a:t>
             </a:r>
             <a:endParaRPr lang="en-US" sz="1800" dirty="0"/>
           </a:p>
@@ -3557,7 +3557,7 @@
                   <a:schemeClr val="tx2"/>
                 </a:solidFill>
               </a:rPr>
-              <a:t>[__] sprints, [__] people</a:t>
+              <a:t>sprints, in one PI</a:t>
             </a:r>
             <a:endParaRPr lang="en-US" sz="1400" dirty="0"/>
           </a:p>
@@ -3615,7 +3615,7 @@
                   <a:schemeClr val="accent1"/>
                 </a:solidFill>
               </a:rPr>
-              <a:t>[__]%</a:t>
+              <a:t>~40%</a:t>
             </a:r>
             <a:endParaRPr lang="en-US" sz="4800" dirty="0"/>
           </a:p>
@@ -3687,7 +3687,7 @@
                   <a:schemeClr val="accent5"/>
                 </a:solidFill>
               </a:rPr>
-              <a:t>(estimate − actual) ÷ estimate</a:t>
+              <a:t>(7 − 4) ÷ 7 sprints</a:t>
             </a:r>
             <a:endParaRPr lang="en-US" sz="1400" dirty="0"/>
           </a:p>
@@ -3942,6 +3942,42 @@
               <a:t>8 architecture and lifecycle diagrams produced alongside the work</a:t>
             </a:r>
             <a:endParaRPr lang="en-US" sz="1500" dirty="0"/>
+          </a:p>
+        </p:txBody>
+      </p:sp>
+      <p:sp>
+        <p:nvSpPr>
+          <p:cNvPr id="22" name="effort-assumptions"/>
+          <p:cNvSpPr txBox="1"/>
+          <p:nvPr/>
+        </p:nvSpPr>
+        <p:spPr>
+          <a:xfrm>
+            <a:off x="548640" y="5989320"/>
+            <a:ext cx="11094415" cy="457200"/>
+          </a:xfrm>
+          <a:prstGeom prst="rect">
+            <a:avLst/>
+          </a:prstGeom>
+          <a:noFill/>
+          <a:ln/>
+        </p:spPr>
+        <p:txBody>
+          <a:bodyPr wrap="square" lIns="0" tIns="0" rIns="0" bIns="0" rtlCol="0" anchor="t"/>
+          <a:lstStyle/>
+          <a:p>
+            <a:pPr indent="0" marL="0">
+              <a:buNone/>
+            </a:pPr>
+            <a:r>
+              <a:rPr lang="en-US" sz="1100" i="1" dirty="0">
+                <a:solidFill>
+                  <a:schemeClr val="tx2"/>
+                </a:solidFill>
+              </a:rPr>
+              <a:t>Generic estimate, not a measured baseline: 105 features × (0.5 day discovery + 2 days build + 0.5 day parity testing) + 25 days documentation ≈ 340 person-days. Team of 5, 2-week sprints = 50 person-days per sprint; 1 PI = 4 development sprints.</a:t>
+            </a:r>
+            <a:endParaRPr lang="en-US" sz="1100" dirty="0"/>
           </a:p>
         </p:txBody>
       </p:sp>

</xml_diff>

<commit_message>
Update jury pitch: effort for a team of 2 and animated objectives slide
Co-Authored-By: Claude Opus 5.5 <noreply@anthropic.com>
Claude-Session: https://claude.ai/code/session_01HdxEbeqqWM97gKbcNqpjAq
</commit_message>
<xml_diff>
--- a/erm-migration/docs/ERM-Migration-Jury-Pitch.pptx
+++ b/erm-migration/docs/ERM-Migration-Jury-Pitch.pptx
@@ -12,9 +12,10 @@
     <p:sldId id="260" r:id="rId6"/>
     <p:sldId id="261" r:id="rId7"/>
     <p:sldId id="262" r:id="rId8"/>
+    <p:sldId id="263" r:id="rId9"/>
   </p:sldIdLst>
   <p:notesMasterIdLst>
-    <p:notesMasterId r:id="rId9"/>
+    <p:notesMasterId r:id="rId10"/>
   </p:notesMasterIdLst>
   <p:sldSz cx="12192000" cy="6858000"/>
   <p:notesSz cx="6858000" cy="12192000"/>
@@ -113,27 +114,28 @@
   <p:extLst>
     <p:ext uri="{521415D9-36F7-43E2-AB2F-B90AF26B5E84}">
       <p14:sectionLst xmlns:p14="http://schemas.microsoft.com/office/powerpoint/2010/main">
-        <p14:section name="Pitch" id="{f9d7b542-1bb9-af64-8da4-219e9bdf59af}">
+        <p14:section name="Pitch" id="{33ca7ca2-bc01-2ed2-fb6a-97406a12c4f4}">
           <p14:sldIdLst>
             <p14:sldId id="256"/>
           </p14:sldIdLst>
         </p14:section>
-        <p14:section name="Problem and method" id="{e840d901-d90f-1a05-676e-e0f15e83fea3}">
+        <p14:section name="Problem and method" id="{de6ffe95-0ce3-e50b-5752-1e7c262878da}">
           <p14:sldIdLst>
             <p14:sldId id="257"/>
             <p14:sldId id="258"/>
           </p14:sldIdLst>
         </p14:section>
-        <p14:section name="Impact" id="{28961b5f-3114-2e9c-40db-c9292b2ea9fd}">
+        <p14:section name="Impact" id="{42ae12a4-0680-d832-7970-7c67feddbf72}">
           <p14:sldIdLst>
             <p14:sldId id="259"/>
             <p14:sldId id="260"/>
             <p14:sldId id="261"/>
+            <p14:sldId id="262"/>
           </p14:sldIdLst>
         </p14:section>
-        <p14:section name="Reuse" id="{0078f65d-e0ff-5fdd-4c8b-1a5aa75b7031}">
+        <p14:section name="Reuse" id="{e8beae28-e3cb-39fb-e193-be7fb727433d}">
           <p14:sldIdLst>
-            <p14:sldId id="262"/>
+            <p14:sldId id="263"/>
           </p14:sldIdLst>
         </p14:section>
       </p14:sectionLst>
@@ -892,7 +894,7 @@
           <a:p>
             <a:r>
               <a:rPr lang="en-US" dirty="0"/>
-              <a:t>These are generic industry-style estimates, not our measured baseline; say so if asked. A manual migration of 105 features typically needs about half a day per feature to reverse-engineer it, two days to rebuild it and half a day to test parity, plus about 25 days to document the app: roughly 340 person-days, or about 7 sprints for a team of 5. We did it in one PI, 4 development sprints, which is about 40% less effort. Then say where the time went: discovery was the biggest saving, because the AI catalogued 105 features straight from the Slate exports with no documentation to read; gap analysis, because every feature was checked against the packed React code; and documentation, because the diagrams were produced alongside the work instead of afterwards.</a:t>
+              <a:t>These are generic industry-style estimates, not our measured baseline; say so if asked. A manual migration of 105 features typically needs about half a day per feature to reverse-engineer it, two days to rebuild it and half a day to test parity, plus about 25 days to document the app: roughly 340 person-days, or about 17 sprints for our team of 2 developers, more than 4 PIs. We did it in one PI, 4 development sprints, which is about 76% less effort. Then say where the time went: discovery was the biggest saving, because the AI catalogued 105 features straight from the Slate exports with no documentation to read; gap analysis, because every feature was checked against the packed React code; and documentation, because the diagrams were produced alongside the work instead of afterwards.</a:t>
             </a:r>
             <a:endParaRPr lang="en-US" dirty="0"/>
           </a:p>
@@ -1068,7 +1070,7 @@
           <a:p>
             <a:r>
               <a:rPr lang="en-US" dirty="0"/>
-              <a:t>Close on reuse. This was a team effort across business, data and security, backend and frontend; name the teams. The method needs only the legacy export, the new codebase and an AI model, so it carries over to other Slate apps and to other legacy tools. The pieces are ready: pack-project.ts, the comparison document layout and the diagram formats. End with the five-word playbook and invite questions.</a:t>
+              <a:t>This slide ties the work to the 2026 objectives; each row appears in turn. Leverage AI to solve business problems: this is an AI-assisted migration of a complex, undocumented app, and the method is now a playbook. Deliver on time, cost and quality: two developers did it in one PI, about 76% less effort than a generic manual estimate. Manage our risks: the AI review caught 7 security and data-integrity issues, the restricted-view access model was kept, and we removed a dependency on Slate configuration by moving to standard React and OSDK code. Digital Design Authority: the app now has 8 architecture and lifecycle diagrams and a documented feature catalogue. Digital acumen and competencies: pack-project.ts and the playbook let other teams repeat this. Customer satisfaction: ERM users get 5 enhancements the old app did not have.</a:t>
             </a:r>
             <a:endParaRPr lang="en-US" dirty="0"/>
           </a:p>
@@ -1092,6 +1094,94 @@
             <a:fld id="{F7021451-1387-4CA6-816F-3879F97B5CBC}" type="slidenum">
               <a:rPr lang="en-US"/>
               <a:t>7</a:t>
+            </a:fld>
+            <a:endParaRPr lang="en-US"/>
+          </a:p>
+        </p:txBody>
+      </p:sp>
+    </p:spTree>
+    <p:extLst>
+      <p:ext uri="{BB962C8B-B14F-4D97-AF65-F5344CB8AC3E}">
+        <p14:creationId xmlns:p14="http://schemas.microsoft.com/office/powerpoint/2010/main" val="1024086991"/>
+      </p:ext>
+    </p:extLst>
+  </p:cSld>
+  <p:clrMapOvr>
+    <a:masterClrMapping/>
+  </p:clrMapOvr>
+</p:notes>
+</file>
+
+<file path=ppt/notesSlides/notesSlide8.xml><?xml version="1.0" encoding="utf-8"?>
+<p:notes xmlns:a="http://schemas.openxmlformats.org/drawingml/2006/main" xmlns:r="http://schemas.openxmlformats.org/officeDocument/2006/relationships" xmlns:p="http://schemas.openxmlformats.org/presentationml/2006/main">
+  <p:cSld>
+    <p:spTree>
+      <p:nvGrpSpPr>
+        <p:cNvPr id="1" name=""/>
+        <p:cNvGrpSpPr/>
+        <p:nvPr/>
+      </p:nvGrpSpPr>
+      <p:grpSpPr>
+        <a:xfrm>
+          <a:off x="0" y="0"/>
+          <a:ext cx="0" cy="0"/>
+          <a:chOff x="0" y="0"/>
+          <a:chExt cx="0" cy="0"/>
+        </a:xfrm>
+      </p:grpSpPr>
+      <p:sp>
+        <p:nvSpPr>
+          <p:cNvPr id="2" name="Slide Image Placeholder 1"/>
+          <p:cNvSpPr>
+            <a:spLocks noGrp="1" noRot="1" noChangeAspect="1"/>
+          </p:cNvSpPr>
+          <p:nvPr>
+            <p:ph type="sldImg"/>
+          </p:nvPr>
+        </p:nvSpPr>
+        <p:spPr/>
+      </p:sp>
+      <p:sp>
+        <p:nvSpPr>
+          <p:cNvPr id="3" name="Notes Placeholder 2"/>
+          <p:cNvSpPr>
+            <a:spLocks noGrp="1"/>
+          </p:cNvSpPr>
+          <p:nvPr>
+            <p:ph type="body" idx="1"/>
+          </p:nvPr>
+        </p:nvSpPr>
+        <p:spPr/>
+        <p:txBody>
+          <a:bodyPr/>
+          <a:lstStyle/>
+          <a:p>
+            <a:r>
+              <a:rPr lang="en-US" dirty="0"/>
+              <a:t>Close on reuse. This was a team effort across business, data and security, backend and frontend; name the teams. The method needs only the legacy export, the new codebase and an AI model, so it carries over to other Slate apps and to other legacy tools. The pieces are ready: pack-project.ts, the comparison document layout and the diagram formats. End with the five-word playbook and invite questions.</a:t>
+            </a:r>
+            <a:endParaRPr lang="en-US" dirty="0"/>
+          </a:p>
+        </p:txBody>
+      </p:sp>
+      <p:sp>
+        <p:nvSpPr>
+          <p:cNvPr id="4" name="Slide Number Placeholder 3"/>
+          <p:cNvSpPr>
+            <a:spLocks noGrp="1"/>
+          </p:cNvSpPr>
+          <p:nvPr>
+            <p:ph type="sldNum" sz="quarter" idx="10"/>
+          </p:nvPr>
+        </p:nvSpPr>
+        <p:spPr/>
+        <p:txBody>
+          <a:bodyPr/>
+          <a:lstStyle/>
+          <a:p>
+            <a:fld id="{F7021451-1387-4CA6-816F-3879F97B5CBC}" type="slidenum">
+              <a:rPr lang="en-US"/>
+              <a:t>8</a:t>
             </a:fld>
             <a:endParaRPr lang="en-US"/>
           </a:p>
@@ -3297,7 +3387,7 @@
                   <a:schemeClr val="tx1"/>
                 </a:solidFill>
               </a:rPr>
-              <a:t>Effort saved: about 40% versus manual</a:t>
+              <a:t>Effort saved: about 76% versus manual</a:t>
             </a:r>
             <a:endParaRPr lang="en-US" sz="3600" dirty="0"/>
           </a:p>
@@ -3355,7 +3445,7 @@
                   <a:schemeClr val="tx1"/>
                 </a:solidFill>
               </a:rPr>
-              <a:t>~7</a:t>
+              <a:t>~17</a:t>
             </a:r>
             <a:endParaRPr lang="en-US" sz="4800" dirty="0"/>
           </a:p>
@@ -3615,7 +3705,7 @@
                   <a:schemeClr val="accent1"/>
                 </a:solidFill>
               </a:rPr>
-              <a:t>~40%</a:t>
+              <a:t>~76%</a:t>
             </a:r>
             <a:endParaRPr lang="en-US" sz="4800" dirty="0"/>
           </a:p>
@@ -3687,7 +3777,7 @@
                   <a:schemeClr val="accent5"/>
                 </a:solidFill>
               </a:rPr>
-              <a:t>(7 − 4) ÷ 7 sprints</a:t>
+              <a:t>(17 − 4) ÷ 17 sprints</a:t>
             </a:r>
             <a:endParaRPr lang="en-US" sz="1400" dirty="0"/>
           </a:p>
@@ -3975,7 +4065,7 @@
                   <a:schemeClr val="tx2"/>
                 </a:solidFill>
               </a:rPr>
-              <a:t>Generic estimate, not a measured baseline: 105 features × (0.5 day discovery + 2 days build + 0.5 day parity testing) + 25 days documentation ≈ 340 person-days. Team of 5, 2-week sprints = 50 person-days per sprint; 1 PI = 4 development sprints.</a:t>
+              <a:t>Generic estimate, not a measured baseline: 105 features × (0.5 day discovery + 2 days build + 0.5 day parity testing) + 25 days documentation ≈ 340 person-days. Team of 2 developers, 2-week sprints = 20 person-days per sprint; 1 PI = 4 development sprints.</a:t>
             </a:r>
             <a:endParaRPr lang="en-US" sz="1100" dirty="0"/>
           </a:p>
@@ -4431,6 +4521,2252 @@
 <file path=ppt/slides/slide7.xml><?xml version="1.0" encoding="utf-8"?>
 <p:sld xmlns:a="http://schemas.openxmlformats.org/drawingml/2006/main" xmlns:r="http://schemas.openxmlformats.org/officeDocument/2006/relationships" xmlns:p="http://schemas.openxmlformats.org/presentationml/2006/main">
   <p:cSld name="Slide 7">
+    <p:spTree>
+      <p:nvGrpSpPr>
+        <p:cNvPr id="1" name=""/>
+        <p:cNvGrpSpPr/>
+        <p:nvPr/>
+      </p:nvGrpSpPr>
+      <p:grpSpPr>
+        <a:xfrm>
+          <a:off x="0" y="0"/>
+          <a:ext cx="0" cy="0"/>
+          <a:chOff x="0" y="0"/>
+          <a:chExt cx="0" cy="0"/>
+        </a:xfrm>
+      </p:grpSpPr>
+      <p:sp>
+        <p:nvSpPr>
+          <p:cNvPr id="2" name="Text 0"/>
+          <p:cNvSpPr/>
+          <p:nvPr>
+            <p:ph idx="100" type="title" hasCustomPrompt="1"/>
+          </p:nvPr>
+        </p:nvSpPr>
+        <p:spPr>
+          <a:xfrm>
+            <a:off x="548640" y="502920"/>
+            <a:ext cx="11094415" cy="822960"/>
+          </a:xfrm>
+          <a:prstGeom prst="rect">
+            <a:avLst/>
+          </a:prstGeom>
+          <a:noFill/>
+          <a:ln/>
+        </p:spPr>
+        <p:txBody>
+          <a:bodyPr wrap="square" lIns="0" tIns="0" rIns="0" bIns="0" rtlCol="0" anchor="t"/>
+          <a:lstStyle/>
+          <a:p>
+            <a:pPr algn="l" indent="0" marL="0">
+              <a:buNone/>
+            </a:pPr>
+            <a:r>
+              <a:rPr lang="en-US" sz="3600" b="1" dirty="0">
+                <a:solidFill>
+                  <a:schemeClr val="tx1"/>
+                </a:solidFill>
+              </a:rPr>
+              <a:t>Our contribution to the 2026 objectives</a:t>
+            </a:r>
+            <a:endParaRPr lang="en-US" sz="3600" dirty="0"/>
+          </a:p>
+        </p:txBody>
+      </p:sp>
+      <p:sp>
+        <p:nvSpPr>
+          <p:cNvPr id="3" name="objhead-left"/>
+          <p:cNvSpPr txBox="1"/>
+          <p:nvPr/>
+        </p:nvSpPr>
+        <p:spPr>
+          <a:xfrm>
+            <a:off x="548640" y="1280160"/>
+            <a:ext cx="4617720" cy="274320"/>
+          </a:xfrm>
+          <a:prstGeom prst="rect">
+            <a:avLst/>
+          </a:prstGeom>
+          <a:noFill/>
+          <a:ln/>
+        </p:spPr>
+        <p:txBody>
+          <a:bodyPr wrap="square" lIns="0" tIns="0" rIns="0" bIns="0" rtlCol="0" anchor="t"/>
+          <a:lstStyle/>
+          <a:p>
+            <a:pPr indent="0" marL="0">
+              <a:buNone/>
+            </a:pPr>
+            <a:r>
+              <a:rPr lang="en-US" sz="1100" b="1" spc="100" kern="0" dirty="0">
+                <a:solidFill>
+                  <a:schemeClr val="tx2"/>
+                </a:solidFill>
+              </a:rPr>
+              <a:t>2026 OBJECTIVE</a:t>
+            </a:r>
+            <a:endParaRPr lang="en-US" sz="1100" dirty="0"/>
+          </a:p>
+        </p:txBody>
+      </p:sp>
+      <p:sp>
+        <p:nvSpPr>
+          <p:cNvPr id="4" name="objhead-right"/>
+          <p:cNvSpPr txBox="1"/>
+          <p:nvPr/>
+        </p:nvSpPr>
+        <p:spPr>
+          <a:xfrm>
+            <a:off x="5577840" y="1280160"/>
+            <a:ext cx="6062472" cy="274320"/>
+          </a:xfrm>
+          <a:prstGeom prst="rect">
+            <a:avLst/>
+          </a:prstGeom>
+          <a:noFill/>
+          <a:ln/>
+        </p:spPr>
+        <p:txBody>
+          <a:bodyPr wrap="square" lIns="0" tIns="0" rIns="0" bIns="0" rtlCol="0" anchor="t"/>
+          <a:lstStyle/>
+          <a:p>
+            <a:pPr indent="0" marL="0">
+              <a:buNone/>
+            </a:pPr>
+            <a:r>
+              <a:rPr lang="en-US" sz="1100" b="1" spc="100" kern="0" dirty="0">
+                <a:solidFill>
+                  <a:schemeClr val="tx2"/>
+                </a:solidFill>
+              </a:rPr>
+              <a:t>WHAT WE CONTRIBUTED</a:t>
+            </a:r>
+            <a:endParaRPr lang="en-US" sz="1100" dirty="0"/>
+          </a:p>
+        </p:txBody>
+      </p:sp>
+      <p:sp>
+        <p:nvSpPr>
+          <p:cNvPr id="5" name="objrow-0-objbox"/>
+          <p:cNvSpPr/>
+          <p:nvPr/>
+        </p:nvSpPr>
+        <p:spPr>
+          <a:xfrm>
+            <a:off x="548640" y="1645920"/>
+            <a:ext cx="4617720" cy="676656"/>
+          </a:xfrm>
+          <a:prstGeom prst="roundRect">
+            <a:avLst>
+              <a:gd name="adj" fmla="val 16216"/>
+            </a:avLst>
+          </a:prstGeom>
+          <a:solidFill>
+            <a:schemeClr val="tx1"/>
+          </a:solidFill>
+          <a:ln/>
+        </p:spPr>
+      </p:sp>
+      <p:sp>
+        <p:nvSpPr>
+          <p:cNvPr id="6" name="objrow-0-objtext"/>
+          <p:cNvSpPr txBox="1"/>
+          <p:nvPr/>
+        </p:nvSpPr>
+        <p:spPr>
+          <a:xfrm>
+            <a:off x="731520" y="1719072"/>
+            <a:ext cx="4297680" cy="530352"/>
+          </a:xfrm>
+          <a:prstGeom prst="rect">
+            <a:avLst/>
+          </a:prstGeom>
+          <a:noFill/>
+          <a:ln/>
+        </p:spPr>
+        <p:txBody>
+          <a:bodyPr wrap="square" lIns="0" tIns="0" rIns="0" bIns="0" rtlCol="0" anchor="ctr"/>
+          <a:lstStyle/>
+          <a:p>
+            <a:pPr indent="0" marL="0">
+              <a:buNone/>
+            </a:pPr>
+            <a:r>
+              <a:rPr lang="en-US" sz="1300" b="1" dirty="0">
+                <a:solidFill>
+                  <a:schemeClr val="bg1"/>
+                </a:solidFill>
+              </a:rPr>
+              <a:t>Leverage AI to solve business problems</a:t>
+            </a:r>
+            <a:endParaRPr lang="en-US" sz="1300" dirty="0"/>
+          </a:p>
+          <a:p>
+            <a:pPr indent="0" marL="0">
+              <a:buNone/>
+            </a:pPr>
+            <a:r>
+              <a:rPr lang="en-US" sz="1100" dirty="0">
+                <a:solidFill>
+                  <a:schemeClr val="accent5"/>
+                </a:solidFill>
+              </a:rPr>
+              <a:t>Digital: democratise AI · India TFO</a:t>
+            </a:r>
+            <a:endParaRPr lang="en-US" sz="1300" dirty="0"/>
+          </a:p>
+        </p:txBody>
+      </p:sp>
+      <p:sp>
+        <p:nvSpPr>
+          <p:cNvPr id="7" name="objrow-0-arrow"/>
+          <p:cNvSpPr/>
+          <p:nvPr/>
+        </p:nvSpPr>
+        <p:spPr>
+          <a:xfrm>
+            <a:off x="5248656" y="1856232"/>
+            <a:ext cx="237744" cy="256032"/>
+          </a:xfrm>
+          <a:prstGeom prst="rightArrow">
+            <a:avLst/>
+          </a:prstGeom>
+          <a:solidFill>
+            <a:schemeClr val="accent1"/>
+          </a:solidFill>
+          <a:ln w="12700">
+            <a:solidFill>
+              <a:schemeClr val="accent1"/>
+            </a:solidFill>
+            <a:prstDash val="solid"/>
+          </a:ln>
+        </p:spPr>
+      </p:sp>
+      <p:sp>
+        <p:nvSpPr>
+          <p:cNvPr id="8" name="objrow-0-contribbox"/>
+          <p:cNvSpPr/>
+          <p:nvPr/>
+        </p:nvSpPr>
+        <p:spPr>
+          <a:xfrm>
+            <a:off x="5577840" y="1645920"/>
+            <a:ext cx="6062472" cy="676656"/>
+          </a:xfrm>
+          <a:prstGeom prst="roundRect">
+            <a:avLst>
+              <a:gd name="adj" fmla="val 16216"/>
+            </a:avLst>
+          </a:prstGeom>
+          <a:solidFill>
+            <a:schemeClr val="bg2"/>
+          </a:solidFill>
+          <a:ln/>
+        </p:spPr>
+      </p:sp>
+      <p:sp>
+        <p:nvSpPr>
+          <p:cNvPr id="9" name="objrow-0-contribtext"/>
+          <p:cNvSpPr txBox="1"/>
+          <p:nvPr/>
+        </p:nvSpPr>
+        <p:spPr>
+          <a:xfrm>
+            <a:off x="5760720" y="1719072"/>
+            <a:ext cx="5696712" cy="530352"/>
+          </a:xfrm>
+          <a:prstGeom prst="rect">
+            <a:avLst/>
+          </a:prstGeom>
+          <a:noFill/>
+          <a:ln/>
+        </p:spPr>
+        <p:txBody>
+          <a:bodyPr wrap="square" lIns="0" tIns="0" rIns="0" bIns="0" rtlCol="0" anchor="ctr"/>
+          <a:lstStyle/>
+          <a:p>
+            <a:pPr indent="0" marL="0">
+              <a:buNone/>
+            </a:pPr>
+            <a:r>
+              <a:rPr lang="en-US" sz="1400" dirty="0">
+                <a:solidFill>
+                  <a:schemeClr val="tx1"/>
+                </a:solidFill>
+              </a:rPr>
+              <a:t>AI-assisted migration of an undocumented, multi-module app, packaged as a reusable playbook</a:t>
+            </a:r>
+            <a:endParaRPr lang="en-US" sz="1400" dirty="0"/>
+          </a:p>
+        </p:txBody>
+      </p:sp>
+      <p:sp>
+        <p:nvSpPr>
+          <p:cNvPr id="10" name="objrow-1-objbox"/>
+          <p:cNvSpPr/>
+          <p:nvPr/>
+        </p:nvSpPr>
+        <p:spPr>
+          <a:xfrm>
+            <a:off x="548640" y="2432304"/>
+            <a:ext cx="4617720" cy="676656"/>
+          </a:xfrm>
+          <a:prstGeom prst="roundRect">
+            <a:avLst>
+              <a:gd name="adj" fmla="val 16216"/>
+            </a:avLst>
+          </a:prstGeom>
+          <a:solidFill>
+            <a:schemeClr val="tx1"/>
+          </a:solidFill>
+          <a:ln/>
+        </p:spPr>
+      </p:sp>
+      <p:sp>
+        <p:nvSpPr>
+          <p:cNvPr id="11" name="objrow-1-objtext"/>
+          <p:cNvSpPr txBox="1"/>
+          <p:nvPr/>
+        </p:nvSpPr>
+        <p:spPr>
+          <a:xfrm>
+            <a:off x="731520" y="2505456"/>
+            <a:ext cx="4297680" cy="530352"/>
+          </a:xfrm>
+          <a:prstGeom prst="rect">
+            <a:avLst/>
+          </a:prstGeom>
+          <a:noFill/>
+          <a:ln/>
+        </p:spPr>
+        <p:txBody>
+          <a:bodyPr wrap="square" lIns="0" tIns="0" rIns="0" bIns="0" rtlCol="0" anchor="ctr"/>
+          <a:lstStyle/>
+          <a:p>
+            <a:pPr indent="0" marL="0">
+              <a:buNone/>
+            </a:pPr>
+            <a:r>
+              <a:rPr lang="en-US" sz="1300" b="1" dirty="0">
+                <a:solidFill>
+                  <a:schemeClr val="bg1"/>
+                </a:solidFill>
+              </a:rPr>
+              <a:t>Deliver on time, on cost, on quality</a:t>
+            </a:r>
+            <a:endParaRPr lang="en-US" sz="1300" dirty="0"/>
+          </a:p>
+          <a:p>
+            <a:pPr indent="0" marL="0">
+              <a:buNone/>
+            </a:pPr>
+            <a:r>
+              <a:rPr lang="en-US" sz="1100" dirty="0">
+                <a:solidFill>
+                  <a:schemeClr val="accent5"/>
+                </a:solidFill>
+              </a:rPr>
+              <a:t>Digital: optimise our resources · Company: financial</a:t>
+            </a:r>
+            <a:endParaRPr lang="en-US" sz="1300" dirty="0"/>
+          </a:p>
+        </p:txBody>
+      </p:sp>
+      <p:sp>
+        <p:nvSpPr>
+          <p:cNvPr id="12" name="objrow-1-arrow"/>
+          <p:cNvSpPr/>
+          <p:nvPr/>
+        </p:nvSpPr>
+        <p:spPr>
+          <a:xfrm>
+            <a:off x="5248656" y="2642616"/>
+            <a:ext cx="237744" cy="256032"/>
+          </a:xfrm>
+          <a:prstGeom prst="rightArrow">
+            <a:avLst/>
+          </a:prstGeom>
+          <a:solidFill>
+            <a:schemeClr val="accent1"/>
+          </a:solidFill>
+          <a:ln w="12700">
+            <a:solidFill>
+              <a:schemeClr val="accent1"/>
+            </a:solidFill>
+            <a:prstDash val="solid"/>
+          </a:ln>
+        </p:spPr>
+      </p:sp>
+      <p:sp>
+        <p:nvSpPr>
+          <p:cNvPr id="13" name="objrow-1-contribbox"/>
+          <p:cNvSpPr/>
+          <p:nvPr/>
+        </p:nvSpPr>
+        <p:spPr>
+          <a:xfrm>
+            <a:off x="5577840" y="2432304"/>
+            <a:ext cx="6062472" cy="676656"/>
+          </a:xfrm>
+          <a:prstGeom prst="roundRect">
+            <a:avLst>
+              <a:gd name="adj" fmla="val 16216"/>
+            </a:avLst>
+          </a:prstGeom>
+          <a:solidFill>
+            <a:schemeClr val="bg2"/>
+          </a:solidFill>
+          <a:ln/>
+        </p:spPr>
+      </p:sp>
+      <p:sp>
+        <p:nvSpPr>
+          <p:cNvPr id="14" name="objrow-1-contribtext"/>
+          <p:cNvSpPr txBox="1"/>
+          <p:nvPr/>
+        </p:nvSpPr>
+        <p:spPr>
+          <a:xfrm>
+            <a:off x="5760720" y="2505456"/>
+            <a:ext cx="5696712" cy="530352"/>
+          </a:xfrm>
+          <a:prstGeom prst="rect">
+            <a:avLst/>
+          </a:prstGeom>
+          <a:noFill/>
+          <a:ln/>
+        </p:spPr>
+        <p:txBody>
+          <a:bodyPr wrap="square" lIns="0" tIns="0" rIns="0" bIns="0" rtlCol="0" anchor="ctr"/>
+          <a:lstStyle/>
+          <a:p>
+            <a:pPr indent="0" marL="0">
+              <a:buNone/>
+            </a:pPr>
+            <a:r>
+              <a:rPr lang="en-US" sz="1400" dirty="0">
+                <a:solidFill>
+                  <a:schemeClr val="tx1"/>
+                </a:solidFill>
+              </a:rPr>
+              <a:t>2 developers, 1 PI, about 76% less effort than a manual estimate</a:t>
+            </a:r>
+            <a:endParaRPr lang="en-US" sz="1400" dirty="0"/>
+          </a:p>
+        </p:txBody>
+      </p:sp>
+      <p:sp>
+        <p:nvSpPr>
+          <p:cNvPr id="15" name="objrow-2-objbox"/>
+          <p:cNvSpPr/>
+          <p:nvPr/>
+        </p:nvSpPr>
+        <p:spPr>
+          <a:xfrm>
+            <a:off x="548640" y="3218688"/>
+            <a:ext cx="4617720" cy="676656"/>
+          </a:xfrm>
+          <a:prstGeom prst="roundRect">
+            <a:avLst>
+              <a:gd name="adj" fmla="val 16216"/>
+            </a:avLst>
+          </a:prstGeom>
+          <a:solidFill>
+            <a:schemeClr val="tx1"/>
+          </a:solidFill>
+          <a:ln/>
+        </p:spPr>
+      </p:sp>
+      <p:sp>
+        <p:nvSpPr>
+          <p:cNvPr id="16" name="objrow-2-objtext"/>
+          <p:cNvSpPr txBox="1"/>
+          <p:nvPr/>
+        </p:nvSpPr>
+        <p:spPr>
+          <a:xfrm>
+            <a:off x="731520" y="3291840"/>
+            <a:ext cx="4297680" cy="530352"/>
+          </a:xfrm>
+          <a:prstGeom prst="rect">
+            <a:avLst/>
+          </a:prstGeom>
+          <a:noFill/>
+          <a:ln/>
+        </p:spPr>
+        <p:txBody>
+          <a:bodyPr wrap="square" lIns="0" tIns="0" rIns="0" bIns="0" rtlCol="0" anchor="ctr"/>
+          <a:lstStyle/>
+          <a:p>
+            <a:pPr indent="0" marL="0">
+              <a:buNone/>
+            </a:pPr>
+            <a:r>
+              <a:rPr lang="en-US" sz="1300" b="1" dirty="0">
+                <a:solidFill>
+                  <a:schemeClr val="bg1"/>
+                </a:solidFill>
+              </a:rPr>
+              <a:t>Manage our risks</a:t>
+            </a:r>
+            <a:endParaRPr lang="en-US" sz="1300" dirty="0"/>
+          </a:p>
+          <a:p>
+            <a:pPr indent="0" marL="0">
+              <a:buNone/>
+            </a:pPr>
+            <a:r>
+              <a:rPr lang="en-US" sz="1100" dirty="0">
+                <a:solidFill>
+                  <a:schemeClr val="accent5"/>
+                </a:solidFill>
+              </a:rPr>
+              <a:t>Digital: cybersecurity, compliance, dependencies</a:t>
+            </a:r>
+            <a:endParaRPr lang="en-US" sz="1300" dirty="0"/>
+          </a:p>
+        </p:txBody>
+      </p:sp>
+      <p:sp>
+        <p:nvSpPr>
+          <p:cNvPr id="17" name="objrow-2-arrow"/>
+          <p:cNvSpPr/>
+          <p:nvPr/>
+        </p:nvSpPr>
+        <p:spPr>
+          <a:xfrm>
+            <a:off x="5248656" y="3429000"/>
+            <a:ext cx="237744" cy="256032"/>
+          </a:xfrm>
+          <a:prstGeom prst="rightArrow">
+            <a:avLst/>
+          </a:prstGeom>
+          <a:solidFill>
+            <a:schemeClr val="accent1"/>
+          </a:solidFill>
+          <a:ln w="12700">
+            <a:solidFill>
+              <a:schemeClr val="accent1"/>
+            </a:solidFill>
+            <a:prstDash val="solid"/>
+          </a:ln>
+        </p:spPr>
+      </p:sp>
+      <p:sp>
+        <p:nvSpPr>
+          <p:cNvPr id="18" name="objrow-2-contribbox"/>
+          <p:cNvSpPr/>
+          <p:nvPr/>
+        </p:nvSpPr>
+        <p:spPr>
+          <a:xfrm>
+            <a:off x="5577840" y="3218688"/>
+            <a:ext cx="6062472" cy="676656"/>
+          </a:xfrm>
+          <a:prstGeom prst="roundRect">
+            <a:avLst>
+              <a:gd name="adj" fmla="val 16216"/>
+            </a:avLst>
+          </a:prstGeom>
+          <a:solidFill>
+            <a:schemeClr val="bg2"/>
+          </a:solidFill>
+          <a:ln/>
+        </p:spPr>
+      </p:sp>
+      <p:sp>
+        <p:nvSpPr>
+          <p:cNvPr id="19" name="objrow-2-contribtext"/>
+          <p:cNvSpPr txBox="1"/>
+          <p:nvPr/>
+        </p:nvSpPr>
+        <p:spPr>
+          <a:xfrm>
+            <a:off x="5760720" y="3291840"/>
+            <a:ext cx="5696712" cy="530352"/>
+          </a:xfrm>
+          <a:prstGeom prst="rect">
+            <a:avLst/>
+          </a:prstGeom>
+          <a:noFill/>
+          <a:ln/>
+        </p:spPr>
+        <p:txBody>
+          <a:bodyPr wrap="square" lIns="0" tIns="0" rIns="0" bIns="0" rtlCol="0" anchor="ctr"/>
+          <a:lstStyle/>
+          <a:p>
+            <a:pPr indent="0" marL="0">
+              <a:buNone/>
+            </a:pPr>
+            <a:r>
+              <a:rPr lang="en-US" sz="1400" dirty="0">
+                <a:solidFill>
+                  <a:schemeClr val="tx1"/>
+                </a:solidFill>
+              </a:rPr>
+              <a:t>7 security and data-integrity issues caught in review; restricted views kept; off Slate onto standard React + OSDK</a:t>
+            </a:r>
+            <a:endParaRPr lang="en-US" sz="1400" dirty="0"/>
+          </a:p>
+        </p:txBody>
+      </p:sp>
+      <p:sp>
+        <p:nvSpPr>
+          <p:cNvPr id="20" name="objrow-3-objbox"/>
+          <p:cNvSpPr/>
+          <p:nvPr/>
+        </p:nvSpPr>
+        <p:spPr>
+          <a:xfrm>
+            <a:off x="548640" y="4005072"/>
+            <a:ext cx="4617720" cy="676656"/>
+          </a:xfrm>
+          <a:prstGeom prst="roundRect">
+            <a:avLst>
+              <a:gd name="adj" fmla="val 16216"/>
+            </a:avLst>
+          </a:prstGeom>
+          <a:solidFill>
+            <a:schemeClr val="tx1"/>
+          </a:solidFill>
+          <a:ln/>
+        </p:spPr>
+      </p:sp>
+      <p:sp>
+        <p:nvSpPr>
+          <p:cNvPr id="21" name="objrow-3-objtext"/>
+          <p:cNvSpPr txBox="1"/>
+          <p:nvPr/>
+        </p:nvSpPr>
+        <p:spPr>
+          <a:xfrm>
+            <a:off x="731520" y="4078224"/>
+            <a:ext cx="4297680" cy="530352"/>
+          </a:xfrm>
+          <a:prstGeom prst="rect">
+            <a:avLst/>
+          </a:prstGeom>
+          <a:noFill/>
+          <a:ln/>
+        </p:spPr>
+        <p:txBody>
+          <a:bodyPr wrap="square" lIns="0" tIns="0" rIns="0" bIns="0" rtlCol="0" anchor="ctr"/>
+          <a:lstStyle/>
+          <a:p>
+            <a:pPr indent="0" marL="0">
+              <a:buNone/>
+            </a:pPr>
+            <a:r>
+              <a:rPr lang="en-US" sz="1300" b="1" dirty="0">
+                <a:solidFill>
+                  <a:schemeClr val="bg1"/>
+                </a:solidFill>
+              </a:rPr>
+              <a:t>Reinforce the Digital Design Authority</a:t>
+            </a:r>
+            <a:endParaRPr lang="en-US" sz="1300" dirty="0"/>
+          </a:p>
+          <a:p>
+            <a:pPr indent="0" marL="0">
+              <a:buNone/>
+            </a:pPr>
+            <a:r>
+              <a:rPr lang="en-US" sz="1100" dirty="0">
+                <a:solidFill>
+                  <a:schemeClr val="accent5"/>
+                </a:solidFill>
+              </a:rPr>
+              <a:t>Digital: enable our future</a:t>
+            </a:r>
+            <a:endParaRPr lang="en-US" sz="1300" dirty="0"/>
+          </a:p>
+        </p:txBody>
+      </p:sp>
+      <p:sp>
+        <p:nvSpPr>
+          <p:cNvPr id="22" name="objrow-3-arrow"/>
+          <p:cNvSpPr/>
+          <p:nvPr/>
+        </p:nvSpPr>
+        <p:spPr>
+          <a:xfrm>
+            <a:off x="5248656" y="4215384"/>
+            <a:ext cx="237744" cy="256032"/>
+          </a:xfrm>
+          <a:prstGeom prst="rightArrow">
+            <a:avLst/>
+          </a:prstGeom>
+          <a:solidFill>
+            <a:schemeClr val="accent1"/>
+          </a:solidFill>
+          <a:ln w="12700">
+            <a:solidFill>
+              <a:schemeClr val="accent1"/>
+            </a:solidFill>
+            <a:prstDash val="solid"/>
+          </a:ln>
+        </p:spPr>
+      </p:sp>
+      <p:sp>
+        <p:nvSpPr>
+          <p:cNvPr id="23" name="objrow-3-contribbox"/>
+          <p:cNvSpPr/>
+          <p:nvPr/>
+        </p:nvSpPr>
+        <p:spPr>
+          <a:xfrm>
+            <a:off x="5577840" y="4005072"/>
+            <a:ext cx="6062472" cy="676656"/>
+          </a:xfrm>
+          <a:prstGeom prst="roundRect">
+            <a:avLst>
+              <a:gd name="adj" fmla="val 16216"/>
+            </a:avLst>
+          </a:prstGeom>
+          <a:solidFill>
+            <a:schemeClr val="bg2"/>
+          </a:solidFill>
+          <a:ln/>
+        </p:spPr>
+      </p:sp>
+      <p:sp>
+        <p:nvSpPr>
+          <p:cNvPr id="24" name="objrow-3-contribtext"/>
+          <p:cNvSpPr txBox="1"/>
+          <p:nvPr/>
+        </p:nvSpPr>
+        <p:spPr>
+          <a:xfrm>
+            <a:off x="5760720" y="4078224"/>
+            <a:ext cx="5696712" cy="530352"/>
+          </a:xfrm>
+          <a:prstGeom prst="rect">
+            <a:avLst/>
+          </a:prstGeom>
+          <a:noFill/>
+          <a:ln/>
+        </p:spPr>
+        <p:txBody>
+          <a:bodyPr wrap="square" lIns="0" tIns="0" rIns="0" bIns="0" rtlCol="0" anchor="ctr"/>
+          <a:lstStyle/>
+          <a:p>
+            <a:pPr indent="0" marL="0">
+              <a:buNone/>
+            </a:pPr>
+            <a:r>
+              <a:rPr lang="en-US" sz="1400" dirty="0">
+                <a:solidFill>
+                  <a:schemeClr val="tx1"/>
+                </a:solidFill>
+              </a:rPr>
+              <a:t>8 architecture and lifecycle diagrams; 105 features documented where nothing existed</a:t>
+            </a:r>
+            <a:endParaRPr lang="en-US" sz="1400" dirty="0"/>
+          </a:p>
+        </p:txBody>
+      </p:sp>
+      <p:sp>
+        <p:nvSpPr>
+          <p:cNvPr id="25" name="objrow-4-objbox"/>
+          <p:cNvSpPr/>
+          <p:nvPr/>
+        </p:nvSpPr>
+        <p:spPr>
+          <a:xfrm>
+            <a:off x="548640" y="4791456"/>
+            <a:ext cx="4617720" cy="676656"/>
+          </a:xfrm>
+          <a:prstGeom prst="roundRect">
+            <a:avLst>
+              <a:gd name="adj" fmla="val 16216"/>
+            </a:avLst>
+          </a:prstGeom>
+          <a:solidFill>
+            <a:schemeClr val="tx1"/>
+          </a:solidFill>
+          <a:ln/>
+        </p:spPr>
+      </p:sp>
+      <p:sp>
+        <p:nvSpPr>
+          <p:cNvPr id="26" name="objrow-4-objtext"/>
+          <p:cNvSpPr txBox="1"/>
+          <p:nvPr/>
+        </p:nvSpPr>
+        <p:spPr>
+          <a:xfrm>
+            <a:off x="731520" y="4864608"/>
+            <a:ext cx="4297680" cy="530352"/>
+          </a:xfrm>
+          <a:prstGeom prst="rect">
+            <a:avLst/>
+          </a:prstGeom>
+          <a:noFill/>
+          <a:ln/>
+        </p:spPr>
+        <p:txBody>
+          <a:bodyPr wrap="square" lIns="0" tIns="0" rIns="0" bIns="0" rtlCol="0" anchor="ctr"/>
+          <a:lstStyle/>
+          <a:p>
+            <a:pPr indent="0" marL="0">
+              <a:buNone/>
+            </a:pPr>
+            <a:r>
+              <a:rPr lang="en-US" sz="1300" b="1" dirty="0">
+                <a:solidFill>
+                  <a:schemeClr val="bg1"/>
+                </a:solidFill>
+              </a:rPr>
+              <a:t>Grow digital acumen and competencies</a:t>
+            </a:r>
+            <a:endParaRPr lang="en-US" sz="1300" dirty="0"/>
+          </a:p>
+          <a:p>
+            <a:pPr indent="0" marL="0">
+              <a:buNone/>
+            </a:pPr>
+            <a:r>
+              <a:rPr lang="en-US" sz="1100" dirty="0">
+                <a:solidFill>
+                  <a:schemeClr val="accent5"/>
+                </a:solidFill>
+              </a:rPr>
+              <a:t>Digital: develop our people · India TFO</a:t>
+            </a:r>
+            <a:endParaRPr lang="en-US" sz="1300" dirty="0"/>
+          </a:p>
+        </p:txBody>
+      </p:sp>
+      <p:sp>
+        <p:nvSpPr>
+          <p:cNvPr id="27" name="objrow-4-arrow"/>
+          <p:cNvSpPr/>
+          <p:nvPr/>
+        </p:nvSpPr>
+        <p:spPr>
+          <a:xfrm>
+            <a:off x="5248656" y="5001768"/>
+            <a:ext cx="237744" cy="256032"/>
+          </a:xfrm>
+          <a:prstGeom prst="rightArrow">
+            <a:avLst/>
+          </a:prstGeom>
+          <a:solidFill>
+            <a:schemeClr val="accent1"/>
+          </a:solidFill>
+          <a:ln w="12700">
+            <a:solidFill>
+              <a:schemeClr val="accent1"/>
+            </a:solidFill>
+            <a:prstDash val="solid"/>
+          </a:ln>
+        </p:spPr>
+      </p:sp>
+      <p:sp>
+        <p:nvSpPr>
+          <p:cNvPr id="28" name="objrow-4-contribbox"/>
+          <p:cNvSpPr/>
+          <p:nvPr/>
+        </p:nvSpPr>
+        <p:spPr>
+          <a:xfrm>
+            <a:off x="5577840" y="4791456"/>
+            <a:ext cx="6062472" cy="676656"/>
+          </a:xfrm>
+          <a:prstGeom prst="roundRect">
+            <a:avLst>
+              <a:gd name="adj" fmla="val 16216"/>
+            </a:avLst>
+          </a:prstGeom>
+          <a:solidFill>
+            <a:schemeClr val="bg2"/>
+          </a:solidFill>
+          <a:ln/>
+        </p:spPr>
+      </p:sp>
+      <p:sp>
+        <p:nvSpPr>
+          <p:cNvPr id="29" name="objrow-4-contribtext"/>
+          <p:cNvSpPr txBox="1"/>
+          <p:nvPr/>
+        </p:nvSpPr>
+        <p:spPr>
+          <a:xfrm>
+            <a:off x="5760720" y="4864608"/>
+            <a:ext cx="5696712" cy="530352"/>
+          </a:xfrm>
+          <a:prstGeom prst="rect">
+            <a:avLst/>
+          </a:prstGeom>
+          <a:noFill/>
+          <a:ln/>
+        </p:spPr>
+        <p:txBody>
+          <a:bodyPr wrap="square" lIns="0" tIns="0" rIns="0" bIns="0" rtlCol="0" anchor="ctr"/>
+          <a:lstStyle/>
+          <a:p>
+            <a:pPr indent="0" marL="0">
+              <a:buNone/>
+            </a:pPr>
+            <a:r>
+              <a:rPr lang="en-US" sz="1400" dirty="0">
+                <a:solidFill>
+                  <a:schemeClr val="tx1"/>
+                </a:solidFill>
+              </a:rPr>
+              <a:t>pack-project.ts and the playbook let other teams repeat the method</a:t>
+            </a:r>
+            <a:endParaRPr lang="en-US" sz="1400" dirty="0"/>
+          </a:p>
+        </p:txBody>
+      </p:sp>
+      <p:sp>
+        <p:nvSpPr>
+          <p:cNvPr id="30" name="objrow-5-objbox"/>
+          <p:cNvSpPr/>
+          <p:nvPr/>
+        </p:nvSpPr>
+        <p:spPr>
+          <a:xfrm>
+            <a:off x="548640" y="5577840"/>
+            <a:ext cx="4617720" cy="676656"/>
+          </a:xfrm>
+          <a:prstGeom prst="roundRect">
+            <a:avLst>
+              <a:gd name="adj" fmla="val 16216"/>
+            </a:avLst>
+          </a:prstGeom>
+          <a:solidFill>
+            <a:schemeClr val="tx1"/>
+          </a:solidFill>
+          <a:ln/>
+        </p:spPr>
+      </p:sp>
+      <p:sp>
+        <p:nvSpPr>
+          <p:cNvPr id="31" name="objrow-5-objtext"/>
+          <p:cNvSpPr txBox="1"/>
+          <p:nvPr/>
+        </p:nvSpPr>
+        <p:spPr>
+          <a:xfrm>
+            <a:off x="731520" y="5650992"/>
+            <a:ext cx="4297680" cy="530352"/>
+          </a:xfrm>
+          <a:prstGeom prst="rect">
+            <a:avLst/>
+          </a:prstGeom>
+          <a:noFill/>
+          <a:ln/>
+        </p:spPr>
+        <p:txBody>
+          <a:bodyPr wrap="square" lIns="0" tIns="0" rIns="0" bIns="0" rtlCol="0" anchor="ctr"/>
+          <a:lstStyle/>
+          <a:p>
+            <a:pPr indent="0" marL="0">
+              <a:buNone/>
+            </a:pPr>
+            <a:r>
+              <a:rPr lang="en-US" sz="1300" b="1" dirty="0">
+                <a:solidFill>
+                  <a:schemeClr val="bg1"/>
+                </a:solidFill>
+              </a:rPr>
+              <a:t>Increase customer satisfaction</a:t>
+            </a:r>
+            <a:endParaRPr lang="en-US" sz="1300" dirty="0"/>
+          </a:p>
+          <a:p>
+            <a:pPr indent="0" marL="0">
+              <a:buNone/>
+            </a:pPr>
+            <a:r>
+              <a:rPr lang="en-US" sz="1100" dirty="0">
+                <a:solidFill>
+                  <a:schemeClr val="accent5"/>
+                </a:solidFill>
+              </a:rPr>
+              <a:t>Company: customer</a:t>
+            </a:r>
+            <a:endParaRPr lang="en-US" sz="1300" dirty="0"/>
+          </a:p>
+        </p:txBody>
+      </p:sp>
+      <p:sp>
+        <p:nvSpPr>
+          <p:cNvPr id="32" name="objrow-5-arrow"/>
+          <p:cNvSpPr/>
+          <p:nvPr/>
+        </p:nvSpPr>
+        <p:spPr>
+          <a:xfrm>
+            <a:off x="5248656" y="5788152"/>
+            <a:ext cx="237744" cy="256032"/>
+          </a:xfrm>
+          <a:prstGeom prst="rightArrow">
+            <a:avLst/>
+          </a:prstGeom>
+          <a:solidFill>
+            <a:schemeClr val="accent1"/>
+          </a:solidFill>
+          <a:ln w="12700">
+            <a:solidFill>
+              <a:schemeClr val="accent1"/>
+            </a:solidFill>
+            <a:prstDash val="solid"/>
+          </a:ln>
+        </p:spPr>
+      </p:sp>
+      <p:sp>
+        <p:nvSpPr>
+          <p:cNvPr id="33" name="objrow-5-contribbox"/>
+          <p:cNvSpPr/>
+          <p:nvPr/>
+        </p:nvSpPr>
+        <p:spPr>
+          <a:xfrm>
+            <a:off x="5577840" y="5577840"/>
+            <a:ext cx="6062472" cy="676656"/>
+          </a:xfrm>
+          <a:prstGeom prst="roundRect">
+            <a:avLst>
+              <a:gd name="adj" fmla="val 16216"/>
+            </a:avLst>
+          </a:prstGeom>
+          <a:solidFill>
+            <a:schemeClr val="bg2"/>
+          </a:solidFill>
+          <a:ln/>
+        </p:spPr>
+      </p:sp>
+      <p:sp>
+        <p:nvSpPr>
+          <p:cNvPr id="34" name="objrow-5-contribtext"/>
+          <p:cNvSpPr txBox="1"/>
+          <p:nvPr/>
+        </p:nvSpPr>
+        <p:spPr>
+          <a:xfrm>
+            <a:off x="5760720" y="5650992"/>
+            <a:ext cx="5696712" cy="530352"/>
+          </a:xfrm>
+          <a:prstGeom prst="rect">
+            <a:avLst/>
+          </a:prstGeom>
+          <a:noFill/>
+          <a:ln/>
+        </p:spPr>
+        <p:txBody>
+          <a:bodyPr wrap="square" lIns="0" tIns="0" rIns="0" bIns="0" rtlCol="0" anchor="ctr"/>
+          <a:lstStyle/>
+          <a:p>
+            <a:pPr indent="0" marL="0">
+              <a:buNone/>
+            </a:pPr>
+            <a:r>
+              <a:rPr lang="en-US" sz="1400" dirty="0">
+                <a:solidFill>
+                  <a:schemeClr val="tx1"/>
+                </a:solidFill>
+              </a:rPr>
+              <a:t>5 enhancements for ERM users, such as the report slideshow and resizable tables</a:t>
+            </a:r>
+            <a:endParaRPr lang="en-US" sz="1400" dirty="0"/>
+          </a:p>
+        </p:txBody>
+      </p:sp>
+    </p:spTree>
+  </p:cSld>
+  <p:clrMapOvr>
+    <a:masterClrMapping/>
+  </p:clrMapOvr>
+  <p:transition spd="med">
+    <p:fade/>
+  </p:transition>
+  <p:timing>
+    <p:tnLst>
+      <p:par>
+        <p:cTn id="1" dur="indefinite" restart="never" nodeType="tmRoot">
+          <p:childTnLst>
+            <p:seq concurrent="1" nextAc="seek">
+              <p:cTn id="2" dur="indefinite" nodeType="mainSeq">
+                <p:childTnLst>
+                  <p:par>
+                    <p:cTn id="99" fill="hold">
+                      <p:stCondLst>
+                        <p:cond delay="indefinite"/>
+                        <p:cond evt="onBegin" delay="0">
+                          <p:tn val="2"/>
+                        </p:cond>
+                      </p:stCondLst>
+                      <p:childTnLst>
+                        <p:par>
+                          <p:cTn id="18" fill="hold">
+                            <p:stCondLst>
+                              <p:cond delay="0"/>
+                            </p:stCondLst>
+                            <p:childTnLst>
+                              <p:par>
+                                <p:cTn id="3" presetID="10" presetClass="entr" presetSubtype="0" fill="hold" grpId="0" nodeType="afterEffect">
+                                  <p:stCondLst>
+                                    <p:cond delay="0"/>
+                                  </p:stCondLst>
+                                  <p:childTnLst>
+                                    <p:set>
+                                      <p:cBhvr>
+                                        <p:cTn id="4" dur="1" fill="hold">
+                                          <p:stCondLst>
+                                            <p:cond delay="0"/>
+                                          </p:stCondLst>
+                                        </p:cTn>
+                                        <p:tgtEl>
+                                          <p:spTgt spid="5"/>
+                                        </p:tgtEl>
+                                        <p:attrNameLst>
+                                          <p:attrName>style.visibility</p:attrName>
+                                        </p:attrNameLst>
+                                      </p:cBhvr>
+                                      <p:to>
+                                        <p:strVal val="visible"/>
+                                      </p:to>
+                                    </p:set>
+                                    <p:animEffect transition="in" filter="fade">
+                                      <p:cBhvr>
+                                        <p:cTn id="5" dur="450"/>
+                                        <p:tgtEl>
+                                          <p:spTgt spid="5"/>
+                                        </p:tgtEl>
+                                      </p:cBhvr>
+                                    </p:animEffect>
+                                  </p:childTnLst>
+                                </p:cTn>
+                              </p:par>
+                              <p:par>
+                                <p:cTn id="6" presetID="10" presetClass="entr" presetSubtype="0" fill="hold" grpId="0" nodeType="withEffect">
+                                  <p:stCondLst>
+                                    <p:cond delay="0"/>
+                                  </p:stCondLst>
+                                  <p:childTnLst>
+                                    <p:set>
+                                      <p:cBhvr>
+                                        <p:cTn id="7" dur="1" fill="hold">
+                                          <p:stCondLst>
+                                            <p:cond delay="0"/>
+                                          </p:stCondLst>
+                                        </p:cTn>
+                                        <p:tgtEl>
+                                          <p:spTgt spid="6"/>
+                                        </p:tgtEl>
+                                        <p:attrNameLst>
+                                          <p:attrName>style.visibility</p:attrName>
+                                        </p:attrNameLst>
+                                      </p:cBhvr>
+                                      <p:to>
+                                        <p:strVal val="visible"/>
+                                      </p:to>
+                                    </p:set>
+                                    <p:animEffect transition="in" filter="fade">
+                                      <p:cBhvr>
+                                        <p:cTn id="8" dur="450"/>
+                                        <p:tgtEl>
+                                          <p:spTgt spid="6"/>
+                                        </p:tgtEl>
+                                      </p:cBhvr>
+                                    </p:animEffect>
+                                  </p:childTnLst>
+                                </p:cTn>
+                              </p:par>
+                              <p:par>
+                                <p:cTn id="9" presetID="22" presetClass="entr" presetSubtype="8" fill="hold" grpId="0" nodeType="withEffect">
+                                  <p:stCondLst>
+                                    <p:cond delay="200"/>
+                                  </p:stCondLst>
+                                  <p:childTnLst>
+                                    <p:set>
+                                      <p:cBhvr>
+                                        <p:cTn id="10" dur="1" fill="hold">
+                                          <p:stCondLst>
+                                            <p:cond delay="0"/>
+                                          </p:stCondLst>
+                                        </p:cTn>
+                                        <p:tgtEl>
+                                          <p:spTgt spid="7"/>
+                                        </p:tgtEl>
+                                        <p:attrNameLst>
+                                          <p:attrName>style.visibility</p:attrName>
+                                        </p:attrNameLst>
+                                      </p:cBhvr>
+                                      <p:to>
+                                        <p:strVal val="visible"/>
+                                      </p:to>
+                                    </p:set>
+                                    <p:animEffect transition="in" filter="wipe(left)">
+                                      <p:cBhvr>
+                                        <p:cTn id="11" dur="450"/>
+                                        <p:tgtEl>
+                                          <p:spTgt spid="7"/>
+                                        </p:tgtEl>
+                                      </p:cBhvr>
+                                    </p:animEffect>
+                                  </p:childTnLst>
+                                </p:cTn>
+                              </p:par>
+                              <p:par>
+                                <p:cTn id="12" presetID="22" presetClass="entr" presetSubtype="8" fill="hold" grpId="0" nodeType="withEffect">
+                                  <p:stCondLst>
+                                    <p:cond delay="300"/>
+                                  </p:stCondLst>
+                                  <p:childTnLst>
+                                    <p:set>
+                                      <p:cBhvr>
+                                        <p:cTn id="13" dur="1" fill="hold">
+                                          <p:stCondLst>
+                                            <p:cond delay="0"/>
+                                          </p:stCondLst>
+                                        </p:cTn>
+                                        <p:tgtEl>
+                                          <p:spTgt spid="8"/>
+                                        </p:tgtEl>
+                                        <p:attrNameLst>
+                                          <p:attrName>style.visibility</p:attrName>
+                                        </p:attrNameLst>
+                                      </p:cBhvr>
+                                      <p:to>
+                                        <p:strVal val="visible"/>
+                                      </p:to>
+                                    </p:set>
+                                    <p:animEffect transition="in" filter="wipe(left)">
+                                      <p:cBhvr>
+                                        <p:cTn id="14" dur="450"/>
+                                        <p:tgtEl>
+                                          <p:spTgt spid="8"/>
+                                        </p:tgtEl>
+                                      </p:cBhvr>
+                                    </p:animEffect>
+                                  </p:childTnLst>
+                                </p:cTn>
+                              </p:par>
+                              <p:par>
+                                <p:cTn id="15" presetID="22" presetClass="entr" presetSubtype="8" fill="hold" grpId="0" nodeType="withEffect">
+                                  <p:stCondLst>
+                                    <p:cond delay="300"/>
+                                  </p:stCondLst>
+                                  <p:childTnLst>
+                                    <p:set>
+                                      <p:cBhvr>
+                                        <p:cTn id="16" dur="1" fill="hold">
+                                          <p:stCondLst>
+                                            <p:cond delay="0"/>
+                                          </p:stCondLst>
+                                        </p:cTn>
+                                        <p:tgtEl>
+                                          <p:spTgt spid="9"/>
+                                        </p:tgtEl>
+                                        <p:attrNameLst>
+                                          <p:attrName>style.visibility</p:attrName>
+                                        </p:attrNameLst>
+                                      </p:cBhvr>
+                                      <p:to>
+                                        <p:strVal val="visible"/>
+                                      </p:to>
+                                    </p:set>
+                                    <p:animEffect transition="in" filter="wipe(left)">
+                                      <p:cBhvr>
+                                        <p:cTn id="17" dur="450"/>
+                                        <p:tgtEl>
+                                          <p:spTgt spid="9"/>
+                                        </p:tgtEl>
+                                      </p:cBhvr>
+                                    </p:animEffect>
+                                  </p:childTnLst>
+                                </p:cTn>
+                              </p:par>
+                            </p:childTnLst>
+                          </p:cTn>
+                        </p:par>
+                        <p:par>
+                          <p:cTn id="34" fill="hold">
+                            <p:stCondLst>
+                              <p:cond delay="650"/>
+                            </p:stCondLst>
+                            <p:childTnLst>
+                              <p:par>
+                                <p:cTn id="19" presetID="10" presetClass="entr" presetSubtype="0" fill="hold" grpId="0" nodeType="afterEffect">
+                                  <p:stCondLst>
+                                    <p:cond delay="0"/>
+                                  </p:stCondLst>
+                                  <p:childTnLst>
+                                    <p:set>
+                                      <p:cBhvr>
+                                        <p:cTn id="20" dur="1" fill="hold">
+                                          <p:stCondLst>
+                                            <p:cond delay="0"/>
+                                          </p:stCondLst>
+                                        </p:cTn>
+                                        <p:tgtEl>
+                                          <p:spTgt spid="10"/>
+                                        </p:tgtEl>
+                                        <p:attrNameLst>
+                                          <p:attrName>style.visibility</p:attrName>
+                                        </p:attrNameLst>
+                                      </p:cBhvr>
+                                      <p:to>
+                                        <p:strVal val="visible"/>
+                                      </p:to>
+                                    </p:set>
+                                    <p:animEffect transition="in" filter="fade">
+                                      <p:cBhvr>
+                                        <p:cTn id="21" dur="450"/>
+                                        <p:tgtEl>
+                                          <p:spTgt spid="10"/>
+                                        </p:tgtEl>
+                                      </p:cBhvr>
+                                    </p:animEffect>
+                                  </p:childTnLst>
+                                </p:cTn>
+                              </p:par>
+                              <p:par>
+                                <p:cTn id="22" presetID="10" presetClass="entr" presetSubtype="0" fill="hold" grpId="0" nodeType="withEffect">
+                                  <p:stCondLst>
+                                    <p:cond delay="0"/>
+                                  </p:stCondLst>
+                                  <p:childTnLst>
+                                    <p:set>
+                                      <p:cBhvr>
+                                        <p:cTn id="23" dur="1" fill="hold">
+                                          <p:stCondLst>
+                                            <p:cond delay="0"/>
+                                          </p:stCondLst>
+                                        </p:cTn>
+                                        <p:tgtEl>
+                                          <p:spTgt spid="11"/>
+                                        </p:tgtEl>
+                                        <p:attrNameLst>
+                                          <p:attrName>style.visibility</p:attrName>
+                                        </p:attrNameLst>
+                                      </p:cBhvr>
+                                      <p:to>
+                                        <p:strVal val="visible"/>
+                                      </p:to>
+                                    </p:set>
+                                    <p:animEffect transition="in" filter="fade">
+                                      <p:cBhvr>
+                                        <p:cTn id="24" dur="450"/>
+                                        <p:tgtEl>
+                                          <p:spTgt spid="11"/>
+                                        </p:tgtEl>
+                                      </p:cBhvr>
+                                    </p:animEffect>
+                                  </p:childTnLst>
+                                </p:cTn>
+                              </p:par>
+                              <p:par>
+                                <p:cTn id="25" presetID="22" presetClass="entr" presetSubtype="8" fill="hold" grpId="0" nodeType="withEffect">
+                                  <p:stCondLst>
+                                    <p:cond delay="200"/>
+                                  </p:stCondLst>
+                                  <p:childTnLst>
+                                    <p:set>
+                                      <p:cBhvr>
+                                        <p:cTn id="26" dur="1" fill="hold">
+                                          <p:stCondLst>
+                                            <p:cond delay="0"/>
+                                          </p:stCondLst>
+                                        </p:cTn>
+                                        <p:tgtEl>
+                                          <p:spTgt spid="12"/>
+                                        </p:tgtEl>
+                                        <p:attrNameLst>
+                                          <p:attrName>style.visibility</p:attrName>
+                                        </p:attrNameLst>
+                                      </p:cBhvr>
+                                      <p:to>
+                                        <p:strVal val="visible"/>
+                                      </p:to>
+                                    </p:set>
+                                    <p:animEffect transition="in" filter="wipe(left)">
+                                      <p:cBhvr>
+                                        <p:cTn id="27" dur="450"/>
+                                        <p:tgtEl>
+                                          <p:spTgt spid="12"/>
+                                        </p:tgtEl>
+                                      </p:cBhvr>
+                                    </p:animEffect>
+                                  </p:childTnLst>
+                                </p:cTn>
+                              </p:par>
+                              <p:par>
+                                <p:cTn id="28" presetID="22" presetClass="entr" presetSubtype="8" fill="hold" grpId="0" nodeType="withEffect">
+                                  <p:stCondLst>
+                                    <p:cond delay="300"/>
+                                  </p:stCondLst>
+                                  <p:childTnLst>
+                                    <p:set>
+                                      <p:cBhvr>
+                                        <p:cTn id="29" dur="1" fill="hold">
+                                          <p:stCondLst>
+                                            <p:cond delay="0"/>
+                                          </p:stCondLst>
+                                        </p:cTn>
+                                        <p:tgtEl>
+                                          <p:spTgt spid="13"/>
+                                        </p:tgtEl>
+                                        <p:attrNameLst>
+                                          <p:attrName>style.visibility</p:attrName>
+                                        </p:attrNameLst>
+                                      </p:cBhvr>
+                                      <p:to>
+                                        <p:strVal val="visible"/>
+                                      </p:to>
+                                    </p:set>
+                                    <p:animEffect transition="in" filter="wipe(left)">
+                                      <p:cBhvr>
+                                        <p:cTn id="30" dur="450"/>
+                                        <p:tgtEl>
+                                          <p:spTgt spid="13"/>
+                                        </p:tgtEl>
+                                      </p:cBhvr>
+                                    </p:animEffect>
+                                  </p:childTnLst>
+                                </p:cTn>
+                              </p:par>
+                              <p:par>
+                                <p:cTn id="31" presetID="22" presetClass="entr" presetSubtype="8" fill="hold" grpId="0" nodeType="withEffect">
+                                  <p:stCondLst>
+                                    <p:cond delay="300"/>
+                                  </p:stCondLst>
+                                  <p:childTnLst>
+                                    <p:set>
+                                      <p:cBhvr>
+                                        <p:cTn id="32" dur="1" fill="hold">
+                                          <p:stCondLst>
+                                            <p:cond delay="0"/>
+                                          </p:stCondLst>
+                                        </p:cTn>
+                                        <p:tgtEl>
+                                          <p:spTgt spid="14"/>
+                                        </p:tgtEl>
+                                        <p:attrNameLst>
+                                          <p:attrName>style.visibility</p:attrName>
+                                        </p:attrNameLst>
+                                      </p:cBhvr>
+                                      <p:to>
+                                        <p:strVal val="visible"/>
+                                      </p:to>
+                                    </p:set>
+                                    <p:animEffect transition="in" filter="wipe(left)">
+                                      <p:cBhvr>
+                                        <p:cTn id="33" dur="450"/>
+                                        <p:tgtEl>
+                                          <p:spTgt spid="14"/>
+                                        </p:tgtEl>
+                                      </p:cBhvr>
+                                    </p:animEffect>
+                                  </p:childTnLst>
+                                </p:cTn>
+                              </p:par>
+                            </p:childTnLst>
+                          </p:cTn>
+                        </p:par>
+                        <p:par>
+                          <p:cTn id="50" fill="hold">
+                            <p:stCondLst>
+                              <p:cond delay="1300"/>
+                            </p:stCondLst>
+                            <p:childTnLst>
+                              <p:par>
+                                <p:cTn id="35" presetID="10" presetClass="entr" presetSubtype="0" fill="hold" grpId="0" nodeType="afterEffect">
+                                  <p:stCondLst>
+                                    <p:cond delay="0"/>
+                                  </p:stCondLst>
+                                  <p:childTnLst>
+                                    <p:set>
+                                      <p:cBhvr>
+                                        <p:cTn id="36" dur="1" fill="hold">
+                                          <p:stCondLst>
+                                            <p:cond delay="0"/>
+                                          </p:stCondLst>
+                                        </p:cTn>
+                                        <p:tgtEl>
+                                          <p:spTgt spid="15"/>
+                                        </p:tgtEl>
+                                        <p:attrNameLst>
+                                          <p:attrName>style.visibility</p:attrName>
+                                        </p:attrNameLst>
+                                      </p:cBhvr>
+                                      <p:to>
+                                        <p:strVal val="visible"/>
+                                      </p:to>
+                                    </p:set>
+                                    <p:animEffect transition="in" filter="fade">
+                                      <p:cBhvr>
+                                        <p:cTn id="37" dur="450"/>
+                                        <p:tgtEl>
+                                          <p:spTgt spid="15"/>
+                                        </p:tgtEl>
+                                      </p:cBhvr>
+                                    </p:animEffect>
+                                  </p:childTnLst>
+                                </p:cTn>
+                              </p:par>
+                              <p:par>
+                                <p:cTn id="38" presetID="10" presetClass="entr" presetSubtype="0" fill="hold" grpId="0" nodeType="withEffect">
+                                  <p:stCondLst>
+                                    <p:cond delay="0"/>
+                                  </p:stCondLst>
+                                  <p:childTnLst>
+                                    <p:set>
+                                      <p:cBhvr>
+                                        <p:cTn id="39" dur="1" fill="hold">
+                                          <p:stCondLst>
+                                            <p:cond delay="0"/>
+                                          </p:stCondLst>
+                                        </p:cTn>
+                                        <p:tgtEl>
+                                          <p:spTgt spid="16"/>
+                                        </p:tgtEl>
+                                        <p:attrNameLst>
+                                          <p:attrName>style.visibility</p:attrName>
+                                        </p:attrNameLst>
+                                      </p:cBhvr>
+                                      <p:to>
+                                        <p:strVal val="visible"/>
+                                      </p:to>
+                                    </p:set>
+                                    <p:animEffect transition="in" filter="fade">
+                                      <p:cBhvr>
+                                        <p:cTn id="40" dur="450"/>
+                                        <p:tgtEl>
+                                          <p:spTgt spid="16"/>
+                                        </p:tgtEl>
+                                      </p:cBhvr>
+                                    </p:animEffect>
+                                  </p:childTnLst>
+                                </p:cTn>
+                              </p:par>
+                              <p:par>
+                                <p:cTn id="41" presetID="22" presetClass="entr" presetSubtype="8" fill="hold" grpId="0" nodeType="withEffect">
+                                  <p:stCondLst>
+                                    <p:cond delay="200"/>
+                                  </p:stCondLst>
+                                  <p:childTnLst>
+                                    <p:set>
+                                      <p:cBhvr>
+                                        <p:cTn id="42" dur="1" fill="hold">
+                                          <p:stCondLst>
+                                            <p:cond delay="0"/>
+                                          </p:stCondLst>
+                                        </p:cTn>
+                                        <p:tgtEl>
+                                          <p:spTgt spid="17"/>
+                                        </p:tgtEl>
+                                        <p:attrNameLst>
+                                          <p:attrName>style.visibility</p:attrName>
+                                        </p:attrNameLst>
+                                      </p:cBhvr>
+                                      <p:to>
+                                        <p:strVal val="visible"/>
+                                      </p:to>
+                                    </p:set>
+                                    <p:animEffect transition="in" filter="wipe(left)">
+                                      <p:cBhvr>
+                                        <p:cTn id="43" dur="450"/>
+                                        <p:tgtEl>
+                                          <p:spTgt spid="17"/>
+                                        </p:tgtEl>
+                                      </p:cBhvr>
+                                    </p:animEffect>
+                                  </p:childTnLst>
+                                </p:cTn>
+                              </p:par>
+                              <p:par>
+                                <p:cTn id="44" presetID="22" presetClass="entr" presetSubtype="8" fill="hold" grpId="0" nodeType="withEffect">
+                                  <p:stCondLst>
+                                    <p:cond delay="300"/>
+                                  </p:stCondLst>
+                                  <p:childTnLst>
+                                    <p:set>
+                                      <p:cBhvr>
+                                        <p:cTn id="45" dur="1" fill="hold">
+                                          <p:stCondLst>
+                                            <p:cond delay="0"/>
+                                          </p:stCondLst>
+                                        </p:cTn>
+                                        <p:tgtEl>
+                                          <p:spTgt spid="18"/>
+                                        </p:tgtEl>
+                                        <p:attrNameLst>
+                                          <p:attrName>style.visibility</p:attrName>
+                                        </p:attrNameLst>
+                                      </p:cBhvr>
+                                      <p:to>
+                                        <p:strVal val="visible"/>
+                                      </p:to>
+                                    </p:set>
+                                    <p:animEffect transition="in" filter="wipe(left)">
+                                      <p:cBhvr>
+                                        <p:cTn id="46" dur="450"/>
+                                        <p:tgtEl>
+                                          <p:spTgt spid="18"/>
+                                        </p:tgtEl>
+                                      </p:cBhvr>
+                                    </p:animEffect>
+                                  </p:childTnLst>
+                                </p:cTn>
+                              </p:par>
+                              <p:par>
+                                <p:cTn id="47" presetID="22" presetClass="entr" presetSubtype="8" fill="hold" grpId="0" nodeType="withEffect">
+                                  <p:stCondLst>
+                                    <p:cond delay="300"/>
+                                  </p:stCondLst>
+                                  <p:childTnLst>
+                                    <p:set>
+                                      <p:cBhvr>
+                                        <p:cTn id="48" dur="1" fill="hold">
+                                          <p:stCondLst>
+                                            <p:cond delay="0"/>
+                                          </p:stCondLst>
+                                        </p:cTn>
+                                        <p:tgtEl>
+                                          <p:spTgt spid="19"/>
+                                        </p:tgtEl>
+                                        <p:attrNameLst>
+                                          <p:attrName>style.visibility</p:attrName>
+                                        </p:attrNameLst>
+                                      </p:cBhvr>
+                                      <p:to>
+                                        <p:strVal val="visible"/>
+                                      </p:to>
+                                    </p:set>
+                                    <p:animEffect transition="in" filter="wipe(left)">
+                                      <p:cBhvr>
+                                        <p:cTn id="49" dur="450"/>
+                                        <p:tgtEl>
+                                          <p:spTgt spid="19"/>
+                                        </p:tgtEl>
+                                      </p:cBhvr>
+                                    </p:animEffect>
+                                  </p:childTnLst>
+                                </p:cTn>
+                              </p:par>
+                            </p:childTnLst>
+                          </p:cTn>
+                        </p:par>
+                        <p:par>
+                          <p:cTn id="66" fill="hold">
+                            <p:stCondLst>
+                              <p:cond delay="1950"/>
+                            </p:stCondLst>
+                            <p:childTnLst>
+                              <p:par>
+                                <p:cTn id="51" presetID="10" presetClass="entr" presetSubtype="0" fill="hold" grpId="0" nodeType="afterEffect">
+                                  <p:stCondLst>
+                                    <p:cond delay="0"/>
+                                  </p:stCondLst>
+                                  <p:childTnLst>
+                                    <p:set>
+                                      <p:cBhvr>
+                                        <p:cTn id="52" dur="1" fill="hold">
+                                          <p:stCondLst>
+                                            <p:cond delay="0"/>
+                                          </p:stCondLst>
+                                        </p:cTn>
+                                        <p:tgtEl>
+                                          <p:spTgt spid="20"/>
+                                        </p:tgtEl>
+                                        <p:attrNameLst>
+                                          <p:attrName>style.visibility</p:attrName>
+                                        </p:attrNameLst>
+                                      </p:cBhvr>
+                                      <p:to>
+                                        <p:strVal val="visible"/>
+                                      </p:to>
+                                    </p:set>
+                                    <p:animEffect transition="in" filter="fade">
+                                      <p:cBhvr>
+                                        <p:cTn id="53" dur="450"/>
+                                        <p:tgtEl>
+                                          <p:spTgt spid="20"/>
+                                        </p:tgtEl>
+                                      </p:cBhvr>
+                                    </p:animEffect>
+                                  </p:childTnLst>
+                                </p:cTn>
+                              </p:par>
+                              <p:par>
+                                <p:cTn id="54" presetID="10" presetClass="entr" presetSubtype="0" fill="hold" grpId="0" nodeType="withEffect">
+                                  <p:stCondLst>
+                                    <p:cond delay="0"/>
+                                  </p:stCondLst>
+                                  <p:childTnLst>
+                                    <p:set>
+                                      <p:cBhvr>
+                                        <p:cTn id="55" dur="1" fill="hold">
+                                          <p:stCondLst>
+                                            <p:cond delay="0"/>
+                                          </p:stCondLst>
+                                        </p:cTn>
+                                        <p:tgtEl>
+                                          <p:spTgt spid="21"/>
+                                        </p:tgtEl>
+                                        <p:attrNameLst>
+                                          <p:attrName>style.visibility</p:attrName>
+                                        </p:attrNameLst>
+                                      </p:cBhvr>
+                                      <p:to>
+                                        <p:strVal val="visible"/>
+                                      </p:to>
+                                    </p:set>
+                                    <p:animEffect transition="in" filter="fade">
+                                      <p:cBhvr>
+                                        <p:cTn id="56" dur="450"/>
+                                        <p:tgtEl>
+                                          <p:spTgt spid="21"/>
+                                        </p:tgtEl>
+                                      </p:cBhvr>
+                                    </p:animEffect>
+                                  </p:childTnLst>
+                                </p:cTn>
+                              </p:par>
+                              <p:par>
+                                <p:cTn id="57" presetID="22" presetClass="entr" presetSubtype="8" fill="hold" grpId="0" nodeType="withEffect">
+                                  <p:stCondLst>
+                                    <p:cond delay="200"/>
+                                  </p:stCondLst>
+                                  <p:childTnLst>
+                                    <p:set>
+                                      <p:cBhvr>
+                                        <p:cTn id="58" dur="1" fill="hold">
+                                          <p:stCondLst>
+                                            <p:cond delay="0"/>
+                                          </p:stCondLst>
+                                        </p:cTn>
+                                        <p:tgtEl>
+                                          <p:spTgt spid="22"/>
+                                        </p:tgtEl>
+                                        <p:attrNameLst>
+                                          <p:attrName>style.visibility</p:attrName>
+                                        </p:attrNameLst>
+                                      </p:cBhvr>
+                                      <p:to>
+                                        <p:strVal val="visible"/>
+                                      </p:to>
+                                    </p:set>
+                                    <p:animEffect transition="in" filter="wipe(left)">
+                                      <p:cBhvr>
+                                        <p:cTn id="59" dur="450"/>
+                                        <p:tgtEl>
+                                          <p:spTgt spid="22"/>
+                                        </p:tgtEl>
+                                      </p:cBhvr>
+                                    </p:animEffect>
+                                  </p:childTnLst>
+                                </p:cTn>
+                              </p:par>
+                              <p:par>
+                                <p:cTn id="60" presetID="22" presetClass="entr" presetSubtype="8" fill="hold" grpId="0" nodeType="withEffect">
+                                  <p:stCondLst>
+                                    <p:cond delay="300"/>
+                                  </p:stCondLst>
+                                  <p:childTnLst>
+                                    <p:set>
+                                      <p:cBhvr>
+                                        <p:cTn id="61" dur="1" fill="hold">
+                                          <p:stCondLst>
+                                            <p:cond delay="0"/>
+                                          </p:stCondLst>
+                                        </p:cTn>
+                                        <p:tgtEl>
+                                          <p:spTgt spid="23"/>
+                                        </p:tgtEl>
+                                        <p:attrNameLst>
+                                          <p:attrName>style.visibility</p:attrName>
+                                        </p:attrNameLst>
+                                      </p:cBhvr>
+                                      <p:to>
+                                        <p:strVal val="visible"/>
+                                      </p:to>
+                                    </p:set>
+                                    <p:animEffect transition="in" filter="wipe(left)">
+                                      <p:cBhvr>
+                                        <p:cTn id="62" dur="450"/>
+                                        <p:tgtEl>
+                                          <p:spTgt spid="23"/>
+                                        </p:tgtEl>
+                                      </p:cBhvr>
+                                    </p:animEffect>
+                                  </p:childTnLst>
+                                </p:cTn>
+                              </p:par>
+                              <p:par>
+                                <p:cTn id="63" presetID="22" presetClass="entr" presetSubtype="8" fill="hold" grpId="0" nodeType="withEffect">
+                                  <p:stCondLst>
+                                    <p:cond delay="300"/>
+                                  </p:stCondLst>
+                                  <p:childTnLst>
+                                    <p:set>
+                                      <p:cBhvr>
+                                        <p:cTn id="64" dur="1" fill="hold">
+                                          <p:stCondLst>
+                                            <p:cond delay="0"/>
+                                          </p:stCondLst>
+                                        </p:cTn>
+                                        <p:tgtEl>
+                                          <p:spTgt spid="24"/>
+                                        </p:tgtEl>
+                                        <p:attrNameLst>
+                                          <p:attrName>style.visibility</p:attrName>
+                                        </p:attrNameLst>
+                                      </p:cBhvr>
+                                      <p:to>
+                                        <p:strVal val="visible"/>
+                                      </p:to>
+                                    </p:set>
+                                    <p:animEffect transition="in" filter="wipe(left)">
+                                      <p:cBhvr>
+                                        <p:cTn id="65" dur="450"/>
+                                        <p:tgtEl>
+                                          <p:spTgt spid="24"/>
+                                        </p:tgtEl>
+                                      </p:cBhvr>
+                                    </p:animEffect>
+                                  </p:childTnLst>
+                                </p:cTn>
+                              </p:par>
+                            </p:childTnLst>
+                          </p:cTn>
+                        </p:par>
+                        <p:par>
+                          <p:cTn id="82" fill="hold">
+                            <p:stCondLst>
+                              <p:cond delay="2600"/>
+                            </p:stCondLst>
+                            <p:childTnLst>
+                              <p:par>
+                                <p:cTn id="67" presetID="10" presetClass="entr" presetSubtype="0" fill="hold" grpId="0" nodeType="afterEffect">
+                                  <p:stCondLst>
+                                    <p:cond delay="0"/>
+                                  </p:stCondLst>
+                                  <p:childTnLst>
+                                    <p:set>
+                                      <p:cBhvr>
+                                        <p:cTn id="68" dur="1" fill="hold">
+                                          <p:stCondLst>
+                                            <p:cond delay="0"/>
+                                          </p:stCondLst>
+                                        </p:cTn>
+                                        <p:tgtEl>
+                                          <p:spTgt spid="25"/>
+                                        </p:tgtEl>
+                                        <p:attrNameLst>
+                                          <p:attrName>style.visibility</p:attrName>
+                                        </p:attrNameLst>
+                                      </p:cBhvr>
+                                      <p:to>
+                                        <p:strVal val="visible"/>
+                                      </p:to>
+                                    </p:set>
+                                    <p:animEffect transition="in" filter="fade">
+                                      <p:cBhvr>
+                                        <p:cTn id="69" dur="450"/>
+                                        <p:tgtEl>
+                                          <p:spTgt spid="25"/>
+                                        </p:tgtEl>
+                                      </p:cBhvr>
+                                    </p:animEffect>
+                                  </p:childTnLst>
+                                </p:cTn>
+                              </p:par>
+                              <p:par>
+                                <p:cTn id="70" presetID="10" presetClass="entr" presetSubtype="0" fill="hold" grpId="0" nodeType="withEffect">
+                                  <p:stCondLst>
+                                    <p:cond delay="0"/>
+                                  </p:stCondLst>
+                                  <p:childTnLst>
+                                    <p:set>
+                                      <p:cBhvr>
+                                        <p:cTn id="71" dur="1" fill="hold">
+                                          <p:stCondLst>
+                                            <p:cond delay="0"/>
+                                          </p:stCondLst>
+                                        </p:cTn>
+                                        <p:tgtEl>
+                                          <p:spTgt spid="26"/>
+                                        </p:tgtEl>
+                                        <p:attrNameLst>
+                                          <p:attrName>style.visibility</p:attrName>
+                                        </p:attrNameLst>
+                                      </p:cBhvr>
+                                      <p:to>
+                                        <p:strVal val="visible"/>
+                                      </p:to>
+                                    </p:set>
+                                    <p:animEffect transition="in" filter="fade">
+                                      <p:cBhvr>
+                                        <p:cTn id="72" dur="450"/>
+                                        <p:tgtEl>
+                                          <p:spTgt spid="26"/>
+                                        </p:tgtEl>
+                                      </p:cBhvr>
+                                    </p:animEffect>
+                                  </p:childTnLst>
+                                </p:cTn>
+                              </p:par>
+                              <p:par>
+                                <p:cTn id="73" presetID="22" presetClass="entr" presetSubtype="8" fill="hold" grpId="0" nodeType="withEffect">
+                                  <p:stCondLst>
+                                    <p:cond delay="200"/>
+                                  </p:stCondLst>
+                                  <p:childTnLst>
+                                    <p:set>
+                                      <p:cBhvr>
+                                        <p:cTn id="74" dur="1" fill="hold">
+                                          <p:stCondLst>
+                                            <p:cond delay="0"/>
+                                          </p:stCondLst>
+                                        </p:cTn>
+                                        <p:tgtEl>
+                                          <p:spTgt spid="27"/>
+                                        </p:tgtEl>
+                                        <p:attrNameLst>
+                                          <p:attrName>style.visibility</p:attrName>
+                                        </p:attrNameLst>
+                                      </p:cBhvr>
+                                      <p:to>
+                                        <p:strVal val="visible"/>
+                                      </p:to>
+                                    </p:set>
+                                    <p:animEffect transition="in" filter="wipe(left)">
+                                      <p:cBhvr>
+                                        <p:cTn id="75" dur="450"/>
+                                        <p:tgtEl>
+                                          <p:spTgt spid="27"/>
+                                        </p:tgtEl>
+                                      </p:cBhvr>
+                                    </p:animEffect>
+                                  </p:childTnLst>
+                                </p:cTn>
+                              </p:par>
+                              <p:par>
+                                <p:cTn id="76" presetID="22" presetClass="entr" presetSubtype="8" fill="hold" grpId="0" nodeType="withEffect">
+                                  <p:stCondLst>
+                                    <p:cond delay="300"/>
+                                  </p:stCondLst>
+                                  <p:childTnLst>
+                                    <p:set>
+                                      <p:cBhvr>
+                                        <p:cTn id="77" dur="1" fill="hold">
+                                          <p:stCondLst>
+                                            <p:cond delay="0"/>
+                                          </p:stCondLst>
+                                        </p:cTn>
+                                        <p:tgtEl>
+                                          <p:spTgt spid="28"/>
+                                        </p:tgtEl>
+                                        <p:attrNameLst>
+                                          <p:attrName>style.visibility</p:attrName>
+                                        </p:attrNameLst>
+                                      </p:cBhvr>
+                                      <p:to>
+                                        <p:strVal val="visible"/>
+                                      </p:to>
+                                    </p:set>
+                                    <p:animEffect transition="in" filter="wipe(left)">
+                                      <p:cBhvr>
+                                        <p:cTn id="78" dur="450"/>
+                                        <p:tgtEl>
+                                          <p:spTgt spid="28"/>
+                                        </p:tgtEl>
+                                      </p:cBhvr>
+                                    </p:animEffect>
+                                  </p:childTnLst>
+                                </p:cTn>
+                              </p:par>
+                              <p:par>
+                                <p:cTn id="79" presetID="22" presetClass="entr" presetSubtype="8" fill="hold" grpId="0" nodeType="withEffect">
+                                  <p:stCondLst>
+                                    <p:cond delay="300"/>
+                                  </p:stCondLst>
+                                  <p:childTnLst>
+                                    <p:set>
+                                      <p:cBhvr>
+                                        <p:cTn id="80" dur="1" fill="hold">
+                                          <p:stCondLst>
+                                            <p:cond delay="0"/>
+                                          </p:stCondLst>
+                                        </p:cTn>
+                                        <p:tgtEl>
+                                          <p:spTgt spid="29"/>
+                                        </p:tgtEl>
+                                        <p:attrNameLst>
+                                          <p:attrName>style.visibility</p:attrName>
+                                        </p:attrNameLst>
+                                      </p:cBhvr>
+                                      <p:to>
+                                        <p:strVal val="visible"/>
+                                      </p:to>
+                                    </p:set>
+                                    <p:animEffect transition="in" filter="wipe(left)">
+                                      <p:cBhvr>
+                                        <p:cTn id="81" dur="450"/>
+                                        <p:tgtEl>
+                                          <p:spTgt spid="29"/>
+                                        </p:tgtEl>
+                                      </p:cBhvr>
+                                    </p:animEffect>
+                                  </p:childTnLst>
+                                </p:cTn>
+                              </p:par>
+                            </p:childTnLst>
+                          </p:cTn>
+                        </p:par>
+                        <p:par>
+                          <p:cTn id="98" fill="hold">
+                            <p:stCondLst>
+                              <p:cond delay="3250"/>
+                            </p:stCondLst>
+                            <p:childTnLst>
+                              <p:par>
+                                <p:cTn id="83" presetID="10" presetClass="entr" presetSubtype="0" fill="hold" grpId="0" nodeType="afterEffect">
+                                  <p:stCondLst>
+                                    <p:cond delay="0"/>
+                                  </p:stCondLst>
+                                  <p:childTnLst>
+                                    <p:set>
+                                      <p:cBhvr>
+                                        <p:cTn id="84" dur="1" fill="hold">
+                                          <p:stCondLst>
+                                            <p:cond delay="0"/>
+                                          </p:stCondLst>
+                                        </p:cTn>
+                                        <p:tgtEl>
+                                          <p:spTgt spid="30"/>
+                                        </p:tgtEl>
+                                        <p:attrNameLst>
+                                          <p:attrName>style.visibility</p:attrName>
+                                        </p:attrNameLst>
+                                      </p:cBhvr>
+                                      <p:to>
+                                        <p:strVal val="visible"/>
+                                      </p:to>
+                                    </p:set>
+                                    <p:animEffect transition="in" filter="fade">
+                                      <p:cBhvr>
+                                        <p:cTn id="85" dur="450"/>
+                                        <p:tgtEl>
+                                          <p:spTgt spid="30"/>
+                                        </p:tgtEl>
+                                      </p:cBhvr>
+                                    </p:animEffect>
+                                  </p:childTnLst>
+                                </p:cTn>
+                              </p:par>
+                              <p:par>
+                                <p:cTn id="86" presetID="10" presetClass="entr" presetSubtype="0" fill="hold" grpId="0" nodeType="withEffect">
+                                  <p:stCondLst>
+                                    <p:cond delay="0"/>
+                                  </p:stCondLst>
+                                  <p:childTnLst>
+                                    <p:set>
+                                      <p:cBhvr>
+                                        <p:cTn id="87" dur="1" fill="hold">
+                                          <p:stCondLst>
+                                            <p:cond delay="0"/>
+                                          </p:stCondLst>
+                                        </p:cTn>
+                                        <p:tgtEl>
+                                          <p:spTgt spid="31"/>
+                                        </p:tgtEl>
+                                        <p:attrNameLst>
+                                          <p:attrName>style.visibility</p:attrName>
+                                        </p:attrNameLst>
+                                      </p:cBhvr>
+                                      <p:to>
+                                        <p:strVal val="visible"/>
+                                      </p:to>
+                                    </p:set>
+                                    <p:animEffect transition="in" filter="fade">
+                                      <p:cBhvr>
+                                        <p:cTn id="88" dur="450"/>
+                                        <p:tgtEl>
+                                          <p:spTgt spid="31"/>
+                                        </p:tgtEl>
+                                      </p:cBhvr>
+                                    </p:animEffect>
+                                  </p:childTnLst>
+                                </p:cTn>
+                              </p:par>
+                              <p:par>
+                                <p:cTn id="89" presetID="22" presetClass="entr" presetSubtype="8" fill="hold" grpId="0" nodeType="withEffect">
+                                  <p:stCondLst>
+                                    <p:cond delay="200"/>
+                                  </p:stCondLst>
+                                  <p:childTnLst>
+                                    <p:set>
+                                      <p:cBhvr>
+                                        <p:cTn id="90" dur="1" fill="hold">
+                                          <p:stCondLst>
+                                            <p:cond delay="0"/>
+                                          </p:stCondLst>
+                                        </p:cTn>
+                                        <p:tgtEl>
+                                          <p:spTgt spid="32"/>
+                                        </p:tgtEl>
+                                        <p:attrNameLst>
+                                          <p:attrName>style.visibility</p:attrName>
+                                        </p:attrNameLst>
+                                      </p:cBhvr>
+                                      <p:to>
+                                        <p:strVal val="visible"/>
+                                      </p:to>
+                                    </p:set>
+                                    <p:animEffect transition="in" filter="wipe(left)">
+                                      <p:cBhvr>
+                                        <p:cTn id="91" dur="450"/>
+                                        <p:tgtEl>
+                                          <p:spTgt spid="32"/>
+                                        </p:tgtEl>
+                                      </p:cBhvr>
+                                    </p:animEffect>
+                                  </p:childTnLst>
+                                </p:cTn>
+                              </p:par>
+                              <p:par>
+                                <p:cTn id="92" presetID="22" presetClass="entr" presetSubtype="8" fill="hold" grpId="0" nodeType="withEffect">
+                                  <p:stCondLst>
+                                    <p:cond delay="300"/>
+                                  </p:stCondLst>
+                                  <p:childTnLst>
+                                    <p:set>
+                                      <p:cBhvr>
+                                        <p:cTn id="93" dur="1" fill="hold">
+                                          <p:stCondLst>
+                                            <p:cond delay="0"/>
+                                          </p:stCondLst>
+                                        </p:cTn>
+                                        <p:tgtEl>
+                                          <p:spTgt spid="33"/>
+                                        </p:tgtEl>
+                                        <p:attrNameLst>
+                                          <p:attrName>style.visibility</p:attrName>
+                                        </p:attrNameLst>
+                                      </p:cBhvr>
+                                      <p:to>
+                                        <p:strVal val="visible"/>
+                                      </p:to>
+                                    </p:set>
+                                    <p:animEffect transition="in" filter="wipe(left)">
+                                      <p:cBhvr>
+                                        <p:cTn id="94" dur="450"/>
+                                        <p:tgtEl>
+                                          <p:spTgt spid="33"/>
+                                        </p:tgtEl>
+                                      </p:cBhvr>
+                                    </p:animEffect>
+                                  </p:childTnLst>
+                                </p:cTn>
+                              </p:par>
+                              <p:par>
+                                <p:cTn id="95" presetID="22" presetClass="entr" presetSubtype="8" fill="hold" grpId="0" nodeType="withEffect">
+                                  <p:stCondLst>
+                                    <p:cond delay="300"/>
+                                  </p:stCondLst>
+                                  <p:childTnLst>
+                                    <p:set>
+                                      <p:cBhvr>
+                                        <p:cTn id="96" dur="1" fill="hold">
+                                          <p:stCondLst>
+                                            <p:cond delay="0"/>
+                                          </p:stCondLst>
+                                        </p:cTn>
+                                        <p:tgtEl>
+                                          <p:spTgt spid="34"/>
+                                        </p:tgtEl>
+                                        <p:attrNameLst>
+                                          <p:attrName>style.visibility</p:attrName>
+                                        </p:attrNameLst>
+                                      </p:cBhvr>
+                                      <p:to>
+                                        <p:strVal val="visible"/>
+                                      </p:to>
+                                    </p:set>
+                                    <p:animEffect transition="in" filter="wipe(left)">
+                                      <p:cBhvr>
+                                        <p:cTn id="97" dur="450"/>
+                                        <p:tgtEl>
+                                          <p:spTgt spid="34"/>
+                                        </p:tgtEl>
+                                      </p:cBhvr>
+                                    </p:animEffect>
+                                  </p:childTnLst>
+                                </p:cTn>
+                              </p:par>
+                            </p:childTnLst>
+                          </p:cTn>
+                        </p:par>
+                      </p:childTnLst>
+                    </p:cTn>
+                  </p:par>
+                </p:childTnLst>
+              </p:cTn>
+              <p:prevCondLst>
+                <p:cond evt="onPrev" delay="0">
+                  <p:tgtEl>
+                    <p:sldTgt/>
+                  </p:tgtEl>
+                </p:cond>
+              </p:prevCondLst>
+              <p:nextCondLst>
+                <p:cond evt="onNext" delay="0">
+                  <p:tgtEl>
+                    <p:sldTgt/>
+                  </p:tgtEl>
+                </p:cond>
+              </p:nextCondLst>
+            </p:seq>
+          </p:childTnLst>
+        </p:cTn>
+      </p:par>
+    </p:tnLst>
+    <p:bldLst>
+      <p:bldP spid="5" grpId="0" animBg="1"/>
+      <p:bldP spid="6" grpId="0" animBg="1"/>
+      <p:bldP spid="7" grpId="0" animBg="1"/>
+      <p:bldP spid="8" grpId="0" animBg="1"/>
+      <p:bldP spid="9" grpId="0" animBg="1"/>
+      <p:bldP spid="10" grpId="0" animBg="1"/>
+      <p:bldP spid="11" grpId="0" animBg="1"/>
+      <p:bldP spid="12" grpId="0" animBg="1"/>
+      <p:bldP spid="13" grpId="0" animBg="1"/>
+      <p:bldP spid="14" grpId="0" animBg="1"/>
+      <p:bldP spid="15" grpId="0" animBg="1"/>
+      <p:bldP spid="16" grpId="0" animBg="1"/>
+      <p:bldP spid="17" grpId="0" animBg="1"/>
+      <p:bldP spid="18" grpId="0" animBg="1"/>
+      <p:bldP spid="19" grpId="0" animBg="1"/>
+      <p:bldP spid="20" grpId="0" animBg="1"/>
+      <p:bldP spid="21" grpId="0" animBg="1"/>
+      <p:bldP spid="22" grpId="0" animBg="1"/>
+      <p:bldP spid="23" grpId="0" animBg="1"/>
+      <p:bldP spid="24" grpId="0" animBg="1"/>
+      <p:bldP spid="25" grpId="0" animBg="1"/>
+      <p:bldP spid="26" grpId="0" animBg="1"/>
+      <p:bldP spid="27" grpId="0" animBg="1"/>
+      <p:bldP spid="28" grpId="0" animBg="1"/>
+      <p:bldP spid="29" grpId="0" animBg="1"/>
+      <p:bldP spid="30" grpId="0" animBg="1"/>
+      <p:bldP spid="31" grpId="0" animBg="1"/>
+      <p:bldP spid="32" grpId="0" animBg="1"/>
+      <p:bldP spid="33" grpId="0" animBg="1"/>
+      <p:bldP spid="34" grpId="0" animBg="1"/>
+    </p:bldLst>
+  </p:timing>
+</p:sld>
+</file>
+
+<file path=ppt/slides/slide8.xml><?xml version="1.0" encoding="utf-8"?>
+<p:sld xmlns:a="http://schemas.openxmlformats.org/drawingml/2006/main" xmlns:r="http://schemas.openxmlformats.org/officeDocument/2006/relationships" xmlns:p="http://schemas.openxmlformats.org/presentationml/2006/main">
+  <p:cSld name="Slide 8">
     <p:spTree>
       <p:nvGrpSpPr>
         <p:cNvPr id="1" name=""/>

</xml_diff>

<commit_message>
Replace objectives slide with an animated flow chart of four objectives
Co-Authored-By: Claude Opus 5.5 <noreply@anthropic.com>
Claude-Session: https://claude.ai/code/session_01HdxEbeqqWM97gKbcNqpjAq
</commit_message>
<xml_diff>
--- a/erm-migration/docs/ERM-Migration-Jury-Pitch.pptx
+++ b/erm-migration/docs/ERM-Migration-Jury-Pitch.pptx
@@ -114,18 +114,18 @@
   <p:extLst>
     <p:ext uri="{521415D9-36F7-43E2-AB2F-B90AF26B5E84}">
       <p14:sectionLst xmlns:p14="http://schemas.microsoft.com/office/powerpoint/2010/main">
-        <p14:section name="Pitch" id="{33ca7ca2-bc01-2ed2-fb6a-97406a12c4f4}">
+        <p14:section name="Pitch" id="{68cee248-ac56-9275-01e0-833e31471027}">
           <p14:sldIdLst>
             <p14:sldId id="256"/>
           </p14:sldIdLst>
         </p14:section>
-        <p14:section name="Problem and method" id="{de6ffe95-0ce3-e50b-5752-1e7c262878da}">
+        <p14:section name="Problem and method" id="{5e3557c1-594e-cbe3-d84d-735b845b56c9}">
           <p14:sldIdLst>
             <p14:sldId id="257"/>
             <p14:sldId id="258"/>
           </p14:sldIdLst>
         </p14:section>
-        <p14:section name="Impact" id="{42ae12a4-0680-d832-7970-7c67feddbf72}">
+        <p14:section name="Impact" id="{0a0c7880-fca0-b643-b453-781e7b2042c3}">
           <p14:sldIdLst>
             <p14:sldId id="259"/>
             <p14:sldId id="260"/>
@@ -133,7 +133,7 @@
             <p14:sldId id="262"/>
           </p14:sldIdLst>
         </p14:section>
-        <p14:section name="Reuse" id="{e8beae28-e3cb-39fb-e193-be7fb727433d}">
+        <p14:section name="Reuse" id="{d7bb1c21-0d15-3ccb-43df-1626f229b72a}">
           <p14:sldIdLst>
             <p14:sldId id="263"/>
           </p14:sldIdLst>
@@ -1070,7 +1070,7 @@
           <a:p>
             <a:r>
               <a:rPr lang="en-US" dirty="0"/>
-              <a:t>This slide ties the work to the 2026 objectives; each row appears in turn. Leverage AI to solve business problems: this is an AI-assisted migration of a complex, undocumented app, and the method is now a playbook. Deliver on time, cost and quality: two developers did it in one PI, about 76% less effort than a generic manual estimate. Manage our risks: the AI review caught 7 security and data-integrity issues, the restricted-view access model was kept, and we removed a dependency on Slate configuration by moving to standard React and OSDK code. Digital Design Authority: the app now has 8 architecture and lifecycle diagrams and a documented feature catalogue. Digital acumen and competencies: pack-project.ts and the playbook let other teams repeat this. Customer satisfaction: ERM users get 5 enhancements the old app did not have.</a:t>
+              <a:t>This slide ties the project to four 2026 objectives; the flow builds one branch at a time. One: Leverage AI to solve business problems. The AI read all 8 Slate exports and the packed React code, recovered 105 features from an undocumented app and found 31 gaps. Two: Deliver on time, on cost, on quality. Two developers delivered it in one PI, about 76% less effort than a generic manual estimate. Three: Ensure our operational performance. ERM is a business system; every one of its 105 features was tracked for parity, and it now runs on standard, maintainable React and OSDK code instead of legacy Slate configuration. Four: Grow digital acumen and competencies. pack-project.ts and the playbook mean other teams can repeat this, which builds AI-assisted engineering skills across the organisation.</a:t>
             </a:r>
             <a:endParaRPr lang="en-US" dirty="0"/>
           </a:p>
@@ -4575,14 +4575,14 @@
       </p:sp>
       <p:sp>
         <p:nvSpPr>
-          <p:cNvPr id="3" name="objhead-left"/>
+          <p:cNvPr id="3" name="flowhead-src"/>
           <p:cNvSpPr txBox="1"/>
           <p:nvPr/>
         </p:nvSpPr>
         <p:spPr>
           <a:xfrm>
             <a:off x="548640" y="1280160"/>
-            <a:ext cx="4617720" cy="274320"/>
+            <a:ext cx="2377440" cy="274320"/>
           </a:xfrm>
           <a:prstGeom prst="rect">
             <a:avLst/>
@@ -4603,6 +4603,78 @@
                   <a:schemeClr val="tx2"/>
                 </a:solidFill>
               </a:rPr>
+              <a:t>OUR PROJECT</a:t>
+            </a:r>
+            <a:endParaRPr lang="en-US" sz="1100" dirty="0"/>
+          </a:p>
+        </p:txBody>
+      </p:sp>
+      <p:sp>
+        <p:nvSpPr>
+          <p:cNvPr id="4" name="flowhead-ev"/>
+          <p:cNvSpPr txBox="1"/>
+          <p:nvPr/>
+        </p:nvSpPr>
+        <p:spPr>
+          <a:xfrm>
+            <a:off x="3429000" y="1280160"/>
+            <a:ext cx="4069080" cy="274320"/>
+          </a:xfrm>
+          <a:prstGeom prst="rect">
+            <a:avLst/>
+          </a:prstGeom>
+          <a:noFill/>
+          <a:ln/>
+        </p:spPr>
+        <p:txBody>
+          <a:bodyPr wrap="square" lIns="0" tIns="0" rIns="0" bIns="0" rtlCol="0" anchor="t"/>
+          <a:lstStyle/>
+          <a:p>
+            <a:pPr indent="0" marL="0">
+              <a:buNone/>
+            </a:pPr>
+            <a:r>
+              <a:rPr lang="en-US" sz="1100" b="1" spc="100" kern="0" dirty="0">
+                <a:solidFill>
+                  <a:schemeClr val="tx2"/>
+                </a:solidFill>
+              </a:rPr>
+              <a:t>EVIDENCE</a:t>
+            </a:r>
+            <a:endParaRPr lang="en-US" sz="1100" dirty="0"/>
+          </a:p>
+        </p:txBody>
+      </p:sp>
+      <p:sp>
+        <p:nvSpPr>
+          <p:cNvPr id="5" name="flowhead-obj"/>
+          <p:cNvSpPr txBox="1"/>
+          <p:nvPr/>
+        </p:nvSpPr>
+        <p:spPr>
+          <a:xfrm>
+            <a:off x="8001000" y="1280160"/>
+            <a:ext cx="3639312" cy="274320"/>
+          </a:xfrm>
+          <a:prstGeom prst="rect">
+            <a:avLst/>
+          </a:prstGeom>
+          <a:noFill/>
+          <a:ln/>
+        </p:spPr>
+        <p:txBody>
+          <a:bodyPr wrap="square" lIns="0" tIns="0" rIns="0" bIns="0" rtlCol="0" anchor="t"/>
+          <a:lstStyle/>
+          <a:p>
+            <a:pPr indent="0" marL="0">
+              <a:buNone/>
+            </a:pPr>
+            <a:r>
+              <a:rPr lang="en-US" sz="1100" b="1" spc="100" kern="0" dirty="0">
+                <a:solidFill>
+                  <a:schemeClr val="tx2"/>
+                </a:solidFill>
+              </a:rPr>
               <a:t>2026 OBJECTIVE</a:t>
             </a:r>
             <a:endParaRPr lang="en-US" sz="1100" dirty="0"/>
@@ -4611,54 +4683,238 @@
       </p:sp>
       <p:sp>
         <p:nvSpPr>
-          <p:cNvPr id="4" name="objhead-right"/>
-          <p:cNvSpPr txBox="1"/>
-          <p:nvPr/>
-        </p:nvSpPr>
-        <p:spPr>
-          <a:xfrm>
-            <a:off x="5577840" y="1280160"/>
-            <a:ext cx="6062472" cy="274320"/>
-          </a:xfrm>
-          <a:prstGeom prst="rect">
-            <a:avLst/>
-          </a:prstGeom>
-          <a:noFill/>
-          <a:ln/>
-        </p:spPr>
-        <p:txBody>
-          <a:bodyPr wrap="square" lIns="0" tIns="0" rIns="0" bIns="0" rtlCol="0" anchor="t"/>
-          <a:lstStyle/>
-          <a:p>
-            <a:pPr indent="0" marL="0">
-              <a:buNone/>
-            </a:pPr>
-            <a:r>
-              <a:rPr lang="en-US" sz="1100" b="1" spc="100" kern="0" dirty="0">
-                <a:solidFill>
-                  <a:schemeClr val="tx2"/>
-                </a:solidFill>
-              </a:rPr>
-              <a:t>WHAT WE CONTRIBUTED</a:t>
-            </a:r>
-            <a:endParaRPr lang="en-US" sz="1100" dirty="0"/>
-          </a:p>
-        </p:txBody>
-      </p:sp>
-      <p:sp>
-        <p:nvSpPr>
-          <p:cNvPr id="5" name="objrow-0-objbox"/>
+          <p:cNvPr id="6" name="flow-src-box"/>
           <p:cNvSpPr/>
           <p:nvPr/>
         </p:nvSpPr>
         <p:spPr>
           <a:xfrm>
             <a:off x="548640" y="1645920"/>
-            <a:ext cx="4617720" cy="676656"/>
+            <a:ext cx="2377440" cy="4498848"/>
           </a:xfrm>
           <a:prstGeom prst="roundRect">
             <a:avLst>
-              <a:gd name="adj" fmla="val 16216"/>
+              <a:gd name="adj" fmla="val 4615"/>
+            </a:avLst>
+          </a:prstGeom>
+          <a:solidFill>
+            <a:schemeClr val="accent1"/>
+          </a:solidFill>
+          <a:ln/>
+        </p:spPr>
+      </p:sp>
+      <p:sp>
+        <p:nvSpPr>
+          <p:cNvPr id="7" name="flow-src-text"/>
+          <p:cNvSpPr txBox="1"/>
+          <p:nvPr/>
+        </p:nvSpPr>
+        <p:spPr>
+          <a:xfrm>
+            <a:off x="777240" y="1920240"/>
+            <a:ext cx="1920240" cy="3950208"/>
+          </a:xfrm>
+          <a:prstGeom prst="rect">
+            <a:avLst/>
+          </a:prstGeom>
+          <a:noFill/>
+          <a:ln/>
+        </p:spPr>
+        <p:txBody>
+          <a:bodyPr wrap="square" lIns="0" tIns="0" rIns="0" bIns="0" rtlCol="0" anchor="ctr"/>
+          <a:lstStyle/>
+          <a:p>
+            <a:pPr indent="0" marL="0">
+              <a:buNone/>
+            </a:pPr>
+            <a:r>
+              <a:rPr lang="en-US" sz="2000" b="1" dirty="0">
+                <a:solidFill>
+                  <a:schemeClr val="tx1"/>
+                </a:solidFill>
+              </a:rPr>
+              <a:t>AI-assisted migration of ERM</a:t>
+            </a:r>
+            <a:endParaRPr lang="en-US" sz="2000" dirty="0"/>
+          </a:p>
+          <a:p>
+            <a:pPr indent="0" marL="0">
+              <a:buNone/>
+            </a:pPr>
+            <a:r>
+              <a:rPr lang="en-US" sz="1000" dirty="0">
+                <a:solidFill>
+                  <a:srgbClr val="000000"/>
+                </a:solidFill>
+              </a:rPr>
+              <a:t> </a:t>
+            </a:r>
+            <a:endParaRPr lang="en-US" sz="2000" dirty="0"/>
+          </a:p>
+          <a:p>
+            <a:pPr indent="0" marL="0">
+              <a:buNone/>
+            </a:pPr>
+            <a:r>
+              <a:rPr lang="en-US" sz="1400" dirty="0">
+                <a:solidFill>
+                  <a:schemeClr val="tx1"/>
+                </a:solidFill>
+              </a:rPr>
+              <a:t>Slate to React + OSDK</a:t>
+            </a:r>
+            <a:endParaRPr lang="en-US" sz="2000" dirty="0"/>
+          </a:p>
+          <a:p>
+            <a:pPr indent="0" marL="0">
+              <a:buNone/>
+            </a:pPr>
+            <a:r>
+              <a:rPr lang="en-US" sz="1400" dirty="0">
+                <a:solidFill>
+                  <a:schemeClr val="tx1"/>
+                </a:solidFill>
+              </a:rPr>
+              <a:t>2 developers · 1 PI</a:t>
+            </a:r>
+            <a:endParaRPr lang="en-US" sz="2000" dirty="0"/>
+          </a:p>
+          <a:p>
+            <a:pPr indent="0" marL="0">
+              <a:buNone/>
+            </a:pPr>
+            <a:r>
+              <a:rPr lang="en-US" sz="1400" dirty="0">
+                <a:solidFill>
+                  <a:schemeClr val="tx1"/>
+                </a:solidFill>
+              </a:rPr>
+              <a:t>pack-project.ts</a:t>
+            </a:r>
+            <a:endParaRPr lang="en-US" sz="2000" dirty="0"/>
+          </a:p>
+        </p:txBody>
+      </p:sp>
+      <p:sp>
+        <p:nvSpPr>
+          <p:cNvPr id="8" name="flow-0-arrow1"/>
+          <p:cNvSpPr/>
+          <p:nvPr/>
+        </p:nvSpPr>
+        <p:spPr>
+          <a:xfrm>
+            <a:off x="2971800" y="2139696"/>
+            <a:ext cx="411480" cy="0"/>
+          </a:xfrm>
+          <a:prstGeom prst="line">
+            <a:avLst/>
+          </a:prstGeom>
+          <a:noFill/>
+          <a:ln w="22225">
+            <a:solidFill>
+              <a:schemeClr val="tx2"/>
+            </a:solidFill>
+            <a:prstDash val="solid"/>
+            <a:tailEnd type="triangle"/>
+          </a:ln>
+        </p:spPr>
+      </p:sp>
+      <p:sp>
+        <p:nvSpPr>
+          <p:cNvPr id="9" name="flow-0-evbox"/>
+          <p:cNvSpPr/>
+          <p:nvPr/>
+        </p:nvSpPr>
+        <p:spPr>
+          <a:xfrm>
+            <a:off x="3429000" y="1645920"/>
+            <a:ext cx="4069080" cy="987552"/>
+          </a:xfrm>
+          <a:prstGeom prst="roundRect">
+            <a:avLst>
+              <a:gd name="adj" fmla="val 11111"/>
+            </a:avLst>
+          </a:prstGeom>
+          <a:solidFill>
+            <a:schemeClr val="bg2"/>
+          </a:solidFill>
+          <a:ln/>
+        </p:spPr>
+      </p:sp>
+      <p:sp>
+        <p:nvSpPr>
+          <p:cNvPr id="10" name="flow-0-evtext"/>
+          <p:cNvSpPr txBox="1"/>
+          <p:nvPr/>
+        </p:nvSpPr>
+        <p:spPr>
+          <a:xfrm>
+            <a:off x="3611880" y="1737360"/>
+            <a:ext cx="3703320" cy="804672"/>
+          </a:xfrm>
+          <a:prstGeom prst="rect">
+            <a:avLst/>
+          </a:prstGeom>
+          <a:noFill/>
+          <a:ln/>
+        </p:spPr>
+        <p:txBody>
+          <a:bodyPr wrap="square" lIns="0" tIns="0" rIns="0" bIns="0" rtlCol="0" anchor="ctr"/>
+          <a:lstStyle/>
+          <a:p>
+            <a:pPr indent="0" marL="0">
+              <a:buNone/>
+            </a:pPr>
+            <a:r>
+              <a:rPr lang="en-US" sz="1400" dirty="0">
+                <a:solidFill>
+                  <a:schemeClr val="tx1"/>
+                </a:solidFill>
+              </a:rPr>
+              <a:t>AI read 8 Slate exports and the packed React code: 105 features recovered, 31 gaps found</a:t>
+            </a:r>
+            <a:endParaRPr lang="en-US" sz="1400" dirty="0"/>
+          </a:p>
+        </p:txBody>
+      </p:sp>
+      <p:sp>
+        <p:nvSpPr>
+          <p:cNvPr id="11" name="flow-0-arrow2"/>
+          <p:cNvSpPr/>
+          <p:nvPr/>
+        </p:nvSpPr>
+        <p:spPr>
+          <a:xfrm>
+            <a:off x="7543800" y="2139696"/>
+            <a:ext cx="411480" cy="0"/>
+          </a:xfrm>
+          <a:prstGeom prst="line">
+            <a:avLst/>
+          </a:prstGeom>
+          <a:noFill/>
+          <a:ln w="22225">
+            <a:solidFill>
+              <a:schemeClr val="tx2"/>
+            </a:solidFill>
+            <a:prstDash val="solid"/>
+            <a:tailEnd type="triangle"/>
+          </a:ln>
+        </p:spPr>
+      </p:sp>
+      <p:sp>
+        <p:nvSpPr>
+          <p:cNvPr id="12" name="flow-0-objbox"/>
+          <p:cNvSpPr/>
+          <p:nvPr/>
+        </p:nvSpPr>
+        <p:spPr>
+          <a:xfrm>
+            <a:off x="8001000" y="1645920"/>
+            <a:ext cx="3639312" cy="987552"/>
+          </a:xfrm>
+          <a:prstGeom prst="roundRect">
+            <a:avLst>
+              <a:gd name="adj" fmla="val 11111"/>
             </a:avLst>
           </a:prstGeom>
           <a:solidFill>
@@ -4669,14 +4925,14 @@
       </p:sp>
       <p:sp>
         <p:nvSpPr>
-          <p:cNvPr id="6" name="objrow-0-objtext"/>
+          <p:cNvPr id="13" name="flow-0-objtext"/>
           <p:cNvSpPr txBox="1"/>
           <p:nvPr/>
         </p:nvSpPr>
         <p:spPr>
           <a:xfrm>
-            <a:off x="731520" y="1719072"/>
-            <a:ext cx="4297680" cy="530352"/>
+            <a:off x="8183880" y="1737360"/>
+            <a:ext cx="3273552" cy="804672"/>
           </a:xfrm>
           <a:prstGeom prst="rect">
             <a:avLst/>
@@ -4692,14 +4948,14 @@
               <a:buNone/>
             </a:pPr>
             <a:r>
-              <a:rPr lang="en-US" sz="1300" b="1" dirty="0">
+              <a:rPr lang="en-US" sz="1500" b="1" dirty="0">
                 <a:solidFill>
                   <a:schemeClr val="bg1"/>
                 </a:solidFill>
               </a:rPr>
               <a:t>Leverage AI to solve business problems</a:t>
             </a:r>
-            <a:endParaRPr lang="en-US" sz="1300" dirty="0"/>
+            <a:endParaRPr lang="en-US" sz="1500" dirty="0"/>
           </a:p>
           <a:p>
             <a:pPr indent="0" marL="0">
@@ -4711,51 +4967,50 @@
                   <a:schemeClr val="accent5"/>
                 </a:solidFill>
               </a:rPr>
-              <a:t>Digital: democratise AI · India TFO</a:t>
-            </a:r>
-            <a:endParaRPr lang="en-US" sz="1300" dirty="0"/>
-          </a:p>
-        </p:txBody>
-      </p:sp>
-      <p:sp>
-        <p:nvSpPr>
-          <p:cNvPr id="7" name="objrow-0-arrow"/>
+              <a:t>India TFO · Digital: democratise AI</a:t>
+            </a:r>
+            <a:endParaRPr lang="en-US" sz="1500" dirty="0"/>
+          </a:p>
+        </p:txBody>
+      </p:sp>
+      <p:sp>
+        <p:nvSpPr>
+          <p:cNvPr id="14" name="flow-1-arrow1"/>
           <p:cNvSpPr/>
           <p:nvPr/>
         </p:nvSpPr>
         <p:spPr>
           <a:xfrm>
-            <a:off x="5248656" y="1856232"/>
-            <a:ext cx="237744" cy="256032"/>
-          </a:xfrm>
-          <a:prstGeom prst="rightArrow">
-            <a:avLst/>
-          </a:prstGeom>
-          <a:solidFill>
-            <a:schemeClr val="accent1"/>
-          </a:solidFill>
-          <a:ln w="12700">
+            <a:off x="2971800" y="3310128"/>
+            <a:ext cx="411480" cy="0"/>
+          </a:xfrm>
+          <a:prstGeom prst="line">
+            <a:avLst/>
+          </a:prstGeom>
+          <a:noFill/>
+          <a:ln w="22225">
             <a:solidFill>
-              <a:schemeClr val="accent1"/>
+              <a:schemeClr val="tx2"/>
             </a:solidFill>
             <a:prstDash val="solid"/>
+            <a:tailEnd type="triangle"/>
           </a:ln>
         </p:spPr>
       </p:sp>
       <p:sp>
         <p:nvSpPr>
-          <p:cNvPr id="8" name="objrow-0-contribbox"/>
+          <p:cNvPr id="15" name="flow-1-evbox"/>
           <p:cNvSpPr/>
           <p:nvPr/>
         </p:nvSpPr>
         <p:spPr>
           <a:xfrm>
-            <a:off x="5577840" y="1645920"/>
-            <a:ext cx="6062472" cy="676656"/>
+            <a:off x="3429000" y="2816352"/>
+            <a:ext cx="4069080" cy="987552"/>
           </a:xfrm>
           <a:prstGeom prst="roundRect">
             <a:avLst>
-              <a:gd name="adj" fmla="val 16216"/>
+              <a:gd name="adj" fmla="val 11111"/>
             </a:avLst>
           </a:prstGeom>
           <a:solidFill>
@@ -4766,14 +5021,14 @@
       </p:sp>
       <p:sp>
         <p:nvSpPr>
-          <p:cNvPr id="9" name="objrow-0-contribtext"/>
+          <p:cNvPr id="16" name="flow-1-evtext"/>
           <p:cNvSpPr txBox="1"/>
           <p:nvPr/>
         </p:nvSpPr>
         <p:spPr>
           <a:xfrm>
-            <a:off x="5760720" y="1719072"/>
-            <a:ext cx="5696712" cy="530352"/>
+            <a:off x="3611880" y="2907792"/>
+            <a:ext cx="3703320" cy="804672"/>
           </a:xfrm>
           <a:prstGeom prst="rect">
             <a:avLst/>
@@ -4794,7 +5049,7 @@
                   <a:schemeClr val="tx1"/>
                 </a:solidFill>
               </a:rPr>
-              <a:t>AI-assisted migration of an undocumented, multi-module app, packaged as a reusable playbook</a:t>
+              <a:t>Delivered in 1 PI by 2 developers, about 76% less effort than a manual estimate</a:t>
             </a:r>
             <a:endParaRPr lang="en-US" sz="1400" dirty="0"/>
           </a:p>
@@ -4802,18 +5057,42 @@
       </p:sp>
       <p:sp>
         <p:nvSpPr>
-          <p:cNvPr id="10" name="objrow-1-objbox"/>
+          <p:cNvPr id="17" name="flow-1-arrow2"/>
           <p:cNvSpPr/>
           <p:nvPr/>
         </p:nvSpPr>
         <p:spPr>
           <a:xfrm>
-            <a:off x="548640" y="2432304"/>
-            <a:ext cx="4617720" cy="676656"/>
+            <a:off x="7543800" y="3310128"/>
+            <a:ext cx="411480" cy="0"/>
+          </a:xfrm>
+          <a:prstGeom prst="line">
+            <a:avLst/>
+          </a:prstGeom>
+          <a:noFill/>
+          <a:ln w="22225">
+            <a:solidFill>
+              <a:schemeClr val="tx2"/>
+            </a:solidFill>
+            <a:prstDash val="solid"/>
+            <a:tailEnd type="triangle"/>
+          </a:ln>
+        </p:spPr>
+      </p:sp>
+      <p:sp>
+        <p:nvSpPr>
+          <p:cNvPr id="18" name="flow-1-objbox"/>
+          <p:cNvSpPr/>
+          <p:nvPr/>
+        </p:nvSpPr>
+        <p:spPr>
+          <a:xfrm>
+            <a:off x="8001000" y="2816352"/>
+            <a:ext cx="3639312" cy="987552"/>
           </a:xfrm>
           <a:prstGeom prst="roundRect">
             <a:avLst>
-              <a:gd name="adj" fmla="val 16216"/>
+              <a:gd name="adj" fmla="val 11111"/>
             </a:avLst>
           </a:prstGeom>
           <a:solidFill>
@@ -4824,14 +5103,14 @@
       </p:sp>
       <p:sp>
         <p:nvSpPr>
-          <p:cNvPr id="11" name="objrow-1-objtext"/>
+          <p:cNvPr id="19" name="flow-1-objtext"/>
           <p:cNvSpPr txBox="1"/>
           <p:nvPr/>
         </p:nvSpPr>
         <p:spPr>
           <a:xfrm>
-            <a:off x="731520" y="2505456"/>
-            <a:ext cx="4297680" cy="530352"/>
+            <a:off x="8183880" y="2907792"/>
+            <a:ext cx="3273552" cy="804672"/>
           </a:xfrm>
           <a:prstGeom prst="rect">
             <a:avLst/>
@@ -4847,14 +5126,14 @@
               <a:buNone/>
             </a:pPr>
             <a:r>
-              <a:rPr lang="en-US" sz="1300" b="1" dirty="0">
+              <a:rPr lang="en-US" sz="1500" b="1" dirty="0">
                 <a:solidFill>
                   <a:schemeClr val="bg1"/>
                 </a:solidFill>
               </a:rPr>
               <a:t>Deliver on time, on cost, on quality</a:t>
             </a:r>
-            <a:endParaRPr lang="en-US" sz="1300" dirty="0"/>
+            <a:endParaRPr lang="en-US" sz="1500" dirty="0"/>
           </a:p>
           <a:p>
             <a:pPr indent="0" marL="0">
@@ -4866,51 +5145,50 @@
                   <a:schemeClr val="accent5"/>
                 </a:solidFill>
               </a:rPr>
-              <a:t>Digital: optimise our resources · Company: financial</a:t>
-            </a:r>
-            <a:endParaRPr lang="en-US" sz="1300" dirty="0"/>
-          </a:p>
-        </p:txBody>
-      </p:sp>
-      <p:sp>
-        <p:nvSpPr>
-          <p:cNvPr id="12" name="objrow-1-arrow"/>
+              <a:t>Digital: optimise our digital resources</a:t>
+            </a:r>
+            <a:endParaRPr lang="en-US" sz="1500" dirty="0"/>
+          </a:p>
+        </p:txBody>
+      </p:sp>
+      <p:sp>
+        <p:nvSpPr>
+          <p:cNvPr id="20" name="flow-2-arrow1"/>
           <p:cNvSpPr/>
           <p:nvPr/>
         </p:nvSpPr>
         <p:spPr>
           <a:xfrm>
-            <a:off x="5248656" y="2642616"/>
-            <a:ext cx="237744" cy="256032"/>
-          </a:xfrm>
-          <a:prstGeom prst="rightArrow">
-            <a:avLst/>
-          </a:prstGeom>
-          <a:solidFill>
-            <a:schemeClr val="accent1"/>
-          </a:solidFill>
-          <a:ln w="12700">
+            <a:off x="2971800" y="4480560"/>
+            <a:ext cx="411480" cy="0"/>
+          </a:xfrm>
+          <a:prstGeom prst="line">
+            <a:avLst/>
+          </a:prstGeom>
+          <a:noFill/>
+          <a:ln w="22225">
             <a:solidFill>
-              <a:schemeClr val="accent1"/>
+              <a:schemeClr val="tx2"/>
             </a:solidFill>
             <a:prstDash val="solid"/>
+            <a:tailEnd type="triangle"/>
           </a:ln>
         </p:spPr>
       </p:sp>
       <p:sp>
         <p:nvSpPr>
-          <p:cNvPr id="13" name="objrow-1-contribbox"/>
+          <p:cNvPr id="21" name="flow-2-evbox"/>
           <p:cNvSpPr/>
           <p:nvPr/>
         </p:nvSpPr>
         <p:spPr>
           <a:xfrm>
-            <a:off x="5577840" y="2432304"/>
-            <a:ext cx="6062472" cy="676656"/>
+            <a:off x="3429000" y="3986784"/>
+            <a:ext cx="4069080" cy="987552"/>
           </a:xfrm>
           <a:prstGeom prst="roundRect">
             <a:avLst>
-              <a:gd name="adj" fmla="val 16216"/>
+              <a:gd name="adj" fmla="val 11111"/>
             </a:avLst>
           </a:prstGeom>
           <a:solidFill>
@@ -4921,14 +5199,14 @@
       </p:sp>
       <p:sp>
         <p:nvSpPr>
-          <p:cNvPr id="14" name="objrow-1-contribtext"/>
+          <p:cNvPr id="22" name="flow-2-evtext"/>
           <p:cNvSpPr txBox="1"/>
           <p:nvPr/>
         </p:nvSpPr>
         <p:spPr>
           <a:xfrm>
-            <a:off x="5760720" y="2505456"/>
-            <a:ext cx="5696712" cy="530352"/>
+            <a:off x="3611880" y="4078224"/>
+            <a:ext cx="3703320" cy="804672"/>
           </a:xfrm>
           <a:prstGeom prst="rect">
             <a:avLst/>
@@ -4949,7 +5227,7 @@
                   <a:schemeClr val="tx1"/>
                 </a:solidFill>
               </a:rPr>
-              <a:t>2 developers, 1 PI, about 76% less effort than a manual estimate</a:t>
+              <a:t>All 105 features tracked for parity; ERM moved off legacy Slate onto a standard, maintainable stack</a:t>
             </a:r>
             <a:endParaRPr lang="en-US" sz="1400" dirty="0"/>
           </a:p>
@@ -4957,18 +5235,42 @@
       </p:sp>
       <p:sp>
         <p:nvSpPr>
-          <p:cNvPr id="15" name="objrow-2-objbox"/>
+          <p:cNvPr id="23" name="flow-2-arrow2"/>
           <p:cNvSpPr/>
           <p:nvPr/>
         </p:nvSpPr>
         <p:spPr>
           <a:xfrm>
-            <a:off x="548640" y="3218688"/>
-            <a:ext cx="4617720" cy="676656"/>
+            <a:off x="7543800" y="4480560"/>
+            <a:ext cx="411480" cy="0"/>
+          </a:xfrm>
+          <a:prstGeom prst="line">
+            <a:avLst/>
+          </a:prstGeom>
+          <a:noFill/>
+          <a:ln w="22225">
+            <a:solidFill>
+              <a:schemeClr val="tx2"/>
+            </a:solidFill>
+            <a:prstDash val="solid"/>
+            <a:tailEnd type="triangle"/>
+          </a:ln>
+        </p:spPr>
+      </p:sp>
+      <p:sp>
+        <p:nvSpPr>
+          <p:cNvPr id="24" name="flow-2-objbox"/>
+          <p:cNvSpPr/>
+          <p:nvPr/>
+        </p:nvSpPr>
+        <p:spPr>
+          <a:xfrm>
+            <a:off x="8001000" y="3986784"/>
+            <a:ext cx="3639312" cy="987552"/>
           </a:xfrm>
           <a:prstGeom prst="roundRect">
             <a:avLst>
-              <a:gd name="adj" fmla="val 16216"/>
+              <a:gd name="adj" fmla="val 11111"/>
             </a:avLst>
           </a:prstGeom>
           <a:solidFill>
@@ -4979,14 +5281,14 @@
       </p:sp>
       <p:sp>
         <p:nvSpPr>
-          <p:cNvPr id="16" name="objrow-2-objtext"/>
+          <p:cNvPr id="25" name="flow-2-objtext"/>
           <p:cNvSpPr txBox="1"/>
           <p:nvPr/>
         </p:nvSpPr>
         <p:spPr>
           <a:xfrm>
-            <a:off x="731520" y="3291840"/>
-            <a:ext cx="4297680" cy="530352"/>
+            <a:off x="8183880" y="4078224"/>
+            <a:ext cx="3273552" cy="804672"/>
           </a:xfrm>
           <a:prstGeom prst="rect">
             <a:avLst/>
@@ -5002,14 +5304,14 @@
               <a:buNone/>
             </a:pPr>
             <a:r>
-              <a:rPr lang="en-US" sz="1300" b="1" dirty="0">
+              <a:rPr lang="en-US" sz="1500" b="1" dirty="0">
                 <a:solidFill>
                   <a:schemeClr val="bg1"/>
                 </a:solidFill>
               </a:rPr>
-              <a:t>Manage our risks</a:t>
-            </a:r>
-            <a:endParaRPr lang="en-US" sz="1300" dirty="0"/>
+              <a:t>Ensure our operational performance</a:t>
+            </a:r>
+            <a:endParaRPr lang="en-US" sz="1500" dirty="0"/>
           </a:p>
           <a:p>
             <a:pPr indent="0" marL="0">
@@ -5021,51 +5323,50 @@
                   <a:schemeClr val="accent5"/>
                 </a:solidFill>
               </a:rPr>
-              <a:t>Digital: cybersecurity, compliance, dependencies</a:t>
-            </a:r>
-            <a:endParaRPr lang="en-US" sz="1300" dirty="0"/>
-          </a:p>
-        </p:txBody>
-      </p:sp>
-      <p:sp>
-        <p:nvSpPr>
-          <p:cNvPr id="17" name="objrow-2-arrow"/>
+              <a:t>Digital: availability of systems for operations</a:t>
+            </a:r>
+            <a:endParaRPr lang="en-US" sz="1500" dirty="0"/>
+          </a:p>
+        </p:txBody>
+      </p:sp>
+      <p:sp>
+        <p:nvSpPr>
+          <p:cNvPr id="26" name="flow-3-arrow1"/>
           <p:cNvSpPr/>
           <p:nvPr/>
         </p:nvSpPr>
         <p:spPr>
           <a:xfrm>
-            <a:off x="5248656" y="3429000"/>
-            <a:ext cx="237744" cy="256032"/>
-          </a:xfrm>
-          <a:prstGeom prst="rightArrow">
-            <a:avLst/>
-          </a:prstGeom>
-          <a:solidFill>
-            <a:schemeClr val="accent1"/>
-          </a:solidFill>
-          <a:ln w="12700">
+            <a:off x="2971800" y="5650992"/>
+            <a:ext cx="411480" cy="0"/>
+          </a:xfrm>
+          <a:prstGeom prst="line">
+            <a:avLst/>
+          </a:prstGeom>
+          <a:noFill/>
+          <a:ln w="22225">
             <a:solidFill>
-              <a:schemeClr val="accent1"/>
+              <a:schemeClr val="tx2"/>
             </a:solidFill>
             <a:prstDash val="solid"/>
+            <a:tailEnd type="triangle"/>
           </a:ln>
         </p:spPr>
       </p:sp>
       <p:sp>
         <p:nvSpPr>
-          <p:cNvPr id="18" name="objrow-2-contribbox"/>
+          <p:cNvPr id="27" name="flow-3-evbox"/>
           <p:cNvSpPr/>
           <p:nvPr/>
         </p:nvSpPr>
         <p:spPr>
           <a:xfrm>
-            <a:off x="5577840" y="3218688"/>
-            <a:ext cx="6062472" cy="676656"/>
+            <a:off x="3429000" y="5157216"/>
+            <a:ext cx="4069080" cy="987552"/>
           </a:xfrm>
           <a:prstGeom prst="roundRect">
             <a:avLst>
-              <a:gd name="adj" fmla="val 16216"/>
+              <a:gd name="adj" fmla="val 11111"/>
             </a:avLst>
           </a:prstGeom>
           <a:solidFill>
@@ -5076,14 +5377,14 @@
       </p:sp>
       <p:sp>
         <p:nvSpPr>
-          <p:cNvPr id="19" name="objrow-2-contribtext"/>
+          <p:cNvPr id="28" name="flow-3-evtext"/>
           <p:cNvSpPr txBox="1"/>
           <p:nvPr/>
         </p:nvSpPr>
         <p:spPr>
           <a:xfrm>
-            <a:off x="5760720" y="3291840"/>
-            <a:ext cx="5696712" cy="530352"/>
+            <a:off x="3611880" y="5248656"/>
+            <a:ext cx="3703320" cy="804672"/>
           </a:xfrm>
           <a:prstGeom prst="rect">
             <a:avLst/>
@@ -5104,7 +5405,7 @@
                   <a:schemeClr val="tx1"/>
                 </a:solidFill>
               </a:rPr>
-              <a:t>7 security and data-integrity issues caught in review; restricted views kept; off Slate onto standard React + OSDK</a:t>
+              <a:t>pack-project.ts and the playbook let any team repeat the method</a:t>
             </a:r>
             <a:endParaRPr lang="en-US" sz="1400" dirty="0"/>
           </a:p>
@@ -5112,18 +5413,42 @@
       </p:sp>
       <p:sp>
         <p:nvSpPr>
-          <p:cNvPr id="20" name="objrow-3-objbox"/>
+          <p:cNvPr id="29" name="flow-3-arrow2"/>
           <p:cNvSpPr/>
           <p:nvPr/>
         </p:nvSpPr>
         <p:spPr>
           <a:xfrm>
-            <a:off x="548640" y="4005072"/>
-            <a:ext cx="4617720" cy="676656"/>
+            <a:off x="7543800" y="5650992"/>
+            <a:ext cx="411480" cy="0"/>
+          </a:xfrm>
+          <a:prstGeom prst="line">
+            <a:avLst/>
+          </a:prstGeom>
+          <a:noFill/>
+          <a:ln w="22225">
+            <a:solidFill>
+              <a:schemeClr val="tx2"/>
+            </a:solidFill>
+            <a:prstDash val="solid"/>
+            <a:tailEnd type="triangle"/>
+          </a:ln>
+        </p:spPr>
+      </p:sp>
+      <p:sp>
+        <p:nvSpPr>
+          <p:cNvPr id="30" name="flow-3-objbox"/>
+          <p:cNvSpPr/>
+          <p:nvPr/>
+        </p:nvSpPr>
+        <p:spPr>
+          <a:xfrm>
+            <a:off x="8001000" y="5157216"/>
+            <a:ext cx="3639312" cy="987552"/>
           </a:xfrm>
           <a:prstGeom prst="roundRect">
             <a:avLst>
-              <a:gd name="adj" fmla="val 16216"/>
+              <a:gd name="adj" fmla="val 11111"/>
             </a:avLst>
           </a:prstGeom>
           <a:solidFill>
@@ -5134,14 +5459,14 @@
       </p:sp>
       <p:sp>
         <p:nvSpPr>
-          <p:cNvPr id="21" name="objrow-3-objtext"/>
+          <p:cNvPr id="31" name="flow-3-objtext"/>
           <p:cNvSpPr txBox="1"/>
           <p:nvPr/>
         </p:nvSpPr>
         <p:spPr>
           <a:xfrm>
-            <a:off x="731520" y="4078224"/>
-            <a:ext cx="4297680" cy="530352"/>
+            <a:off x="8183880" y="5248656"/>
+            <a:ext cx="3273552" cy="804672"/>
           </a:xfrm>
           <a:prstGeom prst="rect">
             <a:avLst/>
@@ -5157,14 +5482,14 @@
               <a:buNone/>
             </a:pPr>
             <a:r>
-              <a:rPr lang="en-US" sz="1300" b="1" dirty="0">
+              <a:rPr lang="en-US" sz="1500" b="1" dirty="0">
                 <a:solidFill>
                   <a:schemeClr val="bg1"/>
                 </a:solidFill>
               </a:rPr>
-              <a:t>Reinforce the Digital Design Authority</a:t>
-            </a:r>
-            <a:endParaRPr lang="en-US" sz="1300" dirty="0"/>
+              <a:t>Grow digital acumen and competencies</a:t>
+            </a:r>
+            <a:endParaRPr lang="en-US" sz="1500" dirty="0"/>
           </a:p>
           <a:p>
             <a:pPr indent="0" marL="0">
@@ -5176,402 +5501,9 @@
                   <a:schemeClr val="accent5"/>
                 </a:solidFill>
               </a:rPr>
-              <a:t>Digital: enable our future</a:t>
-            </a:r>
-            <a:endParaRPr lang="en-US" sz="1300" dirty="0"/>
-          </a:p>
-        </p:txBody>
-      </p:sp>
-      <p:sp>
-        <p:nvSpPr>
-          <p:cNvPr id="22" name="objrow-3-arrow"/>
-          <p:cNvSpPr/>
-          <p:nvPr/>
-        </p:nvSpPr>
-        <p:spPr>
-          <a:xfrm>
-            <a:off x="5248656" y="4215384"/>
-            <a:ext cx="237744" cy="256032"/>
-          </a:xfrm>
-          <a:prstGeom prst="rightArrow">
-            <a:avLst/>
-          </a:prstGeom>
-          <a:solidFill>
-            <a:schemeClr val="accent1"/>
-          </a:solidFill>
-          <a:ln w="12700">
-            <a:solidFill>
-              <a:schemeClr val="accent1"/>
-            </a:solidFill>
-            <a:prstDash val="solid"/>
-          </a:ln>
-        </p:spPr>
-      </p:sp>
-      <p:sp>
-        <p:nvSpPr>
-          <p:cNvPr id="23" name="objrow-3-contribbox"/>
-          <p:cNvSpPr/>
-          <p:nvPr/>
-        </p:nvSpPr>
-        <p:spPr>
-          <a:xfrm>
-            <a:off x="5577840" y="4005072"/>
-            <a:ext cx="6062472" cy="676656"/>
-          </a:xfrm>
-          <a:prstGeom prst="roundRect">
-            <a:avLst>
-              <a:gd name="adj" fmla="val 16216"/>
-            </a:avLst>
-          </a:prstGeom>
-          <a:solidFill>
-            <a:schemeClr val="bg2"/>
-          </a:solidFill>
-          <a:ln/>
-        </p:spPr>
-      </p:sp>
-      <p:sp>
-        <p:nvSpPr>
-          <p:cNvPr id="24" name="objrow-3-contribtext"/>
-          <p:cNvSpPr txBox="1"/>
-          <p:nvPr/>
-        </p:nvSpPr>
-        <p:spPr>
-          <a:xfrm>
-            <a:off x="5760720" y="4078224"/>
-            <a:ext cx="5696712" cy="530352"/>
-          </a:xfrm>
-          <a:prstGeom prst="rect">
-            <a:avLst/>
-          </a:prstGeom>
-          <a:noFill/>
-          <a:ln/>
-        </p:spPr>
-        <p:txBody>
-          <a:bodyPr wrap="square" lIns="0" tIns="0" rIns="0" bIns="0" rtlCol="0" anchor="ctr"/>
-          <a:lstStyle/>
-          <a:p>
-            <a:pPr indent="0" marL="0">
-              <a:buNone/>
-            </a:pPr>
-            <a:r>
-              <a:rPr lang="en-US" sz="1400" dirty="0">
-                <a:solidFill>
-                  <a:schemeClr val="tx1"/>
-                </a:solidFill>
-              </a:rPr>
-              <a:t>8 architecture and lifecycle diagrams; 105 features documented where nothing existed</a:t>
-            </a:r>
-            <a:endParaRPr lang="en-US" sz="1400" dirty="0"/>
-          </a:p>
-        </p:txBody>
-      </p:sp>
-      <p:sp>
-        <p:nvSpPr>
-          <p:cNvPr id="25" name="objrow-4-objbox"/>
-          <p:cNvSpPr/>
-          <p:nvPr/>
-        </p:nvSpPr>
-        <p:spPr>
-          <a:xfrm>
-            <a:off x="548640" y="4791456"/>
-            <a:ext cx="4617720" cy="676656"/>
-          </a:xfrm>
-          <a:prstGeom prst="roundRect">
-            <a:avLst>
-              <a:gd name="adj" fmla="val 16216"/>
-            </a:avLst>
-          </a:prstGeom>
-          <a:solidFill>
-            <a:schemeClr val="tx1"/>
-          </a:solidFill>
-          <a:ln/>
-        </p:spPr>
-      </p:sp>
-      <p:sp>
-        <p:nvSpPr>
-          <p:cNvPr id="26" name="objrow-4-objtext"/>
-          <p:cNvSpPr txBox="1"/>
-          <p:nvPr/>
-        </p:nvSpPr>
-        <p:spPr>
-          <a:xfrm>
-            <a:off x="731520" y="4864608"/>
-            <a:ext cx="4297680" cy="530352"/>
-          </a:xfrm>
-          <a:prstGeom prst="rect">
-            <a:avLst/>
-          </a:prstGeom>
-          <a:noFill/>
-          <a:ln/>
-        </p:spPr>
-        <p:txBody>
-          <a:bodyPr wrap="square" lIns="0" tIns="0" rIns="0" bIns="0" rtlCol="0" anchor="ctr"/>
-          <a:lstStyle/>
-          <a:p>
-            <a:pPr indent="0" marL="0">
-              <a:buNone/>
-            </a:pPr>
-            <a:r>
-              <a:rPr lang="en-US" sz="1300" b="1" dirty="0">
-                <a:solidFill>
-                  <a:schemeClr val="bg1"/>
-                </a:solidFill>
-              </a:rPr>
-              <a:t>Grow digital acumen and competencies</a:t>
-            </a:r>
-            <a:endParaRPr lang="en-US" sz="1300" dirty="0"/>
-          </a:p>
-          <a:p>
-            <a:pPr indent="0" marL="0">
-              <a:buNone/>
-            </a:pPr>
-            <a:r>
-              <a:rPr lang="en-US" sz="1100" dirty="0">
-                <a:solidFill>
-                  <a:schemeClr val="accent5"/>
-                </a:solidFill>
-              </a:rPr>
               <a:t>Digital: develop our people · India TFO</a:t>
             </a:r>
-            <a:endParaRPr lang="en-US" sz="1300" dirty="0"/>
-          </a:p>
-        </p:txBody>
-      </p:sp>
-      <p:sp>
-        <p:nvSpPr>
-          <p:cNvPr id="27" name="objrow-4-arrow"/>
-          <p:cNvSpPr/>
-          <p:nvPr/>
-        </p:nvSpPr>
-        <p:spPr>
-          <a:xfrm>
-            <a:off x="5248656" y="5001768"/>
-            <a:ext cx="237744" cy="256032"/>
-          </a:xfrm>
-          <a:prstGeom prst="rightArrow">
-            <a:avLst/>
-          </a:prstGeom>
-          <a:solidFill>
-            <a:schemeClr val="accent1"/>
-          </a:solidFill>
-          <a:ln w="12700">
-            <a:solidFill>
-              <a:schemeClr val="accent1"/>
-            </a:solidFill>
-            <a:prstDash val="solid"/>
-          </a:ln>
-        </p:spPr>
-      </p:sp>
-      <p:sp>
-        <p:nvSpPr>
-          <p:cNvPr id="28" name="objrow-4-contribbox"/>
-          <p:cNvSpPr/>
-          <p:nvPr/>
-        </p:nvSpPr>
-        <p:spPr>
-          <a:xfrm>
-            <a:off x="5577840" y="4791456"/>
-            <a:ext cx="6062472" cy="676656"/>
-          </a:xfrm>
-          <a:prstGeom prst="roundRect">
-            <a:avLst>
-              <a:gd name="adj" fmla="val 16216"/>
-            </a:avLst>
-          </a:prstGeom>
-          <a:solidFill>
-            <a:schemeClr val="bg2"/>
-          </a:solidFill>
-          <a:ln/>
-        </p:spPr>
-      </p:sp>
-      <p:sp>
-        <p:nvSpPr>
-          <p:cNvPr id="29" name="objrow-4-contribtext"/>
-          <p:cNvSpPr txBox="1"/>
-          <p:nvPr/>
-        </p:nvSpPr>
-        <p:spPr>
-          <a:xfrm>
-            <a:off x="5760720" y="4864608"/>
-            <a:ext cx="5696712" cy="530352"/>
-          </a:xfrm>
-          <a:prstGeom prst="rect">
-            <a:avLst/>
-          </a:prstGeom>
-          <a:noFill/>
-          <a:ln/>
-        </p:spPr>
-        <p:txBody>
-          <a:bodyPr wrap="square" lIns="0" tIns="0" rIns="0" bIns="0" rtlCol="0" anchor="ctr"/>
-          <a:lstStyle/>
-          <a:p>
-            <a:pPr indent="0" marL="0">
-              <a:buNone/>
-            </a:pPr>
-            <a:r>
-              <a:rPr lang="en-US" sz="1400" dirty="0">
-                <a:solidFill>
-                  <a:schemeClr val="tx1"/>
-                </a:solidFill>
-              </a:rPr>
-              <a:t>pack-project.ts and the playbook let other teams repeat the method</a:t>
-            </a:r>
-            <a:endParaRPr lang="en-US" sz="1400" dirty="0"/>
-          </a:p>
-        </p:txBody>
-      </p:sp>
-      <p:sp>
-        <p:nvSpPr>
-          <p:cNvPr id="30" name="objrow-5-objbox"/>
-          <p:cNvSpPr/>
-          <p:nvPr/>
-        </p:nvSpPr>
-        <p:spPr>
-          <a:xfrm>
-            <a:off x="548640" y="5577840"/>
-            <a:ext cx="4617720" cy="676656"/>
-          </a:xfrm>
-          <a:prstGeom prst="roundRect">
-            <a:avLst>
-              <a:gd name="adj" fmla="val 16216"/>
-            </a:avLst>
-          </a:prstGeom>
-          <a:solidFill>
-            <a:schemeClr val="tx1"/>
-          </a:solidFill>
-          <a:ln/>
-        </p:spPr>
-      </p:sp>
-      <p:sp>
-        <p:nvSpPr>
-          <p:cNvPr id="31" name="objrow-5-objtext"/>
-          <p:cNvSpPr txBox="1"/>
-          <p:nvPr/>
-        </p:nvSpPr>
-        <p:spPr>
-          <a:xfrm>
-            <a:off x="731520" y="5650992"/>
-            <a:ext cx="4297680" cy="530352"/>
-          </a:xfrm>
-          <a:prstGeom prst="rect">
-            <a:avLst/>
-          </a:prstGeom>
-          <a:noFill/>
-          <a:ln/>
-        </p:spPr>
-        <p:txBody>
-          <a:bodyPr wrap="square" lIns="0" tIns="0" rIns="0" bIns="0" rtlCol="0" anchor="ctr"/>
-          <a:lstStyle/>
-          <a:p>
-            <a:pPr indent="0" marL="0">
-              <a:buNone/>
-            </a:pPr>
-            <a:r>
-              <a:rPr lang="en-US" sz="1300" b="1" dirty="0">
-                <a:solidFill>
-                  <a:schemeClr val="bg1"/>
-                </a:solidFill>
-              </a:rPr>
-              <a:t>Increase customer satisfaction</a:t>
-            </a:r>
-            <a:endParaRPr lang="en-US" sz="1300" dirty="0"/>
-          </a:p>
-          <a:p>
-            <a:pPr indent="0" marL="0">
-              <a:buNone/>
-            </a:pPr>
-            <a:r>
-              <a:rPr lang="en-US" sz="1100" dirty="0">
-                <a:solidFill>
-                  <a:schemeClr val="accent5"/>
-                </a:solidFill>
-              </a:rPr>
-              <a:t>Company: customer</a:t>
-            </a:r>
-            <a:endParaRPr lang="en-US" sz="1300" dirty="0"/>
-          </a:p>
-        </p:txBody>
-      </p:sp>
-      <p:sp>
-        <p:nvSpPr>
-          <p:cNvPr id="32" name="objrow-5-arrow"/>
-          <p:cNvSpPr/>
-          <p:nvPr/>
-        </p:nvSpPr>
-        <p:spPr>
-          <a:xfrm>
-            <a:off x="5248656" y="5788152"/>
-            <a:ext cx="237744" cy="256032"/>
-          </a:xfrm>
-          <a:prstGeom prst="rightArrow">
-            <a:avLst/>
-          </a:prstGeom>
-          <a:solidFill>
-            <a:schemeClr val="accent1"/>
-          </a:solidFill>
-          <a:ln w="12700">
-            <a:solidFill>
-              <a:schemeClr val="accent1"/>
-            </a:solidFill>
-            <a:prstDash val="solid"/>
-          </a:ln>
-        </p:spPr>
-      </p:sp>
-      <p:sp>
-        <p:nvSpPr>
-          <p:cNvPr id="33" name="objrow-5-contribbox"/>
-          <p:cNvSpPr/>
-          <p:nvPr/>
-        </p:nvSpPr>
-        <p:spPr>
-          <a:xfrm>
-            <a:off x="5577840" y="5577840"/>
-            <a:ext cx="6062472" cy="676656"/>
-          </a:xfrm>
-          <a:prstGeom prst="roundRect">
-            <a:avLst>
-              <a:gd name="adj" fmla="val 16216"/>
-            </a:avLst>
-          </a:prstGeom>
-          <a:solidFill>
-            <a:schemeClr val="bg2"/>
-          </a:solidFill>
-          <a:ln/>
-        </p:spPr>
-      </p:sp>
-      <p:sp>
-        <p:nvSpPr>
-          <p:cNvPr id="34" name="objrow-5-contribtext"/>
-          <p:cNvSpPr txBox="1"/>
-          <p:nvPr/>
-        </p:nvSpPr>
-        <p:spPr>
-          <a:xfrm>
-            <a:off x="5760720" y="5650992"/>
-            <a:ext cx="5696712" cy="530352"/>
-          </a:xfrm>
-          <a:prstGeom prst="rect">
-            <a:avLst/>
-          </a:prstGeom>
-          <a:noFill/>
-          <a:ln/>
-        </p:spPr>
-        <p:txBody>
-          <a:bodyPr wrap="square" lIns="0" tIns="0" rIns="0" bIns="0" rtlCol="0" anchor="ctr"/>
-          <a:lstStyle/>
-          <a:p>
-            <a:pPr indent="0" marL="0">
-              <a:buNone/>
-            </a:pPr>
-            <a:r>
-              <a:rPr lang="en-US" sz="1400" dirty="0">
-                <a:solidFill>
-                  <a:schemeClr val="tx1"/>
-                </a:solidFill>
-              </a:rPr>
-              <a:t>5 enhancements for ERM users, such as the report slideshow and resizable tables</a:t>
-            </a:r>
-            <a:endParaRPr lang="en-US" sz="1400" dirty="0"/>
+            <a:endParaRPr lang="en-US" sz="1500" dirty="0"/>
           </a:p>
         </p:txBody>
       </p:sp>
@@ -5592,7 +5524,7 @@
               <p:cTn id="2" dur="indefinite" nodeType="mainSeq">
                 <p:childTnLst>
                   <p:par>
-                    <p:cTn id="99" fill="hold">
+                    <p:cTn id="86" fill="hold">
                       <p:stCondLst>
                         <p:cond delay="indefinite"/>
                         <p:cond evt="onBegin" delay="0">
@@ -5601,7 +5533,7 @@
                       </p:stCondLst>
                       <p:childTnLst>
                         <p:par>
-                          <p:cTn id="18" fill="hold">
+                          <p:cTn id="9" fill="hold">
                             <p:stCondLst>
                               <p:cond delay="0"/>
                             </p:stCondLst>
@@ -5620,7 +5552,7 @@
                                           </p:stCondLst>
                                         </p:cTn>
                                         <p:tgtEl>
-                                          <p:spTgt spid="5"/>
+                                          <p:spTgt spid="6"/>
                                         </p:tgtEl>
                                         <p:attrNameLst>
                                           <p:attrName>style.visibility</p:attrName>
@@ -5634,7 +5566,7 @@
                                       <p:cBhvr>
                                         <p:cTn id="5" dur="450"/>
                                         <p:tgtEl>
-                                          <p:spTgt spid="5"/>
+                                          <p:spTgt spid="6"/>
                                         </p:tgtEl>
                                       </p:cBhvr>
                                     </p:animEffect>
@@ -5655,7 +5587,7 @@
                                           </p:stCondLst>
                                         </p:cTn>
                                         <p:tgtEl>
-                                          <p:spTgt spid="6"/>
+                                          <p:spTgt spid="7"/>
                                         </p:tgtEl>
                                         <p:attrNameLst>
                                           <p:attrName>style.visibility</p:attrName>
@@ -5669,41 +5601,6 @@
                                       <p:cBhvr>
                                         <p:cTn id="8" dur="450"/>
                                         <p:tgtEl>
-                                          <p:spTgt spid="6"/>
-                                        </p:tgtEl>
-                                      </p:cBhvr>
-                                    </p:animEffect>
-                                  </p:childTnLst>
-                                </p:cTn>
-                              </p:par>
-                              <p:par>
-                                <p:cTn id="9" presetID="22" presetClass="entr" presetSubtype="8" fill="hold" grpId="0" nodeType="withEffect">
-                                  <p:stCondLst>
-                                    <p:cond delay="200"/>
-                                  </p:stCondLst>
-                                  <p:childTnLst>
-                                    <p:set>
-                                      <p:cBhvr>
-                                        <p:cTn id="10" dur="1" fill="hold">
-                                          <p:stCondLst>
-                                            <p:cond delay="0"/>
-                                          </p:stCondLst>
-                                        </p:cTn>
-                                        <p:tgtEl>
-                                          <p:spTgt spid="7"/>
-                                        </p:tgtEl>
-                                        <p:attrNameLst>
-                                          <p:attrName>style.visibility</p:attrName>
-                                        </p:attrNameLst>
-                                      </p:cBhvr>
-                                      <p:to>
-                                        <p:strVal val="visible"/>
-                                      </p:to>
-                                    </p:set>
-                                    <p:animEffect transition="in" filter="wipe(left)">
-                                      <p:cBhvr>
-                                        <p:cTn id="11" dur="450"/>
-                                        <p:tgtEl>
                                           <p:spTgt spid="7"/>
                                         </p:tgtEl>
                                       </p:cBhvr>
@@ -5711,15 +5608,24 @@
                                   </p:childTnLst>
                                 </p:cTn>
                               </p:par>
+                            </p:childTnLst>
+                          </p:cTn>
+                        </p:par>
+                        <p:par>
+                          <p:cTn id="28" fill="hold">
+                            <p:stCondLst>
+                              <p:cond delay="1100"/>
+                            </p:stCondLst>
+                            <p:childTnLst>
                               <p:par>
-                                <p:cTn id="12" presetID="22" presetClass="entr" presetSubtype="8" fill="hold" grpId="0" nodeType="withEffect">
+                                <p:cTn id="10" presetID="22" presetClass="entr" presetSubtype="8" fill="hold" grpId="0" nodeType="afterEffect">
                                   <p:stCondLst>
-                                    <p:cond delay="300"/>
+                                    <p:cond delay="0"/>
                                   </p:stCondLst>
                                   <p:childTnLst>
                                     <p:set>
                                       <p:cBhvr>
-                                        <p:cTn id="13" dur="1" fill="hold">
+                                        <p:cTn id="11" dur="1" fill="hold">
                                           <p:stCondLst>
                                             <p:cond delay="0"/>
                                           </p:stCondLst>
@@ -5737,7 +5643,7 @@
                                     </p:set>
                                     <p:animEffect transition="in" filter="wipe(left)">
                                       <p:cBhvr>
-                                        <p:cTn id="14" dur="450"/>
+                                        <p:cTn id="12" dur="450"/>
                                         <p:tgtEl>
                                           <p:spTgt spid="8"/>
                                         </p:tgtEl>
@@ -5747,14 +5653,14 @@
                                 </p:cTn>
                               </p:par>
                               <p:par>
-                                <p:cTn id="15" presetID="22" presetClass="entr" presetSubtype="8" fill="hold" grpId="0" nodeType="withEffect">
+                                <p:cTn id="13" presetID="10" presetClass="entr" presetSubtype="0" fill="hold" grpId="0" nodeType="withEffect">
                                   <p:stCondLst>
-                                    <p:cond delay="300"/>
+                                    <p:cond delay="250"/>
                                   </p:stCondLst>
                                   <p:childTnLst>
                                     <p:set>
                                       <p:cBhvr>
-                                        <p:cTn id="16" dur="1" fill="hold">
+                                        <p:cTn id="14" dur="1" fill="hold">
                                           <p:stCondLst>
                                             <p:cond delay="0"/>
                                           </p:stCondLst>
@@ -5770,9 +5676,9 @@
                                         <p:strVal val="visible"/>
                                       </p:to>
                                     </p:set>
-                                    <p:animEffect transition="in" filter="wipe(left)">
+                                    <p:animEffect transition="in" filter="fade">
                                       <p:cBhvr>
-                                        <p:cTn id="17" dur="450"/>
+                                        <p:cTn id="15" dur="450"/>
                                         <p:tgtEl>
                                           <p:spTgt spid="9"/>
                                         </p:tgtEl>
@@ -5781,24 +5687,15 @@
                                   </p:childTnLst>
                                 </p:cTn>
                               </p:par>
-                            </p:childTnLst>
-                          </p:cTn>
-                        </p:par>
-                        <p:par>
-                          <p:cTn id="34" fill="hold">
-                            <p:stCondLst>
-                              <p:cond delay="650"/>
-                            </p:stCondLst>
-                            <p:childTnLst>
                               <p:par>
-                                <p:cTn id="19" presetID="10" presetClass="entr" presetSubtype="0" fill="hold" grpId="0" nodeType="afterEffect">
+                                <p:cTn id="16" presetID="10" presetClass="entr" presetSubtype="0" fill="hold" grpId="0" nodeType="withEffect">
                                   <p:stCondLst>
-                                    <p:cond delay="0"/>
+                                    <p:cond delay="250"/>
                                   </p:stCondLst>
                                   <p:childTnLst>
                                     <p:set>
                                       <p:cBhvr>
-                                        <p:cTn id="20" dur="1" fill="hold">
+                                        <p:cTn id="17" dur="1" fill="hold">
                                           <p:stCondLst>
                                             <p:cond delay="0"/>
                                           </p:stCondLst>
@@ -5816,7 +5713,7 @@
                                     </p:set>
                                     <p:animEffect transition="in" filter="fade">
                                       <p:cBhvr>
-                                        <p:cTn id="21" dur="450"/>
+                                        <p:cTn id="18" dur="450"/>
                                         <p:tgtEl>
                                           <p:spTgt spid="10"/>
                                         </p:tgtEl>
@@ -5826,14 +5723,14 @@
                                 </p:cTn>
                               </p:par>
                               <p:par>
-                                <p:cTn id="22" presetID="10" presetClass="entr" presetSubtype="0" fill="hold" grpId="0" nodeType="withEffect">
+                                <p:cTn id="19" presetID="22" presetClass="entr" presetSubtype="8" fill="hold" grpId="0" nodeType="withEffect">
                                   <p:stCondLst>
-                                    <p:cond delay="0"/>
+                                    <p:cond delay="550"/>
                                   </p:stCondLst>
                                   <p:childTnLst>
                                     <p:set>
                                       <p:cBhvr>
-                                        <p:cTn id="23" dur="1" fill="hold">
+                                        <p:cTn id="20" dur="1" fill="hold">
                                           <p:stCondLst>
                                             <p:cond delay="0"/>
                                           </p:stCondLst>
@@ -5849,9 +5746,9 @@
                                         <p:strVal val="visible"/>
                                       </p:to>
                                     </p:set>
-                                    <p:animEffect transition="in" filter="fade">
+                                    <p:animEffect transition="in" filter="wipe(left)">
                                       <p:cBhvr>
-                                        <p:cTn id="24" dur="450"/>
+                                        <p:cTn id="21" dur="450"/>
                                         <p:tgtEl>
                                           <p:spTgt spid="11"/>
                                         </p:tgtEl>
@@ -5861,14 +5758,14 @@
                                 </p:cTn>
                               </p:par>
                               <p:par>
-                                <p:cTn id="25" presetID="22" presetClass="entr" presetSubtype="8" fill="hold" grpId="0" nodeType="withEffect">
+                                <p:cTn id="22" presetID="10" presetClass="entr" presetSubtype="0" fill="hold" grpId="0" nodeType="withEffect">
                                   <p:stCondLst>
-                                    <p:cond delay="200"/>
+                                    <p:cond delay="800"/>
                                   </p:stCondLst>
                                   <p:childTnLst>
                                     <p:set>
                                       <p:cBhvr>
-                                        <p:cTn id="26" dur="1" fill="hold">
+                                        <p:cTn id="23" dur="1" fill="hold">
                                           <p:stCondLst>
                                             <p:cond delay="0"/>
                                           </p:stCondLst>
@@ -5884,9 +5781,9 @@
                                         <p:strVal val="visible"/>
                                       </p:to>
                                     </p:set>
-                                    <p:animEffect transition="in" filter="wipe(left)">
+                                    <p:animEffect transition="in" filter="fade">
                                       <p:cBhvr>
-                                        <p:cTn id="27" dur="450"/>
+                                        <p:cTn id="24" dur="450"/>
                                         <p:tgtEl>
                                           <p:spTgt spid="12"/>
                                         </p:tgtEl>
@@ -5896,14 +5793,14 @@
                                 </p:cTn>
                               </p:par>
                               <p:par>
-                                <p:cTn id="28" presetID="22" presetClass="entr" presetSubtype="8" fill="hold" grpId="0" nodeType="withEffect">
+                                <p:cTn id="25" presetID="10" presetClass="entr" presetSubtype="0" fill="hold" grpId="0" nodeType="withEffect">
                                   <p:stCondLst>
-                                    <p:cond delay="300"/>
+                                    <p:cond delay="800"/>
                                   </p:stCondLst>
                                   <p:childTnLst>
                                     <p:set>
                                       <p:cBhvr>
-                                        <p:cTn id="29" dur="1" fill="hold">
+                                        <p:cTn id="26" dur="1" fill="hold">
                                           <p:stCondLst>
                                             <p:cond delay="0"/>
                                           </p:stCondLst>
@@ -5919,9 +5816,9 @@
                                         <p:strVal val="visible"/>
                                       </p:to>
                                     </p:set>
-                                    <p:animEffect transition="in" filter="wipe(left)">
+                                    <p:animEffect transition="in" filter="fade">
                                       <p:cBhvr>
-                                        <p:cTn id="30" dur="450"/>
+                                        <p:cTn id="27" dur="450"/>
                                         <p:tgtEl>
                                           <p:spTgt spid="13"/>
                                         </p:tgtEl>
@@ -5930,15 +5827,24 @@
                                   </p:childTnLst>
                                 </p:cTn>
                               </p:par>
+                            </p:childTnLst>
+                          </p:cTn>
+                        </p:par>
+                        <p:par>
+                          <p:cTn id="47" fill="hold">
+                            <p:stCondLst>
+                              <p:cond delay="2200"/>
+                            </p:stCondLst>
+                            <p:childTnLst>
                               <p:par>
-                                <p:cTn id="31" presetID="22" presetClass="entr" presetSubtype="8" fill="hold" grpId="0" nodeType="withEffect">
+                                <p:cTn id="29" presetID="22" presetClass="entr" presetSubtype="8" fill="hold" grpId="0" nodeType="afterEffect">
                                   <p:stCondLst>
-                                    <p:cond delay="300"/>
+                                    <p:cond delay="0"/>
                                   </p:stCondLst>
                                   <p:childTnLst>
                                     <p:set>
                                       <p:cBhvr>
-                                        <p:cTn id="32" dur="1" fill="hold">
+                                        <p:cTn id="30" dur="1" fill="hold">
                                           <p:stCondLst>
                                             <p:cond delay="0"/>
                                           </p:stCondLst>
@@ -5956,7 +5862,7 @@
                                     </p:set>
                                     <p:animEffect transition="in" filter="wipe(left)">
                                       <p:cBhvr>
-                                        <p:cTn id="33" dur="450"/>
+                                        <p:cTn id="31" dur="450"/>
                                         <p:tgtEl>
                                           <p:spTgt spid="14"/>
                                         </p:tgtEl>
@@ -5965,24 +5871,15 @@
                                   </p:childTnLst>
                                 </p:cTn>
                               </p:par>
-                            </p:childTnLst>
-                          </p:cTn>
-                        </p:par>
-                        <p:par>
-                          <p:cTn id="50" fill="hold">
-                            <p:stCondLst>
-                              <p:cond delay="1300"/>
-                            </p:stCondLst>
-                            <p:childTnLst>
                               <p:par>
-                                <p:cTn id="35" presetID="10" presetClass="entr" presetSubtype="0" fill="hold" grpId="0" nodeType="afterEffect">
+                                <p:cTn id="32" presetID="10" presetClass="entr" presetSubtype="0" fill="hold" grpId="0" nodeType="withEffect">
                                   <p:stCondLst>
-                                    <p:cond delay="0"/>
+                                    <p:cond delay="250"/>
                                   </p:stCondLst>
                                   <p:childTnLst>
                                     <p:set>
                                       <p:cBhvr>
-                                        <p:cTn id="36" dur="1" fill="hold">
+                                        <p:cTn id="33" dur="1" fill="hold">
                                           <p:stCondLst>
                                             <p:cond delay="0"/>
                                           </p:stCondLst>
@@ -6000,7 +5897,7 @@
                                     </p:set>
                                     <p:animEffect transition="in" filter="fade">
                                       <p:cBhvr>
-                                        <p:cTn id="37" dur="450"/>
+                                        <p:cTn id="34" dur="450"/>
                                         <p:tgtEl>
                                           <p:spTgt spid="15"/>
                                         </p:tgtEl>
@@ -6010,14 +5907,14 @@
                                 </p:cTn>
                               </p:par>
                               <p:par>
-                                <p:cTn id="38" presetID="10" presetClass="entr" presetSubtype="0" fill="hold" grpId="0" nodeType="withEffect">
+                                <p:cTn id="35" presetID="10" presetClass="entr" presetSubtype="0" fill="hold" grpId="0" nodeType="withEffect">
                                   <p:stCondLst>
-                                    <p:cond delay="0"/>
+                                    <p:cond delay="250"/>
                                   </p:stCondLst>
                                   <p:childTnLst>
                                     <p:set>
                                       <p:cBhvr>
-                                        <p:cTn id="39" dur="1" fill="hold">
+                                        <p:cTn id="36" dur="1" fill="hold">
                                           <p:stCondLst>
                                             <p:cond delay="0"/>
                                           </p:stCondLst>
@@ -6035,7 +5932,7 @@
                                     </p:set>
                                     <p:animEffect transition="in" filter="fade">
                                       <p:cBhvr>
-                                        <p:cTn id="40" dur="450"/>
+                                        <p:cTn id="37" dur="450"/>
                                         <p:tgtEl>
                                           <p:spTgt spid="16"/>
                                         </p:tgtEl>
@@ -6045,14 +5942,14 @@
                                 </p:cTn>
                               </p:par>
                               <p:par>
-                                <p:cTn id="41" presetID="22" presetClass="entr" presetSubtype="8" fill="hold" grpId="0" nodeType="withEffect">
+                                <p:cTn id="38" presetID="22" presetClass="entr" presetSubtype="8" fill="hold" grpId="0" nodeType="withEffect">
                                   <p:stCondLst>
-                                    <p:cond delay="200"/>
+                                    <p:cond delay="550"/>
                                   </p:stCondLst>
                                   <p:childTnLst>
                                     <p:set>
                                       <p:cBhvr>
-                                        <p:cTn id="42" dur="1" fill="hold">
+                                        <p:cTn id="39" dur="1" fill="hold">
                                           <p:stCondLst>
                                             <p:cond delay="0"/>
                                           </p:stCondLst>
@@ -6070,7 +5967,7 @@
                                     </p:set>
                                     <p:animEffect transition="in" filter="wipe(left)">
                                       <p:cBhvr>
-                                        <p:cTn id="43" dur="450"/>
+                                        <p:cTn id="40" dur="450"/>
                                         <p:tgtEl>
                                           <p:spTgt spid="17"/>
                                         </p:tgtEl>
@@ -6080,14 +5977,14 @@
                                 </p:cTn>
                               </p:par>
                               <p:par>
-                                <p:cTn id="44" presetID="22" presetClass="entr" presetSubtype="8" fill="hold" grpId="0" nodeType="withEffect">
+                                <p:cTn id="41" presetID="10" presetClass="entr" presetSubtype="0" fill="hold" grpId="0" nodeType="withEffect">
                                   <p:stCondLst>
-                                    <p:cond delay="300"/>
+                                    <p:cond delay="800"/>
                                   </p:stCondLst>
                                   <p:childTnLst>
                                     <p:set>
                                       <p:cBhvr>
-                                        <p:cTn id="45" dur="1" fill="hold">
+                                        <p:cTn id="42" dur="1" fill="hold">
                                           <p:stCondLst>
                                             <p:cond delay="0"/>
                                           </p:stCondLst>
@@ -6103,9 +6000,9 @@
                                         <p:strVal val="visible"/>
                                       </p:to>
                                     </p:set>
-                                    <p:animEffect transition="in" filter="wipe(left)">
+                                    <p:animEffect transition="in" filter="fade">
                                       <p:cBhvr>
-                                        <p:cTn id="46" dur="450"/>
+                                        <p:cTn id="43" dur="450"/>
                                         <p:tgtEl>
                                           <p:spTgt spid="18"/>
                                         </p:tgtEl>
@@ -6115,14 +6012,14 @@
                                 </p:cTn>
                               </p:par>
                               <p:par>
-                                <p:cTn id="47" presetID="22" presetClass="entr" presetSubtype="8" fill="hold" grpId="0" nodeType="withEffect">
+                                <p:cTn id="44" presetID="10" presetClass="entr" presetSubtype="0" fill="hold" grpId="0" nodeType="withEffect">
                                   <p:stCondLst>
-                                    <p:cond delay="300"/>
+                                    <p:cond delay="800"/>
                                   </p:stCondLst>
                                   <p:childTnLst>
                                     <p:set>
                                       <p:cBhvr>
-                                        <p:cTn id="48" dur="1" fill="hold">
+                                        <p:cTn id="45" dur="1" fill="hold">
                                           <p:stCondLst>
                                             <p:cond delay="0"/>
                                           </p:stCondLst>
@@ -6138,9 +6035,9 @@
                                         <p:strVal val="visible"/>
                                       </p:to>
                                     </p:set>
-                                    <p:animEffect transition="in" filter="wipe(left)">
+                                    <p:animEffect transition="in" filter="fade">
                                       <p:cBhvr>
-                                        <p:cTn id="49" dur="450"/>
+                                        <p:cTn id="46" dur="450"/>
                                         <p:tgtEl>
                                           <p:spTgt spid="19"/>
                                         </p:tgtEl>
@@ -6155,18 +6052,18 @@
                         <p:par>
                           <p:cTn id="66" fill="hold">
                             <p:stCondLst>
-                              <p:cond delay="1950"/>
+                              <p:cond delay="3300"/>
                             </p:stCondLst>
                             <p:childTnLst>
                               <p:par>
-                                <p:cTn id="51" presetID="10" presetClass="entr" presetSubtype="0" fill="hold" grpId="0" nodeType="afterEffect">
+                                <p:cTn id="48" presetID="22" presetClass="entr" presetSubtype="8" fill="hold" grpId="0" nodeType="afterEffect">
                                   <p:stCondLst>
                                     <p:cond delay="0"/>
                                   </p:stCondLst>
                                   <p:childTnLst>
                                     <p:set>
                                       <p:cBhvr>
-                                        <p:cTn id="52" dur="1" fill="hold">
+                                        <p:cTn id="49" dur="1" fill="hold">
                                           <p:stCondLst>
                                             <p:cond delay="0"/>
                                           </p:stCondLst>
@@ -6182,9 +6079,9 @@
                                         <p:strVal val="visible"/>
                                       </p:to>
                                     </p:set>
-                                    <p:animEffect transition="in" filter="fade">
+                                    <p:animEffect transition="in" filter="wipe(left)">
                                       <p:cBhvr>
-                                        <p:cTn id="53" dur="450"/>
+                                        <p:cTn id="50" dur="450"/>
                                         <p:tgtEl>
                                           <p:spTgt spid="20"/>
                                         </p:tgtEl>
@@ -6194,14 +6091,14 @@
                                 </p:cTn>
                               </p:par>
                               <p:par>
-                                <p:cTn id="54" presetID="10" presetClass="entr" presetSubtype="0" fill="hold" grpId="0" nodeType="withEffect">
+                                <p:cTn id="51" presetID="10" presetClass="entr" presetSubtype="0" fill="hold" grpId="0" nodeType="withEffect">
                                   <p:stCondLst>
-                                    <p:cond delay="0"/>
+                                    <p:cond delay="250"/>
                                   </p:stCondLst>
                                   <p:childTnLst>
                                     <p:set>
                                       <p:cBhvr>
-                                        <p:cTn id="55" dur="1" fill="hold">
+                                        <p:cTn id="52" dur="1" fill="hold">
                                           <p:stCondLst>
                                             <p:cond delay="0"/>
                                           </p:stCondLst>
@@ -6219,7 +6116,7 @@
                                     </p:set>
                                     <p:animEffect transition="in" filter="fade">
                                       <p:cBhvr>
-                                        <p:cTn id="56" dur="450"/>
+                                        <p:cTn id="53" dur="450"/>
                                         <p:tgtEl>
                                           <p:spTgt spid="21"/>
                                         </p:tgtEl>
@@ -6229,14 +6126,14 @@
                                 </p:cTn>
                               </p:par>
                               <p:par>
-                                <p:cTn id="57" presetID="22" presetClass="entr" presetSubtype="8" fill="hold" grpId="0" nodeType="withEffect">
+                                <p:cTn id="54" presetID="10" presetClass="entr" presetSubtype="0" fill="hold" grpId="0" nodeType="withEffect">
                                   <p:stCondLst>
-                                    <p:cond delay="200"/>
+                                    <p:cond delay="250"/>
                                   </p:stCondLst>
                                   <p:childTnLst>
                                     <p:set>
                                       <p:cBhvr>
-                                        <p:cTn id="58" dur="1" fill="hold">
+                                        <p:cTn id="55" dur="1" fill="hold">
                                           <p:stCondLst>
                                             <p:cond delay="0"/>
                                           </p:stCondLst>
@@ -6252,9 +6149,9 @@
                                         <p:strVal val="visible"/>
                                       </p:to>
                                     </p:set>
-                                    <p:animEffect transition="in" filter="wipe(left)">
+                                    <p:animEffect transition="in" filter="fade">
                                       <p:cBhvr>
-                                        <p:cTn id="59" dur="450"/>
+                                        <p:cTn id="56" dur="450"/>
                                         <p:tgtEl>
                                           <p:spTgt spid="22"/>
                                         </p:tgtEl>
@@ -6264,14 +6161,14 @@
                                 </p:cTn>
                               </p:par>
                               <p:par>
-                                <p:cTn id="60" presetID="22" presetClass="entr" presetSubtype="8" fill="hold" grpId="0" nodeType="withEffect">
+                                <p:cTn id="57" presetID="22" presetClass="entr" presetSubtype="8" fill="hold" grpId="0" nodeType="withEffect">
                                   <p:stCondLst>
-                                    <p:cond delay="300"/>
+                                    <p:cond delay="550"/>
                                   </p:stCondLst>
                                   <p:childTnLst>
                                     <p:set>
                                       <p:cBhvr>
-                                        <p:cTn id="61" dur="1" fill="hold">
+                                        <p:cTn id="58" dur="1" fill="hold">
                                           <p:stCondLst>
                                             <p:cond delay="0"/>
                                           </p:stCondLst>
@@ -6289,7 +6186,7 @@
                                     </p:set>
                                     <p:animEffect transition="in" filter="wipe(left)">
                                       <p:cBhvr>
-                                        <p:cTn id="62" dur="450"/>
+                                        <p:cTn id="59" dur="450"/>
                                         <p:tgtEl>
                                           <p:spTgt spid="23"/>
                                         </p:tgtEl>
@@ -6299,14 +6196,14 @@
                                 </p:cTn>
                               </p:par>
                               <p:par>
-                                <p:cTn id="63" presetID="22" presetClass="entr" presetSubtype="8" fill="hold" grpId="0" nodeType="withEffect">
+                                <p:cTn id="60" presetID="10" presetClass="entr" presetSubtype="0" fill="hold" grpId="0" nodeType="withEffect">
                                   <p:stCondLst>
-                                    <p:cond delay="300"/>
+                                    <p:cond delay="800"/>
                                   </p:stCondLst>
                                   <p:childTnLst>
                                     <p:set>
                                       <p:cBhvr>
-                                        <p:cTn id="64" dur="1" fill="hold">
+                                        <p:cTn id="61" dur="1" fill="hold">
                                           <p:stCondLst>
                                             <p:cond delay="0"/>
                                           </p:stCondLst>
@@ -6322,9 +6219,9 @@
                                         <p:strVal val="visible"/>
                                       </p:to>
                                     </p:set>
-                                    <p:animEffect transition="in" filter="wipe(left)">
+                                    <p:animEffect transition="in" filter="fade">
                                       <p:cBhvr>
-                                        <p:cTn id="65" dur="450"/>
+                                        <p:cTn id="62" dur="450"/>
                                         <p:tgtEl>
                                           <p:spTgt spid="24"/>
                                         </p:tgtEl>
@@ -6333,24 +6230,15 @@
                                   </p:childTnLst>
                                 </p:cTn>
                               </p:par>
-                            </p:childTnLst>
-                          </p:cTn>
-                        </p:par>
-                        <p:par>
-                          <p:cTn id="82" fill="hold">
-                            <p:stCondLst>
-                              <p:cond delay="2600"/>
-                            </p:stCondLst>
-                            <p:childTnLst>
                               <p:par>
-                                <p:cTn id="67" presetID="10" presetClass="entr" presetSubtype="0" fill="hold" grpId="0" nodeType="afterEffect">
+                                <p:cTn id="63" presetID="10" presetClass="entr" presetSubtype="0" fill="hold" grpId="0" nodeType="withEffect">
                                   <p:stCondLst>
-                                    <p:cond delay="0"/>
+                                    <p:cond delay="800"/>
                                   </p:stCondLst>
                                   <p:childTnLst>
                                     <p:set>
                                       <p:cBhvr>
-                                        <p:cTn id="68" dur="1" fill="hold">
+                                        <p:cTn id="64" dur="1" fill="hold">
                                           <p:stCondLst>
                                             <p:cond delay="0"/>
                                           </p:stCondLst>
@@ -6368,7 +6256,7 @@
                                     </p:set>
                                     <p:animEffect transition="in" filter="fade">
                                       <p:cBhvr>
-                                        <p:cTn id="69" dur="450"/>
+                                        <p:cTn id="65" dur="450"/>
                                         <p:tgtEl>
                                           <p:spTgt spid="25"/>
                                         </p:tgtEl>
@@ -6377,15 +6265,24 @@
                                   </p:childTnLst>
                                 </p:cTn>
                               </p:par>
+                            </p:childTnLst>
+                          </p:cTn>
+                        </p:par>
+                        <p:par>
+                          <p:cTn id="85" fill="hold">
+                            <p:stCondLst>
+                              <p:cond delay="4400"/>
+                            </p:stCondLst>
+                            <p:childTnLst>
                               <p:par>
-                                <p:cTn id="70" presetID="10" presetClass="entr" presetSubtype="0" fill="hold" grpId="0" nodeType="withEffect">
+                                <p:cTn id="67" presetID="22" presetClass="entr" presetSubtype="8" fill="hold" grpId="0" nodeType="afterEffect">
                                   <p:stCondLst>
                                     <p:cond delay="0"/>
                                   </p:stCondLst>
                                   <p:childTnLst>
                                     <p:set>
                                       <p:cBhvr>
-                                        <p:cTn id="71" dur="1" fill="hold">
+                                        <p:cTn id="68" dur="1" fill="hold">
                                           <p:stCondLst>
                                             <p:cond delay="0"/>
                                           </p:stCondLst>
@@ -6401,9 +6298,9 @@
                                         <p:strVal val="visible"/>
                                       </p:to>
                                     </p:set>
-                                    <p:animEffect transition="in" filter="fade">
+                                    <p:animEffect transition="in" filter="wipe(left)">
                                       <p:cBhvr>
-                                        <p:cTn id="72" dur="450"/>
+                                        <p:cTn id="69" dur="450"/>
                                         <p:tgtEl>
                                           <p:spTgt spid="26"/>
                                         </p:tgtEl>
@@ -6413,14 +6310,14 @@
                                 </p:cTn>
                               </p:par>
                               <p:par>
-                                <p:cTn id="73" presetID="22" presetClass="entr" presetSubtype="8" fill="hold" grpId="0" nodeType="withEffect">
+                                <p:cTn id="70" presetID="10" presetClass="entr" presetSubtype="0" fill="hold" grpId="0" nodeType="withEffect">
                                   <p:stCondLst>
-                                    <p:cond delay="200"/>
+                                    <p:cond delay="250"/>
                                   </p:stCondLst>
                                   <p:childTnLst>
                                     <p:set>
                                       <p:cBhvr>
-                                        <p:cTn id="74" dur="1" fill="hold">
+                                        <p:cTn id="71" dur="1" fill="hold">
                                           <p:stCondLst>
                                             <p:cond delay="0"/>
                                           </p:stCondLst>
@@ -6436,9 +6333,9 @@
                                         <p:strVal val="visible"/>
                                       </p:to>
                                     </p:set>
-                                    <p:animEffect transition="in" filter="wipe(left)">
+                                    <p:animEffect transition="in" filter="fade">
                                       <p:cBhvr>
-                                        <p:cTn id="75" dur="450"/>
+                                        <p:cTn id="72" dur="450"/>
                                         <p:tgtEl>
                                           <p:spTgt spid="27"/>
                                         </p:tgtEl>
@@ -6448,14 +6345,14 @@
                                 </p:cTn>
                               </p:par>
                               <p:par>
-                                <p:cTn id="76" presetID="22" presetClass="entr" presetSubtype="8" fill="hold" grpId="0" nodeType="withEffect">
+                                <p:cTn id="73" presetID="10" presetClass="entr" presetSubtype="0" fill="hold" grpId="0" nodeType="withEffect">
                                   <p:stCondLst>
-                                    <p:cond delay="300"/>
+                                    <p:cond delay="250"/>
                                   </p:stCondLst>
                                   <p:childTnLst>
                                     <p:set>
                                       <p:cBhvr>
-                                        <p:cTn id="77" dur="1" fill="hold">
+                                        <p:cTn id="74" dur="1" fill="hold">
                                           <p:stCondLst>
                                             <p:cond delay="0"/>
                                           </p:stCondLst>
@@ -6471,9 +6368,9 @@
                                         <p:strVal val="visible"/>
                                       </p:to>
                                     </p:set>
-                                    <p:animEffect transition="in" filter="wipe(left)">
+                                    <p:animEffect transition="in" filter="fade">
                                       <p:cBhvr>
-                                        <p:cTn id="78" dur="450"/>
+                                        <p:cTn id="75" dur="450"/>
                                         <p:tgtEl>
                                           <p:spTgt spid="28"/>
                                         </p:tgtEl>
@@ -6483,14 +6380,14 @@
                                 </p:cTn>
                               </p:par>
                               <p:par>
-                                <p:cTn id="79" presetID="22" presetClass="entr" presetSubtype="8" fill="hold" grpId="0" nodeType="withEffect">
+                                <p:cTn id="76" presetID="22" presetClass="entr" presetSubtype="8" fill="hold" grpId="0" nodeType="withEffect">
                                   <p:stCondLst>
-                                    <p:cond delay="300"/>
+                                    <p:cond delay="550"/>
                                   </p:stCondLst>
                                   <p:childTnLst>
                                     <p:set>
                                       <p:cBhvr>
-                                        <p:cTn id="80" dur="1" fill="hold">
+                                        <p:cTn id="77" dur="1" fill="hold">
                                           <p:stCondLst>
                                             <p:cond delay="0"/>
                                           </p:stCondLst>
@@ -6508,7 +6405,7 @@
                                     </p:set>
                                     <p:animEffect transition="in" filter="wipe(left)">
                                       <p:cBhvr>
-                                        <p:cTn id="81" dur="450"/>
+                                        <p:cTn id="78" dur="450"/>
                                         <p:tgtEl>
                                           <p:spTgt spid="29"/>
                                         </p:tgtEl>
@@ -6517,24 +6414,15 @@
                                   </p:childTnLst>
                                 </p:cTn>
                               </p:par>
-                            </p:childTnLst>
-                          </p:cTn>
-                        </p:par>
-                        <p:par>
-                          <p:cTn id="98" fill="hold">
-                            <p:stCondLst>
-                              <p:cond delay="3250"/>
-                            </p:stCondLst>
-                            <p:childTnLst>
                               <p:par>
-                                <p:cTn id="83" presetID="10" presetClass="entr" presetSubtype="0" fill="hold" grpId="0" nodeType="afterEffect">
+                                <p:cTn id="79" presetID="10" presetClass="entr" presetSubtype="0" fill="hold" grpId="0" nodeType="withEffect">
                                   <p:stCondLst>
-                                    <p:cond delay="0"/>
+                                    <p:cond delay="800"/>
                                   </p:stCondLst>
                                   <p:childTnLst>
                                     <p:set>
                                       <p:cBhvr>
-                                        <p:cTn id="84" dur="1" fill="hold">
+                                        <p:cTn id="80" dur="1" fill="hold">
                                           <p:stCondLst>
                                             <p:cond delay="0"/>
                                           </p:stCondLst>
@@ -6552,7 +6440,7 @@
                                     </p:set>
                                     <p:animEffect transition="in" filter="fade">
                                       <p:cBhvr>
-                                        <p:cTn id="85" dur="450"/>
+                                        <p:cTn id="81" dur="450"/>
                                         <p:tgtEl>
                                           <p:spTgt spid="30"/>
                                         </p:tgtEl>
@@ -6562,14 +6450,14 @@
                                 </p:cTn>
                               </p:par>
                               <p:par>
-                                <p:cTn id="86" presetID="10" presetClass="entr" presetSubtype="0" fill="hold" grpId="0" nodeType="withEffect">
+                                <p:cTn id="82" presetID="10" presetClass="entr" presetSubtype="0" fill="hold" grpId="0" nodeType="withEffect">
                                   <p:stCondLst>
-                                    <p:cond delay="0"/>
+                                    <p:cond delay="800"/>
                                   </p:stCondLst>
                                   <p:childTnLst>
                                     <p:set>
                                       <p:cBhvr>
-                                        <p:cTn id="87" dur="1" fill="hold">
+                                        <p:cTn id="83" dur="1" fill="hold">
                                           <p:stCondLst>
                                             <p:cond delay="0"/>
                                           </p:stCondLst>
@@ -6587,114 +6475,9 @@
                                     </p:set>
                                     <p:animEffect transition="in" filter="fade">
                                       <p:cBhvr>
-                                        <p:cTn id="88" dur="450"/>
+                                        <p:cTn id="84" dur="450"/>
                                         <p:tgtEl>
                                           <p:spTgt spid="31"/>
-                                        </p:tgtEl>
-                                      </p:cBhvr>
-                                    </p:animEffect>
-                                  </p:childTnLst>
-                                </p:cTn>
-                              </p:par>
-                              <p:par>
-                                <p:cTn id="89" presetID="22" presetClass="entr" presetSubtype="8" fill="hold" grpId="0" nodeType="withEffect">
-                                  <p:stCondLst>
-                                    <p:cond delay="200"/>
-                                  </p:stCondLst>
-                                  <p:childTnLst>
-                                    <p:set>
-                                      <p:cBhvr>
-                                        <p:cTn id="90" dur="1" fill="hold">
-                                          <p:stCondLst>
-                                            <p:cond delay="0"/>
-                                          </p:stCondLst>
-                                        </p:cTn>
-                                        <p:tgtEl>
-                                          <p:spTgt spid="32"/>
-                                        </p:tgtEl>
-                                        <p:attrNameLst>
-                                          <p:attrName>style.visibility</p:attrName>
-                                        </p:attrNameLst>
-                                      </p:cBhvr>
-                                      <p:to>
-                                        <p:strVal val="visible"/>
-                                      </p:to>
-                                    </p:set>
-                                    <p:animEffect transition="in" filter="wipe(left)">
-                                      <p:cBhvr>
-                                        <p:cTn id="91" dur="450"/>
-                                        <p:tgtEl>
-                                          <p:spTgt spid="32"/>
-                                        </p:tgtEl>
-                                      </p:cBhvr>
-                                    </p:animEffect>
-                                  </p:childTnLst>
-                                </p:cTn>
-                              </p:par>
-                              <p:par>
-                                <p:cTn id="92" presetID="22" presetClass="entr" presetSubtype="8" fill="hold" grpId="0" nodeType="withEffect">
-                                  <p:stCondLst>
-                                    <p:cond delay="300"/>
-                                  </p:stCondLst>
-                                  <p:childTnLst>
-                                    <p:set>
-                                      <p:cBhvr>
-                                        <p:cTn id="93" dur="1" fill="hold">
-                                          <p:stCondLst>
-                                            <p:cond delay="0"/>
-                                          </p:stCondLst>
-                                        </p:cTn>
-                                        <p:tgtEl>
-                                          <p:spTgt spid="33"/>
-                                        </p:tgtEl>
-                                        <p:attrNameLst>
-                                          <p:attrName>style.visibility</p:attrName>
-                                        </p:attrNameLst>
-                                      </p:cBhvr>
-                                      <p:to>
-                                        <p:strVal val="visible"/>
-                                      </p:to>
-                                    </p:set>
-                                    <p:animEffect transition="in" filter="wipe(left)">
-                                      <p:cBhvr>
-                                        <p:cTn id="94" dur="450"/>
-                                        <p:tgtEl>
-                                          <p:spTgt spid="33"/>
-                                        </p:tgtEl>
-                                      </p:cBhvr>
-                                    </p:animEffect>
-                                  </p:childTnLst>
-                                </p:cTn>
-                              </p:par>
-                              <p:par>
-                                <p:cTn id="95" presetID="22" presetClass="entr" presetSubtype="8" fill="hold" grpId="0" nodeType="withEffect">
-                                  <p:stCondLst>
-                                    <p:cond delay="300"/>
-                                  </p:stCondLst>
-                                  <p:childTnLst>
-                                    <p:set>
-                                      <p:cBhvr>
-                                        <p:cTn id="96" dur="1" fill="hold">
-                                          <p:stCondLst>
-                                            <p:cond delay="0"/>
-                                          </p:stCondLst>
-                                        </p:cTn>
-                                        <p:tgtEl>
-                                          <p:spTgt spid="34"/>
-                                        </p:tgtEl>
-                                        <p:attrNameLst>
-                                          <p:attrName>style.visibility</p:attrName>
-                                        </p:attrNameLst>
-                                      </p:cBhvr>
-                                      <p:to>
-                                        <p:strVal val="visible"/>
-                                      </p:to>
-                                    </p:set>
-                                    <p:animEffect transition="in" filter="wipe(left)">
-                                      <p:cBhvr>
-                                        <p:cTn id="97" dur="450"/>
-                                        <p:tgtEl>
-                                          <p:spTgt spid="34"/>
                                         </p:tgtEl>
                                       </p:cBhvr>
                                     </p:animEffect>
@@ -6729,36 +6512,24 @@
       </p:par>
     </p:tnLst>
     <p:bldLst>
-      <p:bldP spid="5" grpId="0" animBg="1"/>
       <p:bldP spid="6" grpId="0" animBg="1"/>
       <p:bldP spid="7" grpId="0" animBg="1"/>
-      <p:bldP spid="8" grpId="0" animBg="1"/>
       <p:bldP spid="9" grpId="0" animBg="1"/>
       <p:bldP spid="10" grpId="0" animBg="1"/>
-      <p:bldP spid="11" grpId="0" animBg="1"/>
       <p:bldP spid="12" grpId="0" animBg="1"/>
       <p:bldP spid="13" grpId="0" animBg="1"/>
-      <p:bldP spid="14" grpId="0" animBg="1"/>
       <p:bldP spid="15" grpId="0" animBg="1"/>
       <p:bldP spid="16" grpId="0" animBg="1"/>
-      <p:bldP spid="17" grpId="0" animBg="1"/>
       <p:bldP spid="18" grpId="0" animBg="1"/>
       <p:bldP spid="19" grpId="0" animBg="1"/>
-      <p:bldP spid="20" grpId="0" animBg="1"/>
       <p:bldP spid="21" grpId="0" animBg="1"/>
       <p:bldP spid="22" grpId="0" animBg="1"/>
-      <p:bldP spid="23" grpId="0" animBg="1"/>
       <p:bldP spid="24" grpId="0" animBg="1"/>
       <p:bldP spid="25" grpId="0" animBg="1"/>
-      <p:bldP spid="26" grpId="0" animBg="1"/>
       <p:bldP spid="27" grpId="0" animBg="1"/>
       <p:bldP spid="28" grpId="0" animBg="1"/>
-      <p:bldP spid="29" grpId="0" animBg="1"/>
       <p:bldP spid="30" grpId="0" animBg="1"/>
       <p:bldP spid="31" grpId="0" animBg="1"/>
-      <p:bldP spid="32" grpId="0" animBg="1"/>
-      <p:bldP spid="33" grpId="0" animBg="1"/>
-      <p:bldP spid="34" grpId="0" animBg="1"/>
     </p:bldLst>
   </p:timing>
 </p:sld>

</xml_diff>

<commit_message>
Recreate ERM adoption slide with monthly users trend and location profile
Co-Authored-By: Claude Opus 5.5 <noreply@anthropic.com>
Claude-Session: https://claude.ai/code/session_01HdxEbeqqWM97gKbcNqpjAq
</commit_message>
<xml_diff>
--- a/erm-migration/docs/ERM-Migration-Jury-Pitch.pptx
+++ b/erm-migration/docs/ERM-Migration-Jury-Pitch.pptx
@@ -115,31 +115,31 @@
   <p:extLst>
     <p:ext uri="{521415D9-36F7-43E2-AB2F-B90AF26B5E84}">
       <p14:sectionLst xmlns:p14="http://schemas.microsoft.com/office/powerpoint/2010/main">
-        <p14:section name="Pitch" id="{a6b8c539-af5d-9d40-c6ed-4b56507743f5}">
+        <p14:section name="Pitch" id="{853be82f-37cb-3071-5236-597c13728fa0}">
           <p14:sldIdLst>
             <p14:sldId id="256"/>
           </p14:sldIdLst>
         </p14:section>
-        <p14:section name="Context" id="{2fed9648-88eb-020f-b857-1729a9fe55c3}">
+        <p14:section name="Context" id="{17addc18-8c97-9952-eb95-4cafef74b56f}">
           <p14:sldIdLst>
             <p14:sldId id="257"/>
             <p14:sldId id="258"/>
           </p14:sldIdLst>
         </p14:section>
-        <p14:section name="Problem and method" id="{89b656bc-9b3b-5a89-178c-bdb500144a19}">
+        <p14:section name="Problem and method" id="{74955835-f259-be5e-e61d-57f972d936e9}">
           <p14:sldIdLst>
             <p14:sldId id="259"/>
             <p14:sldId id="260"/>
           </p14:sldIdLst>
         </p14:section>
-        <p14:section name="Impact" id="{87eeb092-a30b-3b2b-dd4c-fa2788949f00}">
+        <p14:section name="Impact" id="{0b2bab05-3513-06d5-6bd2-9eae1b80eb52}">
           <p14:sldIdLst>
             <p14:sldId id="261"/>
             <p14:sldId id="262"/>
             <p14:sldId id="263"/>
           </p14:sldIdLst>
         </p14:section>
-        <p14:section name="Reuse" id="{ad97be09-8d8e-abc7-6b9d-09987f9d315d}">
+        <p14:section name="Reuse" id="{fc2a2f20-659d-d93f-2168-1df443d0d753}">
           <p14:sldIdLst>
             <p14:sldId id="264"/>
           </p14:sldIdLst>
@@ -158,41 +158,10 @@
   <c:date1904 val="0"/>
   <c:roundedCorners val="1"/>
   <c:chart>
-    <c:title>
-      <c:tx>
-        <c:rich>
-          <a:bodyPr/>
-          <a:lstStyle/>
-          <a:p>
-            <a:pPr>
-              <a:defRPr sz="1300" b="0" i="0" u="none" strike="noStrike">
-                <a:solidFill>
-                  <a:srgbClr val="00205B"/>
-                </a:solidFill>
-                <a:latin typeface="+mn-lt"/>
-              </a:defRPr>
-            </a:pPr>
-            <a:r>
-              <a:rPr sz="1300" b="0" i="0" u="none" strike="noStrike">
-                <a:solidFill>
-                  <a:srgbClr val="00205B"/>
-                </a:solidFill>
-                <a:latin typeface="+mn-lt"/>
-              </a:rPr>
-              <a:t>ERM users by site</a:t>
-            </a:r>
-          </a:p>
-        </c:rich>
-      </c:tx>
-      <c:layout/>
-      <c:overlay val="0"/>
-    </c:title>
-    <c:autoTitleDeleted val="0"/>
+    <c:autoTitleDeleted val="1"/>
     <c:plotArea>
       <c:layout/>
-      <c:barChart>
-        <c:barDir val="bar"/>
-        <c:grouping val="clustered"/>
+      <c:lineChart>
         <c:varyColors val="0"/>
         <c:ser>
           <c:idx val="0"/>
@@ -203,7 +172,7 @@
               <c:strCache>
                 <c:ptCount val="1"/>
                 <c:pt idx="0">
-                  <c:v>Users</c:v>
+                  <c:v>Unique users</c:v>
                 </c:pt>
               </c:strCache>
             </c:strRef>
@@ -212,6 +181,13 @@
             <a:solidFill>
               <a:srgbClr val="0085CA"/>
             </a:solidFill>
+            <a:ln w="25400" cap="flat">
+              <a:solidFill>
+                <a:srgbClr val="0085CA"/>
+              </a:solidFill>
+              <a:prstDash val="solid"/>
+              <a:round/>
+            </a:ln>
             <a:effectLst/>
           </c:spPr>
           <c:invertIfNegative val="0"/>
@@ -222,52 +198,114 @@
               <a:lstStyle/>
               <a:p>
                 <a:pPr>
-                  <a:defRPr b="0" i="0" strike="noStrike" sz="1100" u="none">
+                  <a:defRPr b="0" i="0" strike="noStrike" sz="1200" u="none">
                     <a:solidFill>
-                      <a:srgbClr val="00205B"/>
+                      <a:srgbClr val="000000"/>
                     </a:solidFill>
-                    <a:latin typeface="+mn-lt"/>
+                    <a:latin typeface="Arial"/>
                   </a:defRPr>
                 </a:pPr>
               </a:p>
             </c:txPr>
             <c:showLegendKey val="0"/>
-            <c:showVal val="1"/>
+            <c:showVal val="0"/>
             <c:showCatName val="0"/>
             <c:showSerName val="0"/>
             <c:showPercent val="0"/>
             <c:showBubbleSize val="0"/>
             <c:showLeaderLines val="0"/>
           </c:dLbls>
+          <c:marker>
+            <c:symbol val="circle"/>
+            <c:size val="5"/>
+            <c:spPr>
+              <a:solidFill>
+                <a:srgbClr val="0085CA"/>
+              </a:solidFill>
+              <a:ln w="9525" cap="flat">
+                <a:solidFill>
+                  <a:srgbClr val="0085CA"/>
+                </a:solidFill>
+                <a:prstDash val="solid"/>
+                <a:round/>
+              </a:ln>
+              <a:effectLst/>
+            </c:spPr>
+          </c:marker>
           <c:cat>
             <c:multiLvlStrRef>
-              <c:f>Sheet1!$A$2:$A$9</c:f>
+              <c:f>Sheet1!$A$2:$A$24</c:f>
               <c:multiLvlStrCache>
-                <c:ptCount val="8"/>
+                <c:ptCount val="23"/>
                 <c:lvl>
                   <c:pt idx="0">
-                    <c:v>Blagnac (FR)</c:v>
+                    <c:v>Aug 24</c:v>
                   </c:pt>
                   <c:pt idx="1">
-                    <c:v>Hamburg (DE)</c:v>
+                    <c:v>Sep 24</c:v>
                   </c:pt>
                   <c:pt idx="2">
-                    <c:v>Saint-Martin (FR)</c:v>
+                    <c:v>Oct 24</c:v>
                   </c:pt>
                   <c:pt idx="3">
-                    <c:v>Broughton (UK)</c:v>
+                    <c:v>Nov 24</c:v>
                   </c:pt>
                   <c:pt idx="4">
-                    <c:v>Filton (UK)</c:v>
+                    <c:v>Dec 24</c:v>
                   </c:pt>
                   <c:pt idx="5">
-                    <c:v>Getafe (ES)</c:v>
+                    <c:v>Jan 25</c:v>
                   </c:pt>
                   <c:pt idx="6">
-                    <c:v>Mirabel (CA)</c:v>
+                    <c:v>Feb 25</c:v>
                   </c:pt>
                   <c:pt idx="7">
-                    <c:v>Bangalore (IN)</c:v>
+                    <c:v>Mar 25</c:v>
+                  </c:pt>
+                  <c:pt idx="8">
+                    <c:v>Apr 25</c:v>
+                  </c:pt>
+                  <c:pt idx="9">
+                    <c:v>May 25</c:v>
+                  </c:pt>
+                  <c:pt idx="10">
+                    <c:v>Jun 25</c:v>
+                  </c:pt>
+                  <c:pt idx="11">
+                    <c:v>Jul 25</c:v>
+                  </c:pt>
+                  <c:pt idx="12">
+                    <c:v>Aug 25</c:v>
+                  </c:pt>
+                  <c:pt idx="13">
+                    <c:v>Sep 25</c:v>
+                  </c:pt>
+                  <c:pt idx="14">
+                    <c:v>Oct 25</c:v>
+                  </c:pt>
+                  <c:pt idx="15">
+                    <c:v>Nov 25</c:v>
+                  </c:pt>
+                  <c:pt idx="16">
+                    <c:v>Dec 25</c:v>
+                  </c:pt>
+                  <c:pt idx="17">
+                    <c:v>Jan 26</c:v>
+                  </c:pt>
+                  <c:pt idx="18">
+                    <c:v>Feb 26</c:v>
+                  </c:pt>
+                  <c:pt idx="19">
+                    <c:v>Mar 26</c:v>
+                  </c:pt>
+                  <c:pt idx="20">
+                    <c:v>Apr 26</c:v>
+                  </c:pt>
+                  <c:pt idx="21">
+                    <c:v>May 26</c:v>
+                  </c:pt>
+                  <c:pt idx="22">
+                    <c:v>Jun 26</c:v>
                   </c:pt>
                 </c:lvl>
               </c:multiLvlStrCache>
@@ -275,37 +313,83 @@
           </c:cat>
           <c:val>
             <c:numRef>
-              <c:f>Sheet1!$B$2:$B$9</c:f>
+              <c:f>Sheet1!$B$2:$B$24</c:f>
               <c:numCache>
                 <c:formatCode>General</c:formatCode>
-                <c:ptCount val="8"/>
+                <c:ptCount val="23"/>
                 <c:pt idx="0">
-                  <c:v>271</c:v>
+                  <c:v>0</c:v>
                 </c:pt>
                 <c:pt idx="1">
-                  <c:v>205</c:v>
+                  <c:v>50</c:v>
                 </c:pt>
                 <c:pt idx="2">
-                  <c:v>43</c:v>
+                  <c:v>95</c:v>
                 </c:pt>
                 <c:pt idx="3">
-                  <c:v>32</c:v>
+                  <c:v>105</c:v>
                 </c:pt>
                 <c:pt idx="4">
-                  <c:v>26</c:v>
+                  <c:v>65</c:v>
                 </c:pt>
                 <c:pt idx="5">
-                  <c:v>25</c:v>
+                  <c:v>110</c:v>
                 </c:pt>
                 <c:pt idx="6">
-                  <c:v>12</c:v>
+                  <c:v>135</c:v>
                 </c:pt>
                 <c:pt idx="7">
-                  <c:v>7</c:v>
+                  <c:v>125</c:v>
+                </c:pt>
+                <c:pt idx="8">
+                  <c:v>150</c:v>
+                </c:pt>
+                <c:pt idx="9">
+                  <c:v>245</c:v>
+                </c:pt>
+                <c:pt idx="10">
+                  <c:v>220</c:v>
+                </c:pt>
+                <c:pt idx="11">
+                  <c:v>230</c:v>
+                </c:pt>
+                <c:pt idx="12">
+                  <c:v>240</c:v>
+                </c:pt>
+                <c:pt idx="13">
+                  <c:v>265</c:v>
+                </c:pt>
+                <c:pt idx="14">
+                  <c:v>230</c:v>
+                </c:pt>
+                <c:pt idx="15">
+                  <c:v>300</c:v>
+                </c:pt>
+                <c:pt idx="16">
+                  <c:v>190</c:v>
+                </c:pt>
+                <c:pt idx="17">
+                  <c:v>210</c:v>
+                </c:pt>
+                <c:pt idx="18">
+                  <c:v>340</c:v>
+                </c:pt>
+                <c:pt idx="19">
+                  <c:v>280</c:v>
+                </c:pt>
+                <c:pt idx="20">
+                  <c:v>220</c:v>
+                </c:pt>
+                <c:pt idx="21">
+                  <c:v>305</c:v>
+                </c:pt>
+                <c:pt idx="22">
+                  <c:v>310</c:v>
                 </c:pt>
               </c:numCache>
             </c:numRef>
           </c:val>
+          <c:smooth val="0"/>
         </c:ser>
         <c:dLbls>
           <c:numFmt formatCode="#,##0" sourceLinked="0"/>
@@ -314,37 +398,120 @@
             <a:lstStyle/>
             <a:p>
               <a:pPr>
-                <a:defRPr b="0" i="0" strike="noStrike" sz="1100" u="none">
+                <a:defRPr b="0" i="0" strike="noStrike" sz="1200" u="none">
                   <a:solidFill>
-                    <a:srgbClr val="00205B"/>
+                    <a:srgbClr val="000000"/>
                   </a:solidFill>
-                  <a:latin typeface="+mn-lt"/>
+                  <a:latin typeface="Arial"/>
                 </a:defRPr>
               </a:pPr>
             </a:p>
           </c:txPr>
           <c:showLegendKey val="0"/>
-          <c:showVal val="1"/>
+          <c:showVal val="0"/>
           <c:showCatName val="0"/>
           <c:showSerName val="0"/>
           <c:showPercent val="0"/>
           <c:showBubbleSize val="0"/>
           <c:showLeaderLines val="0"/>
         </c:dLbls>
-        <c:gapWidth val="60"/>
-        <c:overlap val="0"/>
+        <c:marker val="1"/>
         <c:axId val="2094734554"/>
         <c:axId val="2094734552"/>
         <c:axId val="2094734556"/>
-      </c:barChart>
+      </c:lineChart>
       <c:catAx>
         <c:axId val="2094734554"/>
         <c:scaling>
-          <c:orientation val="maxMin"/>
+          <c:orientation val="minMax"/>
+        </c:scaling>
+        <c:delete val="0"/>
+        <c:axPos val="b"/>
+        <c:numFmt formatCode="General" sourceLinked="1"/>
+        <c:majorTickMark val="out"/>
+        <c:minorTickMark val="none"/>
+        <c:tickLblPos val="low"/>
+        <c:spPr>
+          <a:ln w="12700" cap="flat">
+            <a:solidFill>
+              <a:srgbClr val="888888"/>
+            </a:solidFill>
+            <a:prstDash val="solid"/>
+            <a:round/>
+          </a:ln>
+        </c:spPr>
+        <c:txPr>
+          <a:bodyPr/>
+          <a:lstStyle/>
+          <a:p>
+            <a:pPr>
+              <a:defRPr sz="1000" b="0" i="0" u="none" strike="noStrike">
+                <a:solidFill>
+                  <a:srgbClr val="4A5568"/>
+                </a:solidFill>
+                <a:latin typeface="+mn-lt"/>
+              </a:defRPr>
+            </a:pPr>
+            <a:endParaRPr lang="en-US"/>
+          </a:p>
+        </c:txPr>
+        <c:crossAx val="2094734552"/>
+        <c:crosses val="autoZero"/>
+        <c:auto val="1"/>
+        <c:lblAlgn val="ctr"/>
+        <c:noMultiLvlLbl val="1"/>
+        <c:tickLblSkip val="2"/>
+      </c:catAx>
+      <c:valAx>
+        <c:axId val="2094734552"/>
+        <c:scaling>
+          <c:orientation val="minMax"/>
+          <c:max val="350"/>
+          <c:min val="0"/>
         </c:scaling>
         <c:delete val="0"/>
         <c:axPos val="l"/>
-        <c:numFmt formatCode="General" sourceLinked="1"/>
+        <c:majorGridlines>
+          <c:spPr>
+            <a:ln w="9525" cap="flat">
+              <a:solidFill>
+                <a:srgbClr val="DCE3EE"/>
+              </a:solidFill>
+              <a:prstDash val="solid"/>
+              <a:round/>
+            </a:ln>
+          </c:spPr>
+        </c:majorGridlines>
+        <c:title>
+          <c:tx>
+            <c:rich>
+              <a:bodyPr/>
+              <a:lstStyle/>
+              <a:p>
+                <a:pPr>
+                  <a:defRPr sz="1000" b="0" i="0" u="none" strike="noStrike">
+                    <a:solidFill>
+                      <a:srgbClr val="4A5568"/>
+                    </a:solidFill>
+                    <a:latin typeface="Arial"/>
+                  </a:defRPr>
+                </a:pPr>
+                <a:r>
+                  <a:rPr sz="1000" b="0" i="0" u="none" strike="noStrike">
+                    <a:solidFill>
+                      <a:srgbClr val="4A5568"/>
+                    </a:solidFill>
+                    <a:latin typeface="Arial"/>
+                  </a:rPr>
+                  <a:t>Unique users</a:t>
+                </a:r>
+              </a:p>
+            </c:rich>
+          </c:tx>
+          <c:layout/>
+          <c:overlay val="0"/>
+        </c:title>
+        <c:numFmt formatCode="General" sourceLinked="0"/>
         <c:majorTickMark val="out"/>
         <c:minorTickMark val="none"/>
         <c:tickLblPos val="nextTo"/>
@@ -362,7 +529,7 @@
           <a:lstStyle/>
           <a:p>
             <a:pPr>
-              <a:defRPr sz="1100" b="0" i="0" u="none" strike="noStrike">
+              <a:defRPr sz="1000" b="0" i="0" u="none" strike="noStrike">
                 <a:solidFill>
                   <a:srgbClr val="4A5568"/>
                 </a:solidFill>
@@ -372,50 +539,10 @@
             <a:endParaRPr lang="en-US"/>
           </a:p>
         </c:txPr>
-        <c:crossAx val="2094734552"/>
-        <c:crosses val="autoZero"/>
-        <c:auto val="1"/>
-        <c:lblAlgn val="ctr"/>
-        <c:noMultiLvlLbl val="1"/>
-      </c:catAx>
-      <c:valAx>
-        <c:axId val="2094734552"/>
-        <c:scaling>
-          <c:orientation val="minMax"/>
-        </c:scaling>
-        <c:delete val="1"/>
-        <c:axPos val="b"/>
-        <c:numFmt formatCode="General" sourceLinked="0"/>
-        <c:majorTickMark val="out"/>
-        <c:minorTickMark val="none"/>
-        <c:tickLblPos val="low"/>
-        <c:spPr>
-          <a:ln w="12700" cap="flat">
-            <a:solidFill>
-              <a:srgbClr val="888888"/>
-            </a:solidFill>
-            <a:prstDash val="solid"/>
-            <a:round/>
-          </a:ln>
-        </c:spPr>
-        <c:txPr>
-          <a:bodyPr/>
-          <a:lstStyle/>
-          <a:p>
-            <a:pPr>
-              <a:defRPr sz="1200" b="0" i="0" u="none" strike="noStrike">
-                <a:solidFill>
-                  <a:srgbClr val="000000"/>
-                </a:solidFill>
-                <a:latin typeface="Arial"/>
-              </a:defRPr>
-            </a:pPr>
-            <a:endParaRPr lang="en-US"/>
-          </a:p>
-        </c:txPr>
         <c:crossAx val="2094734554"/>
         <c:crosses val="autoZero"/>
         <c:crossBetween val="between"/>
+        <c:majorUnit val="50"/>
       </c:valAx>
       <c:spPr>
         <a:noFill/>
@@ -1012,7 +1139,7 @@
           <a:p>
             <a:r>
               <a:rPr lang="en-US" dirty="0"/>
-              <a:t>Make the stakes clear. 892 people have used ERM, with a monthly peak above 320 active risk managers. More than 1,600 dashboards have been created and more than 10 are updated every day. Users sit in Blagnac, Hamburg, Saint-Martin, Broughton, Filton, Getafe, Mirabel and Bangalore. That is why the migration could not be a rewrite from memory: every feature had to be found and carried over.</a:t>
+              <a:t>Make the stakes clear. 892 people have used ERM across engineering, programmes and operations, with a monthly peak above 320 active risk managers. More than 1,600 dashboards have been created and more than 10 are updated every day. The trend shows monthly unique users growing from launch in summer 2024 to around 300 a month in 2026. Usage spans France, Germany, the UK, Spain, Canada and India, led by Blagnac and Hamburg. That is why the migration could not be a rewrite from memory: every feature had to be found and carried over.</a:t>
             </a:r>
             <a:endParaRPr lang="en-US" dirty="0"/>
           </a:p>
@@ -5626,7 +5753,7 @@
                   <a:schemeClr val="tx1"/>
                 </a:solidFill>
               </a:rPr>
-              <a:t>Hundreds of risk managers rely on ERM</a:t>
+              <a:t>ERM adoption and user metrics</a:t>
             </a:r>
             <a:endParaRPr lang="en-US" sz="3600" dirty="0"/>
           </a:p>
@@ -5634,18 +5761,54 @@
       </p:sp>
       <p:sp>
         <p:nvSpPr>
-          <p:cNvPr id="3" name="adopt-0-card"/>
+          <p:cNvPr id="3" name="adopt-sub"/>
+          <p:cNvSpPr txBox="1"/>
+          <p:nvPr/>
+        </p:nvSpPr>
+        <p:spPr>
+          <a:xfrm>
+            <a:off x="548640" y="1115568"/>
+            <a:ext cx="11094415" cy="320040"/>
+          </a:xfrm>
+          <a:prstGeom prst="rect">
+            <a:avLst/>
+          </a:prstGeom>
+          <a:noFill/>
+          <a:ln/>
+        </p:spPr>
+        <p:txBody>
+          <a:bodyPr wrap="square" lIns="0" tIns="0" rIns="0" bIns="0" rtlCol="0" anchor="t"/>
+          <a:lstStyle/>
+          <a:p>
+            <a:pPr indent="0" marL="0">
+              <a:buNone/>
+            </a:pPr>
+            <a:r>
+              <a:rPr lang="en-US" sz="1400" dirty="0">
+                <a:solidFill>
+                  <a:schemeClr val="tx2"/>
+                </a:solidFill>
+              </a:rPr>
+              <a:t>A migration that broke a feature would disrupt risk reporting for hundreds of risk managers in 6 countries</a:t>
+            </a:r>
+            <a:endParaRPr lang="en-US" sz="1400" dirty="0"/>
+          </a:p>
+        </p:txBody>
+      </p:sp>
+      <p:sp>
+        <p:nvSpPr>
+          <p:cNvPr id="4" name="adopt-0-card"/>
           <p:cNvSpPr/>
           <p:nvPr/>
         </p:nvSpPr>
         <p:spPr>
           <a:xfrm>
-            <a:off x="548640" y="1371600"/>
-            <a:ext cx="2567864" cy="1737360"/>
+            <a:off x="548640" y="1554480"/>
+            <a:ext cx="2567864" cy="1417320"/>
           </a:xfrm>
           <a:prstGeom prst="roundRect">
             <a:avLst>
-              <a:gd name="adj" fmla="val 6316"/>
+              <a:gd name="adj" fmla="val 7742"/>
             </a:avLst>
           </a:prstGeom>
           <a:solidFill>
@@ -5656,14 +5819,14 @@
       </p:sp>
       <p:sp>
         <p:nvSpPr>
-          <p:cNvPr id="4" name="adopt-0-value"/>
+          <p:cNvPr id="5" name="adopt-0-label"/>
           <p:cNvSpPr txBox="1"/>
           <p:nvPr/>
         </p:nvSpPr>
         <p:spPr>
           <a:xfrm>
-            <a:off x="777240" y="1554480"/>
-            <a:ext cx="2110664" cy="731520"/>
+            <a:off x="749808" y="1664208"/>
+            <a:ext cx="2165528" cy="256032"/>
           </a:xfrm>
           <a:prstGeom prst="rect">
             <a:avLst/>
@@ -5679,27 +5842,63 @@
               <a:buNone/>
             </a:pPr>
             <a:r>
-              <a:rPr lang="en-US" sz="4000" b="1" dirty="0">
+              <a:rPr lang="en-US" sz="1000" b="1" spc="100" kern="0" dirty="0">
+                <a:solidFill>
+                  <a:schemeClr val="accent5"/>
+                </a:solidFill>
+              </a:rPr>
+              <a:t>LIFETIME UNIQUE USERS</a:t>
+            </a:r>
+            <a:endParaRPr lang="en-US" sz="1000" dirty="0"/>
+          </a:p>
+        </p:txBody>
+      </p:sp>
+      <p:sp>
+        <p:nvSpPr>
+          <p:cNvPr id="6" name="adopt-0-value"/>
+          <p:cNvSpPr txBox="1"/>
+          <p:nvPr/>
+        </p:nvSpPr>
+        <p:spPr>
+          <a:xfrm>
+            <a:off x="749808" y="1920240"/>
+            <a:ext cx="2165528" cy="594360"/>
+          </a:xfrm>
+          <a:prstGeom prst="rect">
+            <a:avLst/>
+          </a:prstGeom>
+          <a:noFill/>
+          <a:ln/>
+        </p:spPr>
+        <p:txBody>
+          <a:bodyPr wrap="square" lIns="0" tIns="0" rIns="0" bIns="0" rtlCol="0" anchor="t"/>
+          <a:lstStyle/>
+          <a:p>
+            <a:pPr indent="0" marL="0">
+              <a:buNone/>
+            </a:pPr>
+            <a:r>
+              <a:rPr lang="en-US" sz="3400" b="1" dirty="0">
                 <a:solidFill>
                   <a:schemeClr val="bg1"/>
                 </a:solidFill>
               </a:rPr>
               <a:t>892</a:t>
             </a:r>
-            <a:endParaRPr lang="en-US" sz="4000" dirty="0"/>
+            <a:endParaRPr lang="en-US" sz="3400" dirty="0"/>
           </a:p>
         </p:txBody>
       </p:sp>
       <p:sp>
         <p:nvSpPr>
-          <p:cNvPr id="5" name="adopt-0-label"/>
+          <p:cNvPr id="7" name="adopt-0-desc"/>
           <p:cNvSpPr txBox="1"/>
           <p:nvPr/>
         </p:nvSpPr>
         <p:spPr>
           <a:xfrm>
-            <a:off x="777240" y="2286000"/>
-            <a:ext cx="2110664" cy="685800"/>
+            <a:off x="749808" y="2514600"/>
+            <a:ext cx="2165528" cy="365760"/>
           </a:xfrm>
           <a:prstGeom prst="rect">
             <a:avLst/>
@@ -5715,31 +5914,31 @@
               <a:buNone/>
             </a:pPr>
             <a:r>
-              <a:rPr lang="en-US" sz="1300" dirty="0">
+              <a:rPr lang="en-US" sz="1200" dirty="0">
                 <a:solidFill>
                   <a:schemeClr val="accent5"/>
                 </a:solidFill>
               </a:rPr>
-              <a:t>lifetime unique users across engineering, programmes and operations</a:t>
-            </a:r>
-            <a:endParaRPr lang="en-US" sz="1300" dirty="0"/>
+              <a:t>Across engineering, programmes and operations</a:t>
+            </a:r>
+            <a:endParaRPr lang="en-US" sz="1200" dirty="0"/>
           </a:p>
         </p:txBody>
       </p:sp>
       <p:sp>
         <p:nvSpPr>
-          <p:cNvPr id="6" name="adopt-1-card"/>
+          <p:cNvPr id="8" name="adopt-1-card"/>
           <p:cNvSpPr/>
           <p:nvPr/>
         </p:nvSpPr>
         <p:spPr>
           <a:xfrm>
-            <a:off x="3390824" y="1371600"/>
-            <a:ext cx="2567864" cy="1737360"/>
+            <a:off x="3390824" y="1554480"/>
+            <a:ext cx="2567864" cy="1417320"/>
           </a:xfrm>
           <a:prstGeom prst="roundRect">
             <a:avLst>
-              <a:gd name="adj" fmla="val 6316"/>
+              <a:gd name="adj" fmla="val 7742"/>
             </a:avLst>
           </a:prstGeom>
           <a:solidFill>
@@ -5750,14 +5949,14 @@
       </p:sp>
       <p:sp>
         <p:nvSpPr>
-          <p:cNvPr id="7" name="adopt-1-value"/>
+          <p:cNvPr id="9" name="adopt-1-label"/>
           <p:cNvSpPr txBox="1"/>
           <p:nvPr/>
         </p:nvSpPr>
         <p:spPr>
           <a:xfrm>
-            <a:off x="3619424" y="1554480"/>
-            <a:ext cx="2110664" cy="731520"/>
+            <a:off x="3591992" y="1664208"/>
+            <a:ext cx="2165528" cy="256032"/>
           </a:xfrm>
           <a:prstGeom prst="rect">
             <a:avLst/>
@@ -5773,27 +5972,63 @@
               <a:buNone/>
             </a:pPr>
             <a:r>
-              <a:rPr lang="en-US" sz="4000" b="1" dirty="0">
+              <a:rPr lang="en-US" sz="1000" b="1" spc="100" kern="0" dirty="0">
+                <a:solidFill>
+                  <a:schemeClr val="tx2"/>
+                </a:solidFill>
+              </a:rPr>
+              <a:t>MONTHLY ACTIVE PEAK</a:t>
+            </a:r>
+            <a:endParaRPr lang="en-US" sz="1000" dirty="0"/>
+          </a:p>
+        </p:txBody>
+      </p:sp>
+      <p:sp>
+        <p:nvSpPr>
+          <p:cNvPr id="10" name="adopt-1-value"/>
+          <p:cNvSpPr txBox="1"/>
+          <p:nvPr/>
+        </p:nvSpPr>
+        <p:spPr>
+          <a:xfrm>
+            <a:off x="3591992" y="1920240"/>
+            <a:ext cx="2165528" cy="594360"/>
+          </a:xfrm>
+          <a:prstGeom prst="rect">
+            <a:avLst/>
+          </a:prstGeom>
+          <a:noFill/>
+          <a:ln/>
+        </p:spPr>
+        <p:txBody>
+          <a:bodyPr wrap="square" lIns="0" tIns="0" rIns="0" bIns="0" rtlCol="0" anchor="t"/>
+          <a:lstStyle/>
+          <a:p>
+            <a:pPr indent="0" marL="0">
+              <a:buNone/>
+            </a:pPr>
+            <a:r>
+              <a:rPr lang="en-US" sz="3400" b="1" dirty="0">
                 <a:solidFill>
                   <a:schemeClr val="tx1"/>
                 </a:solidFill>
               </a:rPr>
               <a:t>320+</a:t>
             </a:r>
-            <a:endParaRPr lang="en-US" sz="4000" dirty="0"/>
+            <a:endParaRPr lang="en-US" sz="3400" dirty="0"/>
           </a:p>
         </p:txBody>
       </p:sp>
       <p:sp>
         <p:nvSpPr>
-          <p:cNvPr id="8" name="adopt-1-label"/>
+          <p:cNvPr id="11" name="adopt-1-desc"/>
           <p:cNvSpPr txBox="1"/>
           <p:nvPr/>
         </p:nvSpPr>
         <p:spPr>
           <a:xfrm>
-            <a:off x="3619424" y="2286000"/>
-            <a:ext cx="2110664" cy="685800"/>
+            <a:off x="3591992" y="2514600"/>
+            <a:ext cx="2165528" cy="365760"/>
           </a:xfrm>
           <a:prstGeom prst="rect">
             <a:avLst/>
@@ -5809,31 +6044,31 @@
               <a:buNone/>
             </a:pPr>
             <a:r>
-              <a:rPr lang="en-US" sz="1300" dirty="0">
+              <a:rPr lang="en-US" sz="1200" dirty="0">
                 <a:solidFill>
                   <a:schemeClr val="tx2"/>
                 </a:solidFill>
               </a:rPr>
-              <a:t>monthly active risk managers at peak</a:t>
-            </a:r>
-            <a:endParaRPr lang="en-US" sz="1300" dirty="0"/>
+              <a:t>Active risk managers per reporting month</a:t>
+            </a:r>
+            <a:endParaRPr lang="en-US" sz="1200" dirty="0"/>
           </a:p>
         </p:txBody>
       </p:sp>
       <p:sp>
         <p:nvSpPr>
-          <p:cNvPr id="9" name="adopt-2-card"/>
+          <p:cNvPr id="12" name="adopt-2-card"/>
           <p:cNvSpPr/>
           <p:nvPr/>
         </p:nvSpPr>
         <p:spPr>
           <a:xfrm>
-            <a:off x="6233008" y="1371600"/>
-            <a:ext cx="2567864" cy="1737360"/>
+            <a:off x="6233008" y="1554480"/>
+            <a:ext cx="2567864" cy="1417320"/>
           </a:xfrm>
           <a:prstGeom prst="roundRect">
             <a:avLst>
-              <a:gd name="adj" fmla="val 6316"/>
+              <a:gd name="adj" fmla="val 7742"/>
             </a:avLst>
           </a:prstGeom>
           <a:solidFill>
@@ -5844,14 +6079,14 @@
       </p:sp>
       <p:sp>
         <p:nvSpPr>
-          <p:cNvPr id="10" name="adopt-2-value"/>
+          <p:cNvPr id="13" name="adopt-2-label"/>
           <p:cNvSpPr txBox="1"/>
           <p:nvPr/>
         </p:nvSpPr>
         <p:spPr>
           <a:xfrm>
-            <a:off x="6461608" y="1554480"/>
-            <a:ext cx="2110664" cy="731520"/>
+            <a:off x="6434176" y="1664208"/>
+            <a:ext cx="2165528" cy="256032"/>
           </a:xfrm>
           <a:prstGeom prst="rect">
             <a:avLst/>
@@ -5867,27 +6102,63 @@
               <a:buNone/>
             </a:pPr>
             <a:r>
-              <a:rPr lang="en-US" sz="4000" b="1" dirty="0">
+              <a:rPr lang="en-US" sz="1000" b="1" spc="100" kern="0" dirty="0">
+                <a:solidFill>
+                  <a:schemeClr val="tx2"/>
+                </a:solidFill>
+              </a:rPr>
+              <a:t>DASHBOARDS CREATED</a:t>
+            </a:r>
+            <a:endParaRPr lang="en-US" sz="1000" dirty="0"/>
+          </a:p>
+        </p:txBody>
+      </p:sp>
+      <p:sp>
+        <p:nvSpPr>
+          <p:cNvPr id="14" name="adopt-2-value"/>
+          <p:cNvSpPr txBox="1"/>
+          <p:nvPr/>
+        </p:nvSpPr>
+        <p:spPr>
+          <a:xfrm>
+            <a:off x="6434176" y="1920240"/>
+            <a:ext cx="2165528" cy="594360"/>
+          </a:xfrm>
+          <a:prstGeom prst="rect">
+            <a:avLst/>
+          </a:prstGeom>
+          <a:noFill/>
+          <a:ln/>
+        </p:spPr>
+        <p:txBody>
+          <a:bodyPr wrap="square" lIns="0" tIns="0" rIns="0" bIns="0" rtlCol="0" anchor="t"/>
+          <a:lstStyle/>
+          <a:p>
+            <a:pPr indent="0" marL="0">
+              <a:buNone/>
+            </a:pPr>
+            <a:r>
+              <a:rPr lang="en-US" sz="3400" b="1" dirty="0">
                 <a:solidFill>
                   <a:schemeClr val="tx1"/>
                 </a:solidFill>
               </a:rPr>
               <a:t>1,600+</a:t>
             </a:r>
-            <a:endParaRPr lang="en-US" sz="4000" dirty="0"/>
+            <a:endParaRPr lang="en-US" sz="3400" dirty="0"/>
           </a:p>
         </p:txBody>
       </p:sp>
       <p:sp>
         <p:nvSpPr>
-          <p:cNvPr id="11" name="adopt-2-label"/>
+          <p:cNvPr id="15" name="adopt-2-desc"/>
           <p:cNvSpPr txBox="1"/>
           <p:nvPr/>
         </p:nvSpPr>
         <p:spPr>
           <a:xfrm>
-            <a:off x="6461608" y="2286000"/>
-            <a:ext cx="2110664" cy="685800"/>
+            <a:off x="6434176" y="2514600"/>
+            <a:ext cx="2165528" cy="365760"/>
           </a:xfrm>
           <a:prstGeom prst="rect">
             <a:avLst/>
@@ -5903,31 +6174,31 @@
               <a:buNone/>
             </a:pPr>
             <a:r>
-              <a:rPr lang="en-US" sz="1300" dirty="0">
+              <a:rPr lang="en-US" sz="1200" dirty="0">
                 <a:solidFill>
                   <a:schemeClr val="tx2"/>
                 </a:solidFill>
               </a:rPr>
-              <a:t>custom dashboards created to date</a:t>
-            </a:r>
-            <a:endParaRPr lang="en-US" sz="1300" dirty="0"/>
+              <a:t>Custom dashboards created to date</a:t>
+            </a:r>
+            <a:endParaRPr lang="en-US" sz="1200" dirty="0"/>
           </a:p>
         </p:txBody>
       </p:sp>
       <p:sp>
         <p:nvSpPr>
-          <p:cNvPr id="12" name="adopt-3-card"/>
+          <p:cNvPr id="16" name="adopt-3-card"/>
           <p:cNvSpPr/>
           <p:nvPr/>
         </p:nvSpPr>
         <p:spPr>
           <a:xfrm>
-            <a:off x="9075191" y="1371600"/>
-            <a:ext cx="2567864" cy="1737360"/>
+            <a:off x="9075191" y="1554480"/>
+            <a:ext cx="2567864" cy="1417320"/>
           </a:xfrm>
           <a:prstGeom prst="roundRect">
             <a:avLst>
-              <a:gd name="adj" fmla="val 6316"/>
+              <a:gd name="adj" fmla="val 7742"/>
             </a:avLst>
           </a:prstGeom>
           <a:solidFill>
@@ -5938,14 +6209,14 @@
       </p:sp>
       <p:sp>
         <p:nvSpPr>
-          <p:cNvPr id="13" name="adopt-3-value"/>
+          <p:cNvPr id="17" name="adopt-3-label"/>
           <p:cNvSpPr txBox="1"/>
           <p:nvPr/>
         </p:nvSpPr>
         <p:spPr>
           <a:xfrm>
-            <a:off x="9303791" y="1554480"/>
-            <a:ext cx="2110664" cy="731520"/>
+            <a:off x="9276359" y="1664208"/>
+            <a:ext cx="2165528" cy="256032"/>
           </a:xfrm>
           <a:prstGeom prst="rect">
             <a:avLst/>
@@ -5961,27 +6232,63 @@
               <a:buNone/>
             </a:pPr>
             <a:r>
-              <a:rPr lang="en-US" sz="4000" b="1" dirty="0">
+              <a:rPr lang="en-US" sz="1000" b="1" spc="100" kern="0" dirty="0">
+                <a:solidFill>
+                  <a:schemeClr val="tx2"/>
+                </a:solidFill>
+              </a:rPr>
+              <a:t>UPDATED DAILY</a:t>
+            </a:r>
+            <a:endParaRPr lang="en-US" sz="1000" dirty="0"/>
+          </a:p>
+        </p:txBody>
+      </p:sp>
+      <p:sp>
+        <p:nvSpPr>
+          <p:cNvPr id="18" name="adopt-3-value"/>
+          <p:cNvSpPr txBox="1"/>
+          <p:nvPr/>
+        </p:nvSpPr>
+        <p:spPr>
+          <a:xfrm>
+            <a:off x="9276359" y="1920240"/>
+            <a:ext cx="2165528" cy="594360"/>
+          </a:xfrm>
+          <a:prstGeom prst="rect">
+            <a:avLst/>
+          </a:prstGeom>
+          <a:noFill/>
+          <a:ln/>
+        </p:spPr>
+        <p:txBody>
+          <a:bodyPr wrap="square" lIns="0" tIns="0" rIns="0" bIns="0" rtlCol="0" anchor="t"/>
+          <a:lstStyle/>
+          <a:p>
+            <a:pPr indent="0" marL="0">
+              <a:buNone/>
+            </a:pPr>
+            <a:r>
+              <a:rPr lang="en-US" sz="3400" b="1" dirty="0">
                 <a:solidFill>
                   <a:schemeClr val="tx1"/>
                 </a:solidFill>
               </a:rPr>
               <a:t>10+</a:t>
             </a:r>
-            <a:endParaRPr lang="en-US" sz="4000" dirty="0"/>
+            <a:endParaRPr lang="en-US" sz="3400" dirty="0"/>
           </a:p>
         </p:txBody>
       </p:sp>
       <p:sp>
         <p:nvSpPr>
-          <p:cNvPr id="14" name="adopt-3-label"/>
+          <p:cNvPr id="19" name="adopt-3-desc"/>
           <p:cNvSpPr txBox="1"/>
           <p:nvPr/>
         </p:nvSpPr>
         <p:spPr>
           <a:xfrm>
-            <a:off x="9303791" y="2286000"/>
-            <a:ext cx="2110664" cy="685800"/>
+            <a:off x="9276359" y="2514600"/>
+            <a:ext cx="2165528" cy="365760"/>
           </a:xfrm>
           <a:prstGeom prst="rect">
             <a:avLst/>
@@ -5997,26 +6304,84 @@
               <a:buNone/>
             </a:pPr>
             <a:r>
-              <a:rPr lang="en-US" sz="1300" dirty="0">
+              <a:rPr lang="en-US" sz="1200" dirty="0">
                 <a:solidFill>
                   <a:schemeClr val="tx2"/>
                 </a:solidFill>
               </a:rPr>
-              <a:t>dashboards updated every day by risk owners</a:t>
-            </a:r>
-            <a:endParaRPr lang="en-US" sz="1300" dirty="0"/>
+              <a:t>Maintained continuously by risk owners</a:t>
+            </a:r>
+            <a:endParaRPr lang="en-US" sz="1200" dirty="0"/>
+          </a:p>
+        </p:txBody>
+      </p:sp>
+      <p:sp>
+        <p:nvSpPr>
+          <p:cNvPr id="20" name="trend-card"/>
+          <p:cNvSpPr/>
+          <p:nvPr/>
+        </p:nvSpPr>
+        <p:spPr>
+          <a:xfrm>
+            <a:off x="548640" y="3200400"/>
+            <a:ext cx="6583680" cy="3246120"/>
+          </a:xfrm>
+          <a:prstGeom prst="roundRect">
+            <a:avLst>
+              <a:gd name="adj" fmla="val 3380"/>
+            </a:avLst>
+          </a:prstGeom>
+          <a:solidFill>
+            <a:schemeClr val="bg1"/>
+          </a:solidFill>
+          <a:ln/>
+        </p:spPr>
+      </p:sp>
+      <p:sp>
+        <p:nvSpPr>
+          <p:cNvPr id="21" name="trend-title"/>
+          <p:cNvSpPr txBox="1"/>
+          <p:nvPr/>
+        </p:nvSpPr>
+        <p:spPr>
+          <a:xfrm>
+            <a:off x="777240" y="3310128"/>
+            <a:ext cx="6126480" cy="274320"/>
+          </a:xfrm>
+          <a:prstGeom prst="rect">
+            <a:avLst/>
+          </a:prstGeom>
+          <a:noFill/>
+          <a:ln/>
+        </p:spPr>
+        <p:txBody>
+          <a:bodyPr wrap="square" lIns="0" tIns="0" rIns="0" bIns="0" rtlCol="0" anchor="t"/>
+          <a:lstStyle/>
+          <a:p>
+            <a:pPr indent="0" marL="0">
+              <a:buNone/>
+            </a:pPr>
+            <a:r>
+              <a:rPr lang="en-US" sz="1100" b="1" spc="100" kern="0" dirty="0">
+                <a:solidFill>
+                  <a:schemeClr val="tx1"/>
+                </a:solidFill>
+              </a:rPr>
+              <a:t>MONTHLY UNIQUE USERS TREND</a:t>
+            </a:r>
+            <a:endParaRPr lang="en-US" sz="1100" dirty="0"/>
           </a:p>
         </p:txBody>
       </p:sp>
       <p:graphicFrame>
         <p:nvGraphicFramePr>
-          <p:cNvPr id="15" name="users-by-site" descr=""/>
+          <p:cNvPr id="22" name="users-trend" descr=""/>
           <p:cNvGraphicFramePr/>
           <p:nvPr/>
         </p:nvGraphicFramePr>
         <p:xfrm>
-          <a:off x="548640" y="3337560"/>
-          <a:ext cx="6949440" cy="3063240"/>
+          <a:off x="640080" y="3611880"/>
+          <a:ext cx="6400800" cy="2560320"/>
         </p:xfrm>
         <a:graphic xmlns:a="http://schemas.openxmlformats.org/drawingml/2006/main">
           <a:graphicData uri="http://schemas.openxmlformats.org/drawingml/2006/chart">
@@ -6026,36 +6391,14 @@
       </p:graphicFrame>
       <p:sp>
         <p:nvSpPr>
-          <p:cNvPr id="16" name="adopt-why"/>
-          <p:cNvSpPr/>
-          <p:nvPr/>
-        </p:nvSpPr>
-        <p:spPr>
-          <a:xfrm>
-            <a:off x="7863840" y="3337560"/>
-            <a:ext cx="3776472" cy="3063240"/>
-          </a:xfrm>
-          <a:prstGeom prst="roundRect">
-            <a:avLst>
-              <a:gd name="adj" fmla="val 3582"/>
-            </a:avLst>
-          </a:prstGeom>
-          <a:solidFill>
-            <a:schemeClr val="tx1"/>
-          </a:solidFill>
-          <a:ln/>
-        </p:spPr>
-      </p:sp>
-      <p:sp>
-        <p:nvSpPr>
-          <p:cNvPr id="17" name="adopt-why-text"/>
+          <p:cNvPr id="23" name="trend-caption"/>
           <p:cNvSpPr txBox="1"/>
           <p:nvPr/>
         </p:nvSpPr>
         <p:spPr>
           <a:xfrm>
-            <a:off x="8092440" y="3566160"/>
-            <a:ext cx="3319272" cy="2606040"/>
+            <a:off x="777240" y="6172200"/>
+            <a:ext cx="6126480" cy="228600"/>
           </a:xfrm>
           <a:prstGeom prst="rect">
             <a:avLst/>
@@ -6071,42 +6414,254 @@
               <a:buNone/>
             </a:pPr>
             <a:r>
-              <a:rPr lang="en-US" sz="1800" b="1" dirty="0">
+              <a:rPr lang="en-US" sz="1000" i="1" dirty="0">
                 <a:solidFill>
-                  <a:schemeClr val="bg1"/>
+                  <a:schemeClr val="tx2"/>
                 </a:solidFill>
               </a:rPr>
-              <a:t>Why it had to be done right</a:t>
-            </a:r>
-            <a:endParaRPr lang="en-US" sz="1800" dirty="0"/>
-          </a:p>
+              <a:t>Approximate monthly values, read from the ERM usage chart</a:t>
+            </a:r>
+            <a:endParaRPr lang="en-US" sz="1000" dirty="0"/>
+          </a:p>
+        </p:txBody>
+      </p:sp>
+      <p:sp>
+        <p:nvSpPr>
+          <p:cNvPr id="24" name="loc-card"/>
+          <p:cNvSpPr/>
+          <p:nvPr/>
+        </p:nvSpPr>
+        <p:spPr>
+          <a:xfrm>
+            <a:off x="7406640" y="3200400"/>
+            <a:ext cx="4233672" cy="3246120"/>
+          </a:xfrm>
+          <a:prstGeom prst="roundRect">
+            <a:avLst>
+              <a:gd name="adj" fmla="val 3380"/>
+            </a:avLst>
+          </a:prstGeom>
+          <a:solidFill>
+            <a:schemeClr val="bg1"/>
+          </a:solidFill>
+          <a:ln/>
+        </p:spPr>
+      </p:sp>
+      <p:sp>
+        <p:nvSpPr>
+          <p:cNvPr id="25" name="loc-title"/>
+          <p:cNvSpPr txBox="1"/>
+          <p:nvPr/>
+        </p:nvSpPr>
+        <p:spPr>
+          <a:xfrm>
+            <a:off x="7635240" y="3310128"/>
+            <a:ext cx="3840480" cy="274320"/>
+          </a:xfrm>
+          <a:prstGeom prst="rect">
+            <a:avLst/>
+          </a:prstGeom>
+          <a:noFill/>
+          <a:ln/>
+        </p:spPr>
+        <p:txBody>
+          <a:bodyPr wrap="square" lIns="0" tIns="0" rIns="0" bIns="0" rtlCol="0" anchor="t"/>
+          <a:lstStyle/>
           <a:p>
             <a:pPr indent="0" marL="0">
               <a:buNone/>
             </a:pPr>
             <a:r>
-              <a:rPr lang="en-US" sz="800" dirty="0">
+              <a:rPr lang="en-US" sz="1100" b="1" spc="100" kern="0" dirty="0">
                 <a:solidFill>
-                  <a:srgbClr val="000000"/>
+                  <a:schemeClr val="tx1"/>
                 </a:solidFill>
               </a:rPr>
-              <a:t> </a:t>
-            </a:r>
-            <a:endParaRPr lang="en-US" sz="1800" dirty="0"/>
-          </a:p>
+              <a:t>LOCATION PROFILE: GLOBAL MULTI-SITE USE</a:t>
+            </a:r>
+            <a:endParaRPr lang="en-US" sz="1100" dirty="0"/>
+          </a:p>
+        </p:txBody>
+      </p:sp>
+      <p:sp>
+        <p:nvSpPr>
+          <p:cNvPr id="26" name="loc-intro"/>
+          <p:cNvSpPr txBox="1"/>
+          <p:nvPr/>
+        </p:nvSpPr>
+        <p:spPr>
+          <a:xfrm>
+            <a:off x="7635240" y="3657600"/>
+            <a:ext cx="3840480" cy="320040"/>
+          </a:xfrm>
+          <a:prstGeom prst="rect">
+            <a:avLst/>
+          </a:prstGeom>
+          <a:noFill/>
+          <a:ln/>
+        </p:spPr>
+        <p:txBody>
+          <a:bodyPr wrap="square" lIns="0" tIns="0" rIns="0" bIns="0" rtlCol="0" anchor="t"/>
+          <a:lstStyle/>
           <a:p>
             <a:pPr indent="0" marL="0">
               <a:buNone/>
             </a:pPr>
             <a:r>
-              <a:rPr lang="en-US" sz="1400" dirty="0">
+              <a:rPr lang="en-US" sz="1300" dirty="0">
                 <a:solidFill>
-                  <a:schemeClr val="accent5"/>
+                  <a:schemeClr val="tx2"/>
                 </a:solidFill>
               </a:rPr>
-              <a:t>ERM is part of how Airbus manages risk. A migration that broke a feature would disrupt reporting for hundreds of risk managers across sites.</a:t>
-            </a:r>
-            <a:endParaRPr lang="en-US" sz="1800" dirty="0"/>
+              <a:t>Usage spans countries and engineering campuses:</a:t>
+            </a:r>
+            <a:endParaRPr lang="en-US" sz="1300" dirty="0"/>
+          </a:p>
+        </p:txBody>
+      </p:sp>
+      <p:sp>
+        <p:nvSpPr>
+          <p:cNvPr id="27" name="loc-list"/>
+          <p:cNvSpPr txBox="1"/>
+          <p:nvPr/>
+        </p:nvSpPr>
+        <p:spPr>
+          <a:xfrm>
+            <a:off x="7635240" y="4069080"/>
+            <a:ext cx="3840480" cy="2240280"/>
+          </a:xfrm>
+          <a:prstGeom prst="rect">
+            <a:avLst/>
+          </a:prstGeom>
+          <a:noFill/>
+          <a:ln/>
+        </p:spPr>
+        <p:txBody>
+          <a:bodyPr wrap="square" lIns="0" tIns="0" rIns="0" bIns="0" rtlCol="0" anchor="t"/>
+          <a:lstStyle/>
+          <a:p>
+            <a:pPr indent="0" marL="0">
+              <a:buNone/>
+            </a:pPr>
+            <a:r>
+              <a:rPr lang="en-US" sz="1300" b="1" dirty="0">
+                <a:solidFill>
+                  <a:schemeClr val="tx1"/>
+                </a:solidFill>
+              </a:rPr>
+              <a:t>France</a:t>
+            </a:r>
+            <a:endParaRPr lang="en-US" sz="1300" dirty="0"/>
+          </a:p>
+          <a:p>
+            <a:pPr indent="0" marL="0">
+              <a:spcAft>
+                <a:spcPts val="800"/>
+              </a:spcAft>
+              <a:buNone/>
+            </a:pPr>
+            <a:r>
+              <a:rPr lang="en-US" sz="1300" dirty="0">
+                <a:solidFill>
+                  <a:schemeClr val="tx2"/>
+                </a:solidFill>
+              </a:rPr>
+              <a:t>Blagnac Wings Campus (271 users), Saint-Martin (43)</a:t>
+            </a:r>
+            <a:endParaRPr lang="en-US" sz="1300" dirty="0"/>
+          </a:p>
+          <a:p>
+            <a:pPr indent="0" marL="0">
+              <a:buNone/>
+            </a:pPr>
+            <a:r>
+              <a:rPr lang="en-US" sz="1300" b="1" dirty="0">
+                <a:solidFill>
+                  <a:schemeClr val="tx1"/>
+                </a:solidFill>
+              </a:rPr>
+              <a:t>Germany</a:t>
+            </a:r>
+            <a:endParaRPr lang="en-US" sz="1300" dirty="0"/>
+          </a:p>
+          <a:p>
+            <a:pPr indent="0" marL="0">
+              <a:spcAft>
+                <a:spcPts val="800"/>
+              </a:spcAft>
+              <a:buNone/>
+            </a:pPr>
+            <a:r>
+              <a:rPr lang="en-US" sz="1300" dirty="0">
+                <a:solidFill>
+                  <a:schemeClr val="tx2"/>
+                </a:solidFill>
+              </a:rPr>
+              <a:t>Hamburg Finkenwerder (205 users)</a:t>
+            </a:r>
+            <a:endParaRPr lang="en-US" sz="1300" dirty="0"/>
+          </a:p>
+          <a:p>
+            <a:pPr indent="0" marL="0">
+              <a:buNone/>
+            </a:pPr>
+            <a:r>
+              <a:rPr lang="en-US" sz="1300" b="1" dirty="0">
+                <a:solidFill>
+                  <a:schemeClr val="tx1"/>
+                </a:solidFill>
+              </a:rPr>
+              <a:t>United Kingdom</a:t>
+            </a:r>
+            <a:endParaRPr lang="en-US" sz="1300" dirty="0"/>
+          </a:p>
+          <a:p>
+            <a:pPr indent="0" marL="0">
+              <a:spcAft>
+                <a:spcPts val="800"/>
+              </a:spcAft>
+              <a:buNone/>
+            </a:pPr>
+            <a:r>
+              <a:rPr lang="en-US" sz="1300" dirty="0">
+                <a:solidFill>
+                  <a:schemeClr val="tx2"/>
+                </a:solidFill>
+              </a:rPr>
+              <a:t>Broughton (32 users), Filton (26)</a:t>
+            </a:r>
+            <a:endParaRPr lang="en-US" sz="1300" dirty="0"/>
+          </a:p>
+          <a:p>
+            <a:pPr indent="0" marL="0">
+              <a:buNone/>
+            </a:pPr>
+            <a:r>
+              <a:rPr lang="en-US" sz="1300" b="1" dirty="0">
+                <a:solidFill>
+                  <a:schemeClr val="tx1"/>
+                </a:solidFill>
+              </a:rPr>
+              <a:t>Spain and international</a:t>
+            </a:r>
+            <a:endParaRPr lang="en-US" sz="1300" dirty="0"/>
+          </a:p>
+          <a:p>
+            <a:pPr indent="0" marL="0">
+              <a:spcAft>
+                <a:spcPts val="800"/>
+              </a:spcAft>
+              <a:buNone/>
+            </a:pPr>
+            <a:r>
+              <a:rPr lang="en-US" sz="1300" dirty="0">
+                <a:solidFill>
+                  <a:schemeClr val="tx2"/>
+                </a:solidFill>
+              </a:rPr>
+              <a:t>Getafe (25 users), Mirabel Canada (12), Bangalore India (7)</a:t>
+            </a:r>
+            <a:endParaRPr lang="en-US" sz="1300" dirty="0"/>
           </a:p>
         </p:txBody>
       </p:sp>
@@ -6127,7 +6682,7 @@
               <p:cTn id="2" dur="indefinite" nodeType="mainSeq">
                 <p:childTnLst>
                   <p:par>
-                    <p:cTn id="54" fill="hold">
+                    <p:cTn id="86" fill="hold">
                       <p:stCondLst>
                         <p:cond delay="indefinite"/>
                         <p:cond evt="onBegin" delay="0">
@@ -6136,7 +6691,7 @@
                       </p:stCondLst>
                       <p:childTnLst>
                         <p:par>
-                          <p:cTn id="12" fill="hold">
+                          <p:cTn id="6" fill="hold">
                             <p:stCondLst>
                               <p:cond delay="0"/>
                             </p:stCondLst>
@@ -6176,93 +6731,93 @@
                                   </p:childTnLst>
                                 </p:cTn>
                               </p:par>
-                              <p:par>
-                                <p:cTn id="6" presetID="10" presetClass="entr" presetSubtype="0" fill="hold" grpId="0" nodeType="withEffect">
-                                  <p:stCondLst>
-                                    <p:cond delay="0"/>
-                                  </p:stCondLst>
-                                  <p:childTnLst>
-                                    <p:set>
-                                      <p:cBhvr>
-                                        <p:cTn id="7" dur="1" fill="hold">
-                                          <p:stCondLst>
-                                            <p:cond delay="0"/>
-                                          </p:stCondLst>
-                                        </p:cTn>
-                                        <p:tgtEl>
-                                          <p:spTgt spid="4"/>
-                                        </p:tgtEl>
-                                        <p:attrNameLst>
-                                          <p:attrName>style.visibility</p:attrName>
-                                        </p:attrNameLst>
-                                      </p:cBhvr>
-                                      <p:to>
-                                        <p:strVal val="visible"/>
-                                      </p:to>
-                                    </p:set>
-                                    <p:animEffect transition="in" filter="fade">
-                                      <p:cBhvr>
-                                        <p:cTn id="8" dur="450"/>
-                                        <p:tgtEl>
-                                          <p:spTgt spid="4"/>
-                                        </p:tgtEl>
-                                      </p:cBhvr>
-                                    </p:animEffect>
-                                  </p:childTnLst>
-                                </p:cTn>
-                              </p:par>
-                              <p:par>
-                                <p:cTn id="9" presetID="10" presetClass="entr" presetSubtype="0" fill="hold" grpId="0" nodeType="withEffect">
-                                  <p:stCondLst>
-                                    <p:cond delay="0"/>
-                                  </p:stCondLst>
-                                  <p:childTnLst>
-                                    <p:set>
-                                      <p:cBhvr>
-                                        <p:cTn id="10" dur="1" fill="hold">
-                                          <p:stCondLst>
-                                            <p:cond delay="0"/>
-                                          </p:stCondLst>
-                                        </p:cTn>
-                                        <p:tgtEl>
-                                          <p:spTgt spid="5"/>
-                                        </p:tgtEl>
-                                        <p:attrNameLst>
-                                          <p:attrName>style.visibility</p:attrName>
-                                        </p:attrNameLst>
-                                      </p:cBhvr>
-                                      <p:to>
-                                        <p:strVal val="visible"/>
-                                      </p:to>
-                                    </p:set>
-                                    <p:animEffect transition="in" filter="fade">
-                                      <p:cBhvr>
-                                        <p:cTn id="11" dur="450"/>
-                                        <p:tgtEl>
-                                          <p:spTgt spid="5"/>
-                                        </p:tgtEl>
-                                      </p:cBhvr>
-                                    </p:animEffect>
-                                  </p:childTnLst>
-                                </p:cTn>
-                              </p:par>
                             </p:childTnLst>
                           </p:cTn>
                         </p:par>
                         <p:par>
-                          <p:cTn id="22" fill="hold">
+                          <p:cTn id="19" fill="hold">
                             <p:stCondLst>
-                              <p:cond delay="450"/>
+                              <p:cond delay="400"/>
                             </p:stCondLst>
                             <p:childTnLst>
                               <p:par>
-                                <p:cTn id="13" presetID="10" presetClass="entr" presetSubtype="0" fill="hold" grpId="0" nodeType="afterEffect">
+                                <p:cTn id="7" presetID="10" presetClass="entr" presetSubtype="0" fill="hold" grpId="0" nodeType="afterEffect">
                                   <p:stCondLst>
                                     <p:cond delay="0"/>
                                   </p:stCondLst>
                                   <p:childTnLst>
                                     <p:set>
                                       <p:cBhvr>
+                                        <p:cTn id="8" dur="1" fill="hold">
+                                          <p:stCondLst>
+                                            <p:cond delay="0"/>
+                                          </p:stCondLst>
+                                        </p:cTn>
+                                        <p:tgtEl>
+                                          <p:spTgt spid="4"/>
+                                        </p:tgtEl>
+                                        <p:attrNameLst>
+                                          <p:attrName>style.visibility</p:attrName>
+                                        </p:attrNameLst>
+                                      </p:cBhvr>
+                                      <p:to>
+                                        <p:strVal val="visible"/>
+                                      </p:to>
+                                    </p:set>
+                                    <p:animEffect transition="in" filter="fade">
+                                      <p:cBhvr>
+                                        <p:cTn id="9" dur="450"/>
+                                        <p:tgtEl>
+                                          <p:spTgt spid="4"/>
+                                        </p:tgtEl>
+                                      </p:cBhvr>
+                                    </p:animEffect>
+                                  </p:childTnLst>
+                                </p:cTn>
+                              </p:par>
+                              <p:par>
+                                <p:cTn id="10" presetID="10" presetClass="entr" presetSubtype="0" fill="hold" grpId="0" nodeType="withEffect">
+                                  <p:stCondLst>
+                                    <p:cond delay="0"/>
+                                  </p:stCondLst>
+                                  <p:childTnLst>
+                                    <p:set>
+                                      <p:cBhvr>
+                                        <p:cTn id="11" dur="1" fill="hold">
+                                          <p:stCondLst>
+                                            <p:cond delay="0"/>
+                                          </p:stCondLst>
+                                        </p:cTn>
+                                        <p:tgtEl>
+                                          <p:spTgt spid="5"/>
+                                        </p:tgtEl>
+                                        <p:attrNameLst>
+                                          <p:attrName>style.visibility</p:attrName>
+                                        </p:attrNameLst>
+                                      </p:cBhvr>
+                                      <p:to>
+                                        <p:strVal val="visible"/>
+                                      </p:to>
+                                    </p:set>
+                                    <p:animEffect transition="in" filter="fade">
+                                      <p:cBhvr>
+                                        <p:cTn id="12" dur="450"/>
+                                        <p:tgtEl>
+                                          <p:spTgt spid="5"/>
+                                        </p:tgtEl>
+                                      </p:cBhvr>
+                                    </p:animEffect>
+                                  </p:childTnLst>
+                                </p:cTn>
+                              </p:par>
+                              <p:par>
+                                <p:cTn id="13" presetID="10" presetClass="entr" presetSubtype="0" fill="hold" grpId="0" nodeType="withEffect">
+                                  <p:stCondLst>
+                                    <p:cond delay="0"/>
+                                  </p:stCondLst>
+                                  <p:childTnLst>
+                                    <p:set>
+                                      <p:cBhvr>
                                         <p:cTn id="14" dur="1" fill="hold">
                                           <p:stCondLst>
                                             <p:cond delay="0"/>
@@ -6319,41 +6874,6 @@
                                         <p:cTn id="18" dur="450"/>
                                         <p:tgtEl>
                                           <p:spTgt spid="7"/>
-                                        </p:tgtEl>
-                                      </p:cBhvr>
-                                    </p:animEffect>
-                                  </p:childTnLst>
-                                </p:cTn>
-                              </p:par>
-                              <p:par>
-                                <p:cTn id="19" presetID="10" presetClass="entr" presetSubtype="0" fill="hold" grpId="0" nodeType="withEffect">
-                                  <p:stCondLst>
-                                    <p:cond delay="0"/>
-                                  </p:stCondLst>
-                                  <p:childTnLst>
-                                    <p:set>
-                                      <p:cBhvr>
-                                        <p:cTn id="20" dur="1" fill="hold">
-                                          <p:stCondLst>
-                                            <p:cond delay="0"/>
-                                          </p:stCondLst>
-                                        </p:cTn>
-                                        <p:tgtEl>
-                                          <p:spTgt spid="8"/>
-                                        </p:tgtEl>
-                                        <p:attrNameLst>
-                                          <p:attrName>style.visibility</p:attrName>
-                                        </p:attrNameLst>
-                                      </p:cBhvr>
-                                      <p:to>
-                                        <p:strVal val="visible"/>
-                                      </p:to>
-                                    </p:set>
-                                    <p:animEffect transition="in" filter="fade">
-                                      <p:cBhvr>
-                                        <p:cTn id="21" dur="450"/>
-                                        <p:tgtEl>
-                                          <p:spTgt spid="8"/>
                                         </p:tgtEl>
                                       </p:cBhvr>
                                     </p:animEffect>
@@ -6366,11 +6886,46 @@
                         <p:par>
                           <p:cTn id="32" fill="hold">
                             <p:stCondLst>
-                              <p:cond delay="900"/>
+                              <p:cond delay="800"/>
                             </p:stCondLst>
                             <p:childTnLst>
                               <p:par>
-                                <p:cTn id="23" presetID="10" presetClass="entr" presetSubtype="0" fill="hold" grpId="0" nodeType="afterEffect">
+                                <p:cTn id="20" presetID="10" presetClass="entr" presetSubtype="0" fill="hold" grpId="0" nodeType="afterEffect">
+                                  <p:stCondLst>
+                                    <p:cond delay="0"/>
+                                  </p:stCondLst>
+                                  <p:childTnLst>
+                                    <p:set>
+                                      <p:cBhvr>
+                                        <p:cTn id="21" dur="1" fill="hold">
+                                          <p:stCondLst>
+                                            <p:cond delay="0"/>
+                                          </p:stCondLst>
+                                        </p:cTn>
+                                        <p:tgtEl>
+                                          <p:spTgt spid="8"/>
+                                        </p:tgtEl>
+                                        <p:attrNameLst>
+                                          <p:attrName>style.visibility</p:attrName>
+                                        </p:attrNameLst>
+                                      </p:cBhvr>
+                                      <p:to>
+                                        <p:strVal val="visible"/>
+                                      </p:to>
+                                    </p:set>
+                                    <p:animEffect transition="in" filter="fade">
+                                      <p:cBhvr>
+                                        <p:cTn id="22" dur="450"/>
+                                        <p:tgtEl>
+                                          <p:spTgt spid="8"/>
+                                        </p:tgtEl>
+                                      </p:cBhvr>
+                                    </p:animEffect>
+                                  </p:childTnLst>
+                                </p:cTn>
+                              </p:par>
+                              <p:par>
+                                <p:cTn id="23" presetID="10" presetClass="entr" presetSubtype="0" fill="hold" grpId="0" nodeType="withEffect">
                                   <p:stCondLst>
                                     <p:cond delay="0"/>
                                   </p:stCondLst>
@@ -6478,9 +7033,9 @@
                           </p:cTn>
                         </p:par>
                         <p:par>
-                          <p:cTn id="42" fill="hold">
+                          <p:cTn id="45" fill="hold">
                             <p:stCondLst>
-                              <p:cond delay="1350"/>
+                              <p:cond delay="1200"/>
                             </p:stCondLst>
                             <p:childTnLst>
                               <p:par>
@@ -6582,6 +7137,41 @@
                                         <p:cTn id="41" dur="450"/>
                                         <p:tgtEl>
                                           <p:spTgt spid="14"/>
+                                        </p:tgtEl>
+                                      </p:cBhvr>
+                                    </p:animEffect>
+                                  </p:childTnLst>
+                                </p:cTn>
+                              </p:par>
+                              <p:par>
+                                <p:cTn id="42" presetID="10" presetClass="entr" presetSubtype="0" fill="hold" grpId="0" nodeType="withEffect">
+                                  <p:stCondLst>
+                                    <p:cond delay="0"/>
+                                  </p:stCondLst>
+                                  <p:childTnLst>
+                                    <p:set>
+                                      <p:cBhvr>
+                                        <p:cTn id="43" dur="1" fill="hold">
+                                          <p:stCondLst>
+                                            <p:cond delay="0"/>
+                                          </p:stCondLst>
+                                        </p:cTn>
+                                        <p:tgtEl>
+                                          <p:spTgt spid="15"/>
+                                        </p:tgtEl>
+                                        <p:attrNameLst>
+                                          <p:attrName>style.visibility</p:attrName>
+                                        </p:attrNameLst>
+                                      </p:cBhvr>
+                                      <p:to>
+                                        <p:strVal val="visible"/>
+                                      </p:to>
+                                    </p:set>
+                                    <p:animEffect transition="in" filter="fade">
+                                      <p:cBhvr>
+                                        <p:cTn id="44" dur="450"/>
+                                        <p:tgtEl>
+                                          <p:spTgt spid="15"/>
                                         </p:tgtEl>
                                       </p:cBhvr>
                                     </p:animEffect>
@@ -6592,40 +7182,145 @@
                           </p:cTn>
                         </p:par>
                         <p:par>
-                          <p:cTn id="46" fill="hold">
+                          <p:cTn id="58" fill="hold">
                             <p:stCondLst>
-                              <p:cond delay="1800"/>
+                              <p:cond delay="1600"/>
                             </p:stCondLst>
                             <p:childTnLst>
                               <p:par>
-                                <p:cTn id="43" presetID="22" presetClass="entr" presetSubtype="8" fill="hold" grpId="0" nodeType="afterEffect">
+                                <p:cTn id="46" presetID="10" presetClass="entr" presetSubtype="0" fill="hold" grpId="0" nodeType="afterEffect">
                                   <p:stCondLst>
                                     <p:cond delay="0"/>
                                   </p:stCondLst>
                                   <p:childTnLst>
                                     <p:set>
                                       <p:cBhvr>
-                                        <p:cTn id="44" dur="1" fill="hold">
-                                          <p:stCondLst>
-                                            <p:cond delay="0"/>
-                                          </p:stCondLst>
-                                        </p:cTn>
-                                        <p:tgtEl>
-                                          <p:spTgt spid="15"/>
-                                        </p:tgtEl>
-                                        <p:attrNameLst>
-                                          <p:attrName>style.visibility</p:attrName>
-                                        </p:attrNameLst>
-                                      </p:cBhvr>
-                                      <p:to>
-                                        <p:strVal val="visible"/>
-                                      </p:to>
-                                    </p:set>
-                                    <p:animEffect transition="in" filter="wipe(left)">
-                                      <p:cBhvr>
-                                        <p:cTn id="45" dur="450"/>
-                                        <p:tgtEl>
-                                          <p:spTgt spid="15"/>
+                                        <p:cTn id="47" dur="1" fill="hold">
+                                          <p:stCondLst>
+                                            <p:cond delay="0"/>
+                                          </p:stCondLst>
+                                        </p:cTn>
+                                        <p:tgtEl>
+                                          <p:spTgt spid="16"/>
+                                        </p:tgtEl>
+                                        <p:attrNameLst>
+                                          <p:attrName>style.visibility</p:attrName>
+                                        </p:attrNameLst>
+                                      </p:cBhvr>
+                                      <p:to>
+                                        <p:strVal val="visible"/>
+                                      </p:to>
+                                    </p:set>
+                                    <p:animEffect transition="in" filter="fade">
+                                      <p:cBhvr>
+                                        <p:cTn id="48" dur="450"/>
+                                        <p:tgtEl>
+                                          <p:spTgt spid="16"/>
+                                        </p:tgtEl>
+                                      </p:cBhvr>
+                                    </p:animEffect>
+                                  </p:childTnLst>
+                                </p:cTn>
+                              </p:par>
+                              <p:par>
+                                <p:cTn id="49" presetID="10" presetClass="entr" presetSubtype="0" fill="hold" grpId="0" nodeType="withEffect">
+                                  <p:stCondLst>
+                                    <p:cond delay="0"/>
+                                  </p:stCondLst>
+                                  <p:childTnLst>
+                                    <p:set>
+                                      <p:cBhvr>
+                                        <p:cTn id="50" dur="1" fill="hold">
+                                          <p:stCondLst>
+                                            <p:cond delay="0"/>
+                                          </p:stCondLst>
+                                        </p:cTn>
+                                        <p:tgtEl>
+                                          <p:spTgt spid="17"/>
+                                        </p:tgtEl>
+                                        <p:attrNameLst>
+                                          <p:attrName>style.visibility</p:attrName>
+                                        </p:attrNameLst>
+                                      </p:cBhvr>
+                                      <p:to>
+                                        <p:strVal val="visible"/>
+                                      </p:to>
+                                    </p:set>
+                                    <p:animEffect transition="in" filter="fade">
+                                      <p:cBhvr>
+                                        <p:cTn id="51" dur="450"/>
+                                        <p:tgtEl>
+                                          <p:spTgt spid="17"/>
+                                        </p:tgtEl>
+                                      </p:cBhvr>
+                                    </p:animEffect>
+                                  </p:childTnLst>
+                                </p:cTn>
+                              </p:par>
+                              <p:par>
+                                <p:cTn id="52" presetID="10" presetClass="entr" presetSubtype="0" fill="hold" grpId="0" nodeType="withEffect">
+                                  <p:stCondLst>
+                                    <p:cond delay="0"/>
+                                  </p:stCondLst>
+                                  <p:childTnLst>
+                                    <p:set>
+                                      <p:cBhvr>
+                                        <p:cTn id="53" dur="1" fill="hold">
+                                          <p:stCondLst>
+                                            <p:cond delay="0"/>
+                                          </p:stCondLst>
+                                        </p:cTn>
+                                        <p:tgtEl>
+                                          <p:spTgt spid="18"/>
+                                        </p:tgtEl>
+                                        <p:attrNameLst>
+                                          <p:attrName>style.visibility</p:attrName>
+                                        </p:attrNameLst>
+                                      </p:cBhvr>
+                                      <p:to>
+                                        <p:strVal val="visible"/>
+                                      </p:to>
+                                    </p:set>
+                                    <p:animEffect transition="in" filter="fade">
+                                      <p:cBhvr>
+                                        <p:cTn id="54" dur="450"/>
+                                        <p:tgtEl>
+                                          <p:spTgt spid="18"/>
+                                        </p:tgtEl>
+                                      </p:cBhvr>
+                                    </p:animEffect>
+                                  </p:childTnLst>
+                                </p:cTn>
+                              </p:par>
+                              <p:par>
+                                <p:cTn id="55" presetID="10" presetClass="entr" presetSubtype="0" fill="hold" grpId="0" nodeType="withEffect">
+                                  <p:stCondLst>
+                                    <p:cond delay="0"/>
+                                  </p:stCondLst>
+                                  <p:childTnLst>
+                                    <p:set>
+                                      <p:cBhvr>
+                                        <p:cTn id="56" dur="1" fill="hold">
+                                          <p:stCondLst>
+                                            <p:cond delay="0"/>
+                                          </p:stCondLst>
+                                        </p:cTn>
+                                        <p:tgtEl>
+                                          <p:spTgt spid="19"/>
+                                        </p:tgtEl>
+                                        <p:attrNameLst>
+                                          <p:attrName>style.visibility</p:attrName>
+                                        </p:attrNameLst>
+                                      </p:cBhvr>
+                                      <p:to>
+                                        <p:strVal val="visible"/>
+                                      </p:to>
+                                    </p:set>
+                                    <p:animEffect transition="in" filter="fade">
+                                      <p:cBhvr>
+                                        <p:cTn id="57" dur="450"/>
+                                        <p:tgtEl>
+                                          <p:spTgt spid="19"/>
                                         </p:tgtEl>
                                       </p:cBhvr>
                                     </p:animEffect>
@@ -6636,26 +7331,26 @@
                           </p:cTn>
                         </p:par>
                         <p:par>
-                          <p:cTn id="53" fill="hold">
+                          <p:cTn id="71" fill="hold">
                             <p:stCondLst>
-                              <p:cond delay="2250"/>
+                              <p:cond delay="2000"/>
                             </p:stCondLst>
                             <p:childTnLst>
                               <p:par>
-                                <p:cTn id="47" presetID="10" presetClass="entr" presetSubtype="0" fill="hold" grpId="0" nodeType="afterEffect">
+                                <p:cTn id="59" presetID="10" presetClass="entr" presetSubtype="0" fill="hold" grpId="0" nodeType="afterEffect">
                                   <p:stCondLst>
                                     <p:cond delay="0"/>
                                   </p:stCondLst>
                                   <p:childTnLst>
                                     <p:set>
                                       <p:cBhvr>
-                                        <p:cTn id="48" dur="1" fill="hold">
-                                          <p:stCondLst>
-                                            <p:cond delay="0"/>
-                                          </p:stCondLst>
-                                        </p:cTn>
-                                        <p:tgtEl>
-                                          <p:spTgt spid="16"/>
+                                        <p:cTn id="60" dur="1" fill="hold">
+                                          <p:stCondLst>
+                                            <p:cond delay="0"/>
+                                          </p:stCondLst>
+                                        </p:cTn>
+                                        <p:tgtEl>
+                                          <p:spTgt spid="20"/>
                                         </p:tgtEl>
                                         <p:attrNameLst>
                                           <p:attrName>style.visibility</p:attrName>
@@ -6667,30 +7362,30 @@
                                     </p:set>
                                     <p:animEffect transition="in" filter="fade">
                                       <p:cBhvr>
-                                        <p:cTn id="49" dur="450"/>
-                                        <p:tgtEl>
-                                          <p:spTgt spid="16"/>
-                                        </p:tgtEl>
-                                      </p:cBhvr>
-                                    </p:animEffect>
-                                  </p:childTnLst>
-                                </p:cTn>
-                              </p:par>
-                              <p:par>
-                                <p:cTn id="50" presetID="10" presetClass="entr" presetSubtype="0" fill="hold" grpId="0" nodeType="withEffect">
+                                        <p:cTn id="61" dur="450"/>
+                                        <p:tgtEl>
+                                          <p:spTgt spid="20"/>
+                                        </p:tgtEl>
+                                      </p:cBhvr>
+                                    </p:animEffect>
+                                  </p:childTnLst>
+                                </p:cTn>
+                              </p:par>
+                              <p:par>
+                                <p:cTn id="62" presetID="10" presetClass="entr" presetSubtype="0" fill="hold" grpId="0" nodeType="withEffect">
                                   <p:stCondLst>
                                     <p:cond delay="0"/>
                                   </p:stCondLst>
                                   <p:childTnLst>
                                     <p:set>
                                       <p:cBhvr>
-                                        <p:cTn id="51" dur="1" fill="hold">
-                                          <p:stCondLst>
-                                            <p:cond delay="0"/>
-                                          </p:stCondLst>
-                                        </p:cTn>
-                                        <p:tgtEl>
-                                          <p:spTgt spid="17"/>
+                                        <p:cTn id="63" dur="1" fill="hold">
+                                          <p:stCondLst>
+                                            <p:cond delay="0"/>
+                                          </p:stCondLst>
+                                        </p:cTn>
+                                        <p:tgtEl>
+                                          <p:spTgt spid="21"/>
                                         </p:tgtEl>
                                         <p:attrNameLst>
                                           <p:attrName>style.visibility</p:attrName>
@@ -6702,9 +7397,237 @@
                                     </p:set>
                                     <p:animEffect transition="in" filter="fade">
                                       <p:cBhvr>
-                                        <p:cTn id="52" dur="450"/>
-                                        <p:tgtEl>
-                                          <p:spTgt spid="17"/>
+                                        <p:cTn id="64" dur="450"/>
+                                        <p:tgtEl>
+                                          <p:spTgt spid="21"/>
+                                        </p:tgtEl>
+                                      </p:cBhvr>
+                                    </p:animEffect>
+                                  </p:childTnLst>
+                                </p:cTn>
+                              </p:par>
+                              <p:par>
+                                <p:cTn id="65" presetID="10" presetClass="entr" presetSubtype="0" fill="hold" grpId="0" nodeType="withEffect">
+                                  <p:stCondLst>
+                                    <p:cond delay="0"/>
+                                  </p:stCondLst>
+                                  <p:childTnLst>
+                                    <p:set>
+                                      <p:cBhvr>
+                                        <p:cTn id="66" dur="1" fill="hold">
+                                          <p:stCondLst>
+                                            <p:cond delay="0"/>
+                                          </p:stCondLst>
+                                        </p:cTn>
+                                        <p:tgtEl>
+                                          <p:spTgt spid="23"/>
+                                        </p:tgtEl>
+                                        <p:attrNameLst>
+                                          <p:attrName>style.visibility</p:attrName>
+                                        </p:attrNameLst>
+                                      </p:cBhvr>
+                                      <p:to>
+                                        <p:strVal val="visible"/>
+                                      </p:to>
+                                    </p:set>
+                                    <p:animEffect transition="in" filter="fade">
+                                      <p:cBhvr>
+                                        <p:cTn id="67" dur="450"/>
+                                        <p:tgtEl>
+                                          <p:spTgt spid="23"/>
+                                        </p:tgtEl>
+                                      </p:cBhvr>
+                                    </p:animEffect>
+                                  </p:childTnLst>
+                                </p:cTn>
+                              </p:par>
+                              <p:par>
+                                <p:cTn id="68" presetID="22" presetClass="entr" presetSubtype="8" fill="hold" grpId="0" nodeType="withEffect">
+                                  <p:stCondLst>
+                                    <p:cond delay="200"/>
+                                  </p:stCondLst>
+                                  <p:childTnLst>
+                                    <p:set>
+                                      <p:cBhvr>
+                                        <p:cTn id="69" dur="1" fill="hold">
+                                          <p:stCondLst>
+                                            <p:cond delay="0"/>
+                                          </p:stCondLst>
+                                        </p:cTn>
+                                        <p:tgtEl>
+                                          <p:spTgt spid="22"/>
+                                        </p:tgtEl>
+                                        <p:attrNameLst>
+                                          <p:attrName>style.visibility</p:attrName>
+                                        </p:attrNameLst>
+                                      </p:cBhvr>
+                                      <p:to>
+                                        <p:strVal val="visible"/>
+                                      </p:to>
+                                    </p:set>
+                                    <p:animEffect transition="in" filter="wipe(left)">
+                                      <p:cBhvr>
+                                        <p:cTn id="70" dur="450"/>
+                                        <p:tgtEl>
+                                          <p:spTgt spid="22"/>
+                                        </p:tgtEl>
+                                      </p:cBhvr>
+                                    </p:animEffect>
+                                  </p:childTnLst>
+                                </p:cTn>
+                              </p:par>
+                            </p:childTnLst>
+                          </p:cTn>
+                        </p:par>
+                        <p:par>
+                          <p:cTn id="81" fill="hold">
+                            <p:stCondLst>
+                              <p:cond delay="2400"/>
+                            </p:stCondLst>
+                            <p:childTnLst>
+                              <p:par>
+                                <p:cTn id="72" presetID="10" presetClass="entr" presetSubtype="0" fill="hold" grpId="0" nodeType="afterEffect">
+                                  <p:stCondLst>
+                                    <p:cond delay="0"/>
+                                  </p:stCondLst>
+                                  <p:childTnLst>
+                                    <p:set>
+                                      <p:cBhvr>
+                                        <p:cTn id="73" dur="1" fill="hold">
+                                          <p:stCondLst>
+                                            <p:cond delay="0"/>
+                                          </p:stCondLst>
+                                        </p:cTn>
+                                        <p:tgtEl>
+                                          <p:spTgt spid="24"/>
+                                        </p:tgtEl>
+                                        <p:attrNameLst>
+                                          <p:attrName>style.visibility</p:attrName>
+                                        </p:attrNameLst>
+                                      </p:cBhvr>
+                                      <p:to>
+                                        <p:strVal val="visible"/>
+                                      </p:to>
+                                    </p:set>
+                                    <p:animEffect transition="in" filter="fade">
+                                      <p:cBhvr>
+                                        <p:cTn id="74" dur="450"/>
+                                        <p:tgtEl>
+                                          <p:spTgt spid="24"/>
+                                        </p:tgtEl>
+                                      </p:cBhvr>
+                                    </p:animEffect>
+                                  </p:childTnLst>
+                                </p:cTn>
+                              </p:par>
+                              <p:par>
+                                <p:cTn id="75" presetID="10" presetClass="entr" presetSubtype="0" fill="hold" grpId="0" nodeType="withEffect">
+                                  <p:stCondLst>
+                                    <p:cond delay="0"/>
+                                  </p:stCondLst>
+                                  <p:childTnLst>
+                                    <p:set>
+                                      <p:cBhvr>
+                                        <p:cTn id="76" dur="1" fill="hold">
+                                          <p:stCondLst>
+                                            <p:cond delay="0"/>
+                                          </p:stCondLst>
+                                        </p:cTn>
+                                        <p:tgtEl>
+                                          <p:spTgt spid="25"/>
+                                        </p:tgtEl>
+                                        <p:attrNameLst>
+                                          <p:attrName>style.visibility</p:attrName>
+                                        </p:attrNameLst>
+                                      </p:cBhvr>
+                                      <p:to>
+                                        <p:strVal val="visible"/>
+                                      </p:to>
+                                    </p:set>
+                                    <p:animEffect transition="in" filter="fade">
+                                      <p:cBhvr>
+                                        <p:cTn id="77" dur="450"/>
+                                        <p:tgtEl>
+                                          <p:spTgt spid="25"/>
+                                        </p:tgtEl>
+                                      </p:cBhvr>
+                                    </p:animEffect>
+                                  </p:childTnLst>
+                                </p:cTn>
+                              </p:par>
+                              <p:par>
+                                <p:cTn id="78" presetID="10" presetClass="entr" presetSubtype="0" fill="hold" grpId="0" nodeType="withEffect">
+                                  <p:stCondLst>
+                                    <p:cond delay="0"/>
+                                  </p:stCondLst>
+                                  <p:childTnLst>
+                                    <p:set>
+                                      <p:cBhvr>
+                                        <p:cTn id="79" dur="1" fill="hold">
+                                          <p:stCondLst>
+                                            <p:cond delay="0"/>
+                                          </p:stCondLst>
+                                        </p:cTn>
+                                        <p:tgtEl>
+                                          <p:spTgt spid="26"/>
+                                        </p:tgtEl>
+                                        <p:attrNameLst>
+                                          <p:attrName>style.visibility</p:attrName>
+                                        </p:attrNameLst>
+                                      </p:cBhvr>
+                                      <p:to>
+                                        <p:strVal val="visible"/>
+                                      </p:to>
+                                    </p:set>
+                                    <p:animEffect transition="in" filter="fade">
+                                      <p:cBhvr>
+                                        <p:cTn id="80" dur="450"/>
+                                        <p:tgtEl>
+                                          <p:spTgt spid="26"/>
+                                        </p:tgtEl>
+                                      </p:cBhvr>
+                                    </p:animEffect>
+                                  </p:childTnLst>
+                                </p:cTn>
+                              </p:par>
+                            </p:childTnLst>
+                          </p:cTn>
+                        </p:par>
+                        <p:par>
+                          <p:cTn id="85" fill="hold">
+                            <p:stCondLst>
+                              <p:cond delay="2800"/>
+                            </p:stCondLst>
+                            <p:childTnLst>
+                              <p:par>
+                                <p:cTn id="82" presetID="10" presetClass="entr" presetSubtype="0" fill="hold" grpId="0" nodeType="afterEffect">
+                                  <p:stCondLst>
+                                    <p:cond delay="0"/>
+                                  </p:stCondLst>
+                                  <p:childTnLst>
+                                    <p:set>
+                                      <p:cBhvr>
+                                        <p:cTn id="83" dur="1" fill="hold">
+                                          <p:stCondLst>
+                                            <p:cond delay="0"/>
+                                          </p:stCondLst>
+                                        </p:cTn>
+                                        <p:tgtEl>
+                                          <p:spTgt spid="27"/>
+                                        </p:tgtEl>
+                                        <p:attrNameLst>
+                                          <p:attrName>style.visibility</p:attrName>
+                                        </p:attrNameLst>
+                                      </p:cBhvr>
+                                      <p:to>
+                                        <p:strVal val="visible"/>
+                                      </p:to>
+                                    </p:set>
+                                    <p:animEffect transition="in" filter="fade">
+                                      <p:cBhvr>
+                                        <p:cTn id="84" dur="450"/>
+                                        <p:tgtEl>
+                                          <p:spTgt spid="27"/>
                                         </p:tgtEl>
                                       </p:cBhvr>
                                     </p:animEffect>
@@ -6751,8 +7674,18 @@
       <p:bldP spid="12" grpId="0" animBg="1"/>
       <p:bldP spid="13" grpId="0" animBg="1"/>
       <p:bldP spid="14" grpId="0" animBg="1"/>
+      <p:bldP spid="15" grpId="0" animBg="1"/>
       <p:bldP spid="16" grpId="0" animBg="1"/>
       <p:bldP spid="17" grpId="0" animBg="1"/>
+      <p:bldP spid="18" grpId="0" animBg="1"/>
+      <p:bldP spid="19" grpId="0" animBg="1"/>
+      <p:bldP spid="20" grpId="0" animBg="1"/>
+      <p:bldP spid="21" grpId="0" animBg="1"/>
+      <p:bldP spid="23" grpId="0" animBg="1"/>
+      <p:bldP spid="24" grpId="0" animBg="1"/>
+      <p:bldP spid="25" grpId="0" animBg="1"/>
+      <p:bldP spid="26" grpId="0" animBg="1"/>
+      <p:bldP spid="27" grpId="0" animBg="1"/>
     </p:bldLst>
   </p:timing>
 </p:sld>

</xml_diff>

<commit_message>
v2 pitch: merge proof and faster-to-build slides, drop go-live row; drop 11-files metric in both
Co-Authored-By: Claude Opus 5.5 <noreply@anthropic.com>
Claude-Session: https://claude.ai/code/session_01HdxEbeqqWM97gKbcNqpjAq
</commit_message>
<xml_diff>
--- a/erm-migration/docs/ERM-Migration-Jury-Pitch.pptx
+++ b/erm-migration/docs/ERM-Migration-Jury-Pitch.pptx
@@ -118,25 +118,25 @@
   <p:extLst>
     <p:ext uri="{521415D9-36F7-43E2-AB2F-B90AF26B5E84}">
       <p14:sectionLst xmlns:p14="http://schemas.microsoft.com/office/powerpoint/2010/main">
-        <p14:section name="Pitch" id="{d916c957-daf2-c608-d878-8673d4279de4}">
+        <p14:section name="Pitch" id="{39d5b421-b7c5-776b-9880-1fb9a7d5555d}">
           <p14:sldIdLst>
             <p14:sldId id="256"/>
           </p14:sldIdLst>
         </p14:section>
-        <p14:section name="Context" id="{91f07159-1eff-7fef-99ef-16bb23de2640}">
+        <p14:section name="Context" id="{3e9bfaa9-cb89-78cd-c9fc-d15db49999f6}">
           <p14:sldIdLst>
             <p14:sldId id="257"/>
             <p14:sldId id="258"/>
             <p14:sldId id="259"/>
           </p14:sldIdLst>
         </p14:section>
-        <p14:section name="Problem and method" id="{a40653da-c0c5-a815-7d21-3a4f03fca472}">
+        <p14:section name="Problem and method" id="{6515b38d-5baa-0eb1-8306-2ef8415a0834}">
           <p14:sldIdLst>
             <p14:sldId id="260"/>
             <p14:sldId id="261"/>
           </p14:sldIdLst>
         </p14:section>
-        <p14:section name="Impact" id="{72119732-8eef-6e12-fa01-e32899b55249}">
+        <p14:section name="Impact" id="{faddd1e6-c95b-53cc-9af7-ccd2c2d39f87}">
           <p14:sldIdLst>
             <p14:sldId id="262"/>
             <p14:sldId id="263"/>
@@ -145,7 +145,7 @@
             <p14:sldId id="266"/>
           </p14:sldIdLst>
         </p14:section>
-        <p14:section name="Reuse" id="{1d88723a-52ec-60e5-75ed-0f0d34fa04f1}">
+        <p14:section name="Reuse" id="{58499a7c-bb27-cb5d-6f2f-07703843f999}">
           <p14:sldIdLst>
             <p14:sldId id="267"/>
           </p14:sldIdLst>
@@ -2200,7 +2200,7 @@
           <a:p>
             <a:r>
               <a:rPr lang="en-US" dirty="0"/>
-              <a:t>Building new features is now easy, and that keeps paying back. During the same PI we built 11 features Slate never had: permissions-only edit for locked versions, a web address per tab, a searchable dashboard switcher, a criticality-differs filter, category and impact-category filters, a fourth one-pager layout with custom slots, resizable columns saved per board, report classification and cover toggle, slideshow mode, one-pager selection shortcuts, and showing risks by ID or title. One change added app-wide notifications and automatic list refresh across 11 files. 25 MB of Slate configuration became about 0.8 MB of typed source in 75 files. In Slate, a feature meant wiring widgets, events, variables and functions across 8 exports, with no documentation; in React it is one typed component and one OSDK call, and pack-project.ts gives AI the whole app as context. On recurring cost: using a common rule of thumb that maintenance costs about 20% of build effort a year, a Slate-equivalent app would need about 68 person-days a year, around $21,000 at $38.50 an hour. Assuming modular, typed, documented code halves that, we save around $10,000 a year. Say clearly these are estimates.</a:t>
+              <a:t>Building new features is now easy, and that keeps paying back. During the same PI we built 11 features Slate never had: permissions-only edit for locked versions, a web address per tab, a searchable dashboard switcher, a criticality-differs filter, category and impact-category filters, a fourth one-pager layout with custom slots, resizable columns saved per board, report classification and cover toggle, slideshow mode, one-pager selection shortcuts, and showing risks by ID or title. 25 MB of Slate configuration became about 0.8 MB of typed source in 75 files. In Slate, a feature meant wiring widgets, events, variables and functions across 8 exports, with no documentation; in React it is one typed component and one OSDK call, and pack-project.ts gives AI the whole app as context. On recurring cost: using a common rule of thumb that maintenance costs about 20% of build effort a year, a Slate-equivalent app would need about 68 person-days a year, around $21,000 at $38.50 an hour. Assuming modular, typed, documented code halves that, we save around $10,000 a year. Say clearly these are estimates.</a:t>
             </a:r>
             <a:endParaRPr lang="en-US" dirty="0"/>
           </a:p>
@@ -17079,7 +17079,7 @@
         <p:spPr>
           <a:xfrm>
             <a:off x="548640" y="1371600"/>
-            <a:ext cx="2567864" cy="1554480"/>
+            <a:ext cx="3515258" cy="1554480"/>
           </a:xfrm>
           <a:prstGeom prst="roundRect">
             <a:avLst>
@@ -17101,7 +17101,7 @@
         <p:spPr>
           <a:xfrm>
             <a:off x="749808" y="1481328"/>
-            <a:ext cx="2165528" cy="640080"/>
+            <a:ext cx="3112922" cy="640080"/>
           </a:xfrm>
           <a:prstGeom prst="rect">
             <a:avLst/>
@@ -17137,7 +17137,7 @@
         <p:spPr>
           <a:xfrm>
             <a:off x="749808" y="2148840"/>
-            <a:ext cx="2165528" cy="685800"/>
+            <a:ext cx="3112922" cy="685800"/>
           </a:xfrm>
           <a:prstGeom prst="rect">
             <a:avLst/>
@@ -17172,8 +17172,8 @@
         </p:nvSpPr>
         <p:spPr>
           <a:xfrm>
-            <a:off x="3390824" y="1371600"/>
-            <a:ext cx="2567864" cy="1554480"/>
+            <a:off x="4338218" y="1371600"/>
+            <a:ext cx="3515258" cy="1554480"/>
           </a:xfrm>
           <a:prstGeom prst="roundRect">
             <a:avLst>
@@ -17194,8 +17194,8 @@
         </p:nvSpPr>
         <p:spPr>
           <a:xfrm>
-            <a:off x="3591992" y="1481328"/>
-            <a:ext cx="2165528" cy="640080"/>
+            <a:off x="4539386" y="1481328"/>
+            <a:ext cx="3112922" cy="640080"/>
           </a:xfrm>
           <a:prstGeom prst="rect">
             <a:avLst/>
@@ -17216,7 +17216,7 @@
                   <a:schemeClr val="tx1"/>
                 </a:solidFill>
               </a:rPr>
-              <a:t>11 files</a:t>
+              <a:t>−97%</a:t>
             </a:r>
             <a:endParaRPr lang="en-US" sz="3400" dirty="0"/>
           </a:p>
@@ -17230,8 +17230,8 @@
         </p:nvSpPr>
         <p:spPr>
           <a:xfrm>
-            <a:off x="3591992" y="2148840"/>
-            <a:ext cx="2165528" cy="685800"/>
+            <a:off x="4539386" y="2148840"/>
+            <a:ext cx="3112922" cy="685800"/>
           </a:xfrm>
           <a:prstGeom prst="rect">
             <a:avLst/>
@@ -17252,7 +17252,7 @@
                   <a:schemeClr val="tx2"/>
                 </a:solidFill>
               </a:rPr>
-              <a:t>one change added app-wide notifications and auto-refresh</a:t>
+              <a:t>25 MB of Slate configuration became 0.8 MB of typed code</a:t>
             </a:r>
             <a:endParaRPr lang="en-US" sz="1300" dirty="0"/>
           </a:p>
@@ -17266,8 +17266,8 @@
         </p:nvSpPr>
         <p:spPr>
           <a:xfrm>
-            <a:off x="6233008" y="1371600"/>
-            <a:ext cx="2567864" cy="1554480"/>
+            <a:off x="8127797" y="1371600"/>
+            <a:ext cx="3515258" cy="1554480"/>
           </a:xfrm>
           <a:prstGeom prst="roundRect">
             <a:avLst>
@@ -17275,7 +17275,7 @@
             </a:avLst>
           </a:prstGeom>
           <a:solidFill>
-            <a:schemeClr val="bg1"/>
+            <a:schemeClr val="tx1"/>
           </a:solidFill>
           <a:ln/>
         </p:spPr>
@@ -17288,8 +17288,8 @@
         </p:nvSpPr>
         <p:spPr>
           <a:xfrm>
-            <a:off x="6434176" y="1481328"/>
-            <a:ext cx="2165528" cy="640080"/>
+            <a:off x="8328965" y="1481328"/>
+            <a:ext cx="3112922" cy="640080"/>
           </a:xfrm>
           <a:prstGeom prst="rect">
             <a:avLst/>
@@ -17307,10 +17307,10 @@
             <a:r>
               <a:rPr lang="en-US" sz="3400" b="1" dirty="0">
                 <a:solidFill>
-                  <a:schemeClr val="tx1"/>
+                  <a:schemeClr val="accent5"/>
                 </a:solidFill>
               </a:rPr>
-              <a:t>−97%</a:t>
+              <a:t>~$10K</a:t>
             </a:r>
             <a:endParaRPr lang="en-US" sz="3400" dirty="0"/>
           </a:p>
@@ -17324,8 +17324,8 @@
         </p:nvSpPr>
         <p:spPr>
           <a:xfrm>
-            <a:off x="6434176" y="2148840"/>
-            <a:ext cx="2165528" cy="685800"/>
+            <a:off x="8328965" y="2148840"/>
+            <a:ext cx="3112922" cy="685800"/>
           </a:xfrm>
           <a:prstGeom prst="rect">
             <a:avLst/>
@@ -17343,100 +17343,6 @@
             <a:r>
               <a:rPr lang="en-US" sz="1300" dirty="0">
                 <a:solidFill>
-                  <a:schemeClr val="tx2"/>
-                </a:solidFill>
-              </a:rPr>
-              <a:t>25 MB of Slate configuration became 0.8 MB of typed code</a:t>
-            </a:r>
-            <a:endParaRPr lang="en-US" sz="1300" dirty="0"/>
-          </a:p>
-        </p:txBody>
-      </p:sp>
-      <p:sp>
-        <p:nvSpPr>
-          <p:cNvPr id="12" name="ease-3-card"/>
-          <p:cNvSpPr/>
-          <p:nvPr/>
-        </p:nvSpPr>
-        <p:spPr>
-          <a:xfrm>
-            <a:off x="9075191" y="1371600"/>
-            <a:ext cx="2567864" cy="1554480"/>
-          </a:xfrm>
-          <a:prstGeom prst="roundRect">
-            <a:avLst>
-              <a:gd name="adj" fmla="val 7059"/>
-            </a:avLst>
-          </a:prstGeom>
-          <a:solidFill>
-            <a:schemeClr val="tx1"/>
-          </a:solidFill>
-          <a:ln/>
-        </p:spPr>
-      </p:sp>
-      <p:sp>
-        <p:nvSpPr>
-          <p:cNvPr id="13" name="ease-3-value"/>
-          <p:cNvSpPr txBox="1"/>
-          <p:nvPr/>
-        </p:nvSpPr>
-        <p:spPr>
-          <a:xfrm>
-            <a:off x="9276359" y="1481328"/>
-            <a:ext cx="2165528" cy="640080"/>
-          </a:xfrm>
-          <a:prstGeom prst="rect">
-            <a:avLst/>
-          </a:prstGeom>
-          <a:noFill/>
-          <a:ln/>
-        </p:spPr>
-        <p:txBody>
-          <a:bodyPr wrap="square" lIns="0" tIns="0" rIns="0" bIns="0" rtlCol="0" anchor="t"/>
-          <a:lstStyle/>
-          <a:p>
-            <a:pPr indent="0" marL="0">
-              <a:buNone/>
-            </a:pPr>
-            <a:r>
-              <a:rPr lang="en-US" sz="3400" b="1" dirty="0">
-                <a:solidFill>
-                  <a:schemeClr val="accent5"/>
-                </a:solidFill>
-              </a:rPr>
-              <a:t>~$10K</a:t>
-            </a:r>
-            <a:endParaRPr lang="en-US" sz="3400" dirty="0"/>
-          </a:p>
-        </p:txBody>
-      </p:sp>
-      <p:sp>
-        <p:nvSpPr>
-          <p:cNvPr id="14" name="ease-3-label"/>
-          <p:cNvSpPr txBox="1"/>
-          <p:nvPr/>
-        </p:nvSpPr>
-        <p:spPr>
-          <a:xfrm>
-            <a:off x="9276359" y="2148840"/>
-            <a:ext cx="2165528" cy="685800"/>
-          </a:xfrm>
-          <a:prstGeom prst="rect">
-            <a:avLst/>
-          </a:prstGeom>
-          <a:noFill/>
-          <a:ln/>
-        </p:spPr>
-        <p:txBody>
-          <a:bodyPr wrap="square" lIns="0" tIns="0" rIns="0" bIns="0" rtlCol="0" anchor="t"/>
-          <a:lstStyle/>
-          <a:p>
-            <a:pPr indent="0" marL="0">
-              <a:buNone/>
-            </a:pPr>
-            <a:r>
-              <a:rPr lang="en-US" sz="1300" dirty="0">
-                <a:solidFill>
                   <a:schemeClr val="accent5"/>
                 </a:solidFill>
               </a:rPr>
@@ -17448,7 +17354,7 @@
       </p:sp>
       <p:sp>
         <p:nvSpPr>
-          <p:cNvPr id="15" name="ease-old"/>
+          <p:cNvPr id="12" name="ease-old"/>
           <p:cNvSpPr/>
           <p:nvPr/>
         </p:nvSpPr>
@@ -17470,7 +17376,7 @@
       </p:sp>
       <p:sp>
         <p:nvSpPr>
-          <p:cNvPr id="16" name="ease-old-text"/>
+          <p:cNvPr id="13" name="ease-old-text"/>
           <p:cNvSpPr txBox="1"/>
           <p:nvPr/>
         </p:nvSpPr>
@@ -17580,7 +17486,7 @@
       </p:sp>
       <p:sp>
         <p:nvSpPr>
-          <p:cNvPr id="17" name="ease-new"/>
+          <p:cNvPr id="14" name="ease-new"/>
           <p:cNvSpPr/>
           <p:nvPr/>
         </p:nvSpPr>
@@ -17602,7 +17508,7 @@
       </p:sp>
       <p:sp>
         <p:nvSpPr>
-          <p:cNvPr id="18" name="ease-new-text"/>
+          <p:cNvPr id="15" name="ease-new-text"/>
           <p:cNvSpPr txBox="1"/>
           <p:nvPr/>
         </p:nvSpPr>
@@ -17712,7 +17618,7 @@
       </p:sp>
       <p:sp>
         <p:nvSpPr>
-          <p:cNvPr id="19" name="ease-foot"/>
+          <p:cNvPr id="16" name="ease-foot"/>
           <p:cNvSpPr txBox="1"/>
           <p:nvPr/>
         </p:nvSpPr>
@@ -17763,7 +17669,7 @@
               <p:cTn id="2" dur="indefinite" nodeType="mainSeq">
                 <p:childTnLst>
                   <p:par>
-                    <p:cTn id="61" fill="hold">
+                    <p:cTn id="51" fill="hold">
                       <p:stCondLst>
                         <p:cond delay="indefinite"/>
                         <p:cond evt="onBegin" delay="0">
@@ -18114,7 +18020,7 @@
                           </p:cTn>
                         </p:par>
                         <p:par>
-                          <p:cTn id="42" fill="hold">
+                          <p:cTn id="39" fill="hold">
                             <p:stCondLst>
                               <p:cond delay="1200"/>
                             </p:stCondLst>
@@ -18189,58 +18095,58 @@
                                   </p:childTnLst>
                                 </p:cTn>
                               </p:par>
-                              <p:par>
-                                <p:cTn id="39" presetID="10" presetClass="entr" presetSubtype="0" fill="hold" grpId="0" nodeType="withEffect">
-                                  <p:stCondLst>
-                                    <p:cond delay="0"/>
-                                  </p:stCondLst>
-                                  <p:childTnLst>
-                                    <p:set>
-                                      <p:cBhvr>
-                                        <p:cTn id="40" dur="1" fill="hold">
-                                          <p:stCondLst>
-                                            <p:cond delay="0"/>
-                                          </p:stCondLst>
-                                        </p:cTn>
-                                        <p:tgtEl>
-                                          <p:spTgt spid="14"/>
-                                        </p:tgtEl>
-                                        <p:attrNameLst>
-                                          <p:attrName>style.visibility</p:attrName>
-                                        </p:attrNameLst>
-                                      </p:cBhvr>
-                                      <p:to>
-                                        <p:strVal val="visible"/>
-                                      </p:to>
-                                    </p:set>
-                                    <p:animEffect transition="in" filter="fade">
-                                      <p:cBhvr>
-                                        <p:cTn id="41" dur="450"/>
-                                        <p:tgtEl>
-                                          <p:spTgt spid="14"/>
-                                        </p:tgtEl>
-                                      </p:cBhvr>
-                                    </p:animEffect>
-                                  </p:childTnLst>
-                                </p:cTn>
-                              </p:par>
                             </p:childTnLst>
                           </p:cTn>
                         </p:par>
                         <p:par>
-                          <p:cTn id="49" fill="hold">
+                          <p:cTn id="46" fill="hold">
                             <p:stCondLst>
                               <p:cond delay="1600"/>
                             </p:stCondLst>
                             <p:childTnLst>
                               <p:par>
-                                <p:cTn id="43" presetID="10" presetClass="entr" presetSubtype="0" fill="hold" grpId="0" nodeType="afterEffect">
+                                <p:cTn id="40" presetID="22" presetClass="entr" presetSubtype="8" fill="hold" grpId="0" nodeType="afterEffect">
                                   <p:stCondLst>
                                     <p:cond delay="0"/>
                                   </p:stCondLst>
                                   <p:childTnLst>
                                     <p:set>
                                       <p:cBhvr>
+                                        <p:cTn id="41" dur="1" fill="hold">
+                                          <p:stCondLst>
+                                            <p:cond delay="0"/>
+                                          </p:stCondLst>
+                                        </p:cTn>
+                                        <p:tgtEl>
+                                          <p:spTgt spid="14"/>
+                                        </p:tgtEl>
+                                        <p:attrNameLst>
+                                          <p:attrName>style.visibility</p:attrName>
+                                        </p:attrNameLst>
+                                      </p:cBhvr>
+                                      <p:to>
+                                        <p:strVal val="visible"/>
+                                      </p:to>
+                                    </p:set>
+                                    <p:animEffect transition="in" filter="wipe(left)">
+                                      <p:cBhvr>
+                                        <p:cTn id="42" dur="450"/>
+                                        <p:tgtEl>
+                                          <p:spTgt spid="14"/>
+                                        </p:tgtEl>
+                                      </p:cBhvr>
+                                    </p:animEffect>
+                                  </p:childTnLst>
+                                </p:cTn>
+                              </p:par>
+                              <p:par>
+                                <p:cTn id="43" presetID="22" presetClass="entr" presetSubtype="8" fill="hold" grpId="0" nodeType="withEffect">
+                                  <p:stCondLst>
+                                    <p:cond delay="0"/>
+                                  </p:stCondLst>
+                                  <p:childTnLst>
+                                    <p:set>
+                                      <p:cBhvr>
                                         <p:cTn id="44" dur="1" fill="hold">
                                           <p:stCondLst>
                                             <p:cond delay="0"/>
@@ -18257,46 +18163,11 @@
                                         <p:strVal val="visible"/>
                                       </p:to>
                                     </p:set>
-                                    <p:animEffect transition="in" filter="fade">
+                                    <p:animEffect transition="in" filter="wipe(left)">
                                       <p:cBhvr>
                                         <p:cTn id="45" dur="450"/>
                                         <p:tgtEl>
                                           <p:spTgt spid="15"/>
-                                        </p:tgtEl>
-                                      </p:cBhvr>
-                                    </p:animEffect>
-                                  </p:childTnLst>
-                                </p:cTn>
-                              </p:par>
-                              <p:par>
-                                <p:cTn id="46" presetID="10" presetClass="entr" presetSubtype="0" fill="hold" grpId="0" nodeType="withEffect">
-                                  <p:stCondLst>
-                                    <p:cond delay="0"/>
-                                  </p:stCondLst>
-                                  <p:childTnLst>
-                                    <p:set>
-                                      <p:cBhvr>
-                                        <p:cTn id="47" dur="1" fill="hold">
-                                          <p:stCondLst>
-                                            <p:cond delay="0"/>
-                                          </p:stCondLst>
-                                        </p:cTn>
-                                        <p:tgtEl>
-                                          <p:spTgt spid="16"/>
-                                        </p:tgtEl>
-                                        <p:attrNameLst>
-                                          <p:attrName>style.visibility</p:attrName>
-                                        </p:attrNameLst>
-                                      </p:cBhvr>
-                                      <p:to>
-                                        <p:strVal val="visible"/>
-                                      </p:to>
-                                    </p:set>
-                                    <p:animEffect transition="in" filter="fade">
-                                      <p:cBhvr>
-                                        <p:cTn id="48" dur="450"/>
-                                        <p:tgtEl>
-                                          <p:spTgt spid="16"/>
                                         </p:tgtEl>
                                       </p:cBhvr>
                                     </p:animEffect>
@@ -18307,105 +18178,26 @@
                           </p:cTn>
                         </p:par>
                         <p:par>
-                          <p:cTn id="56" fill="hold">
+                          <p:cTn id="50" fill="hold">
                             <p:stCondLst>
                               <p:cond delay="2000"/>
                             </p:stCondLst>
                             <p:childTnLst>
                               <p:par>
-                                <p:cTn id="50" presetID="22" presetClass="entr" presetSubtype="8" fill="hold" grpId="0" nodeType="afterEffect">
+                                <p:cTn id="47" presetID="10" presetClass="entr" presetSubtype="0" fill="hold" grpId="0" nodeType="afterEffect">
                                   <p:stCondLst>
                                     <p:cond delay="0"/>
                                   </p:stCondLst>
                                   <p:childTnLst>
                                     <p:set>
                                       <p:cBhvr>
-                                        <p:cTn id="51" dur="1" fill="hold">
-                                          <p:stCondLst>
-                                            <p:cond delay="0"/>
-                                          </p:stCondLst>
-                                        </p:cTn>
-                                        <p:tgtEl>
-                                          <p:spTgt spid="17"/>
-                                        </p:tgtEl>
-                                        <p:attrNameLst>
-                                          <p:attrName>style.visibility</p:attrName>
-                                        </p:attrNameLst>
-                                      </p:cBhvr>
-                                      <p:to>
-                                        <p:strVal val="visible"/>
-                                      </p:to>
-                                    </p:set>
-                                    <p:animEffect transition="in" filter="wipe(left)">
-                                      <p:cBhvr>
-                                        <p:cTn id="52" dur="450"/>
-                                        <p:tgtEl>
-                                          <p:spTgt spid="17"/>
-                                        </p:tgtEl>
-                                      </p:cBhvr>
-                                    </p:animEffect>
-                                  </p:childTnLst>
-                                </p:cTn>
-                              </p:par>
-                              <p:par>
-                                <p:cTn id="53" presetID="22" presetClass="entr" presetSubtype="8" fill="hold" grpId="0" nodeType="withEffect">
-                                  <p:stCondLst>
-                                    <p:cond delay="0"/>
-                                  </p:stCondLst>
-                                  <p:childTnLst>
-                                    <p:set>
-                                      <p:cBhvr>
-                                        <p:cTn id="54" dur="1" fill="hold">
-                                          <p:stCondLst>
-                                            <p:cond delay="0"/>
-                                          </p:stCondLst>
-                                        </p:cTn>
-                                        <p:tgtEl>
-                                          <p:spTgt spid="18"/>
-                                        </p:tgtEl>
-                                        <p:attrNameLst>
-                                          <p:attrName>style.visibility</p:attrName>
-                                        </p:attrNameLst>
-                                      </p:cBhvr>
-                                      <p:to>
-                                        <p:strVal val="visible"/>
-                                      </p:to>
-                                    </p:set>
-                                    <p:animEffect transition="in" filter="wipe(left)">
-                                      <p:cBhvr>
-                                        <p:cTn id="55" dur="450"/>
-                                        <p:tgtEl>
-                                          <p:spTgt spid="18"/>
-                                        </p:tgtEl>
-                                      </p:cBhvr>
-                                    </p:animEffect>
-                                  </p:childTnLst>
-                                </p:cTn>
-                              </p:par>
-                            </p:childTnLst>
-                          </p:cTn>
-                        </p:par>
-                        <p:par>
-                          <p:cTn id="60" fill="hold">
-                            <p:stCondLst>
-                              <p:cond delay="2400"/>
-                            </p:stCondLst>
-                            <p:childTnLst>
-                              <p:par>
-                                <p:cTn id="57" presetID="10" presetClass="entr" presetSubtype="0" fill="hold" grpId="0" nodeType="afterEffect">
-                                  <p:stCondLst>
-                                    <p:cond delay="0"/>
-                                  </p:stCondLst>
-                                  <p:childTnLst>
-                                    <p:set>
-                                      <p:cBhvr>
-                                        <p:cTn id="58" dur="1" fill="hold">
-                                          <p:stCondLst>
-                                            <p:cond delay="0"/>
-                                          </p:stCondLst>
-                                        </p:cTn>
-                                        <p:tgtEl>
-                                          <p:spTgt spid="19"/>
+                                        <p:cTn id="48" dur="1" fill="hold">
+                                          <p:stCondLst>
+                                            <p:cond delay="0"/>
+                                          </p:stCondLst>
+                                        </p:cTn>
+                                        <p:tgtEl>
+                                          <p:spTgt spid="16"/>
                                         </p:tgtEl>
                                         <p:attrNameLst>
                                           <p:attrName>style.visibility</p:attrName>
@@ -18417,9 +18209,9 @@
                                     </p:set>
                                     <p:animEffect transition="in" filter="fade">
                                       <p:cBhvr>
-                                        <p:cTn id="59" dur="450"/>
-                                        <p:tgtEl>
-                                          <p:spTgt spid="19"/>
+                                        <p:cTn id="49" dur="450"/>
+                                        <p:tgtEl>
+                                          <p:spTgt spid="16"/>
                                         </p:tgtEl>
                                       </p:cBhvr>
                                     </p:animEffect>
@@ -18468,9 +18260,6 @@
       <p:bldP spid="14" grpId="0" animBg="1"/>
       <p:bldP spid="15" grpId="0" animBg="1"/>
       <p:bldP spid="16" grpId="0" animBg="1"/>
-      <p:bldP spid="17" grpId="0" animBg="1"/>
-      <p:bldP spid="18" grpId="0" animBg="1"/>
-      <p:bldP spid="19" grpId="0" animBg="1"/>
     </p:bldLst>
   </p:timing>
 </p:sld>

</xml_diff>